<commit_message>
More model training. Began to implement ES and RLROP.
</commit_message>
<xml_diff>
--- a/dissemination/Brain Tumor Classification Model Comparisons.pptx
+++ b/dissemination/Brain Tumor Classification Model Comparisons.pptx
@@ -4,6 +4,9 @@
   <p:sldMasterIdLst>
     <p:sldMasterId id="2147483648" r:id="rId1"/>
   </p:sldMasterIdLst>
+  <p:notesMasterIdLst>
+    <p:notesMasterId r:id="rId19"/>
+  </p:notesMasterIdLst>
   <p:sldIdLst>
     <p:sldId id="257" r:id="rId2"/>
     <p:sldId id="258" r:id="rId3"/>
@@ -16,6 +19,12 @@
     <p:sldId id="265" r:id="rId10"/>
     <p:sldId id="266" r:id="rId11"/>
     <p:sldId id="267" r:id="rId12"/>
+    <p:sldId id="269" r:id="rId13"/>
+    <p:sldId id="270" r:id="rId14"/>
+    <p:sldId id="271" r:id="rId15"/>
+    <p:sldId id="272" r:id="rId16"/>
+    <p:sldId id="273" r:id="rId17"/>
+    <p:sldId id="268" r:id="rId18"/>
   </p:sldIdLst>
   <p:sldSz cx="12192000" cy="6858000"/>
   <p:notesSz cx="6858000" cy="9144000"/>
@@ -114,7 +123,449 @@
       </a:defRPr>
     </a:lvl9pPr>
   </p:defaultTextStyle>
+  <p:extLst>
+    <p:ext uri="{EFAFB233-063F-42B5-8137-9DF3F51BA10A}">
+      <p15:sldGuideLst xmlns:p15="http://schemas.microsoft.com/office/powerpoint/2012/main"/>
+    </p:ext>
+  </p:extLst>
 </p:presentation>
+</file>
+
+<file path=ppt/notesMasters/notesMaster1.xml><?xml version="1.0" encoding="utf-8"?>
+<p:notesMaster xmlns:a="http://schemas.openxmlformats.org/drawingml/2006/main" xmlns:r="http://schemas.openxmlformats.org/officeDocument/2006/relationships" xmlns:p="http://schemas.openxmlformats.org/presentationml/2006/main">
+  <p:cSld>
+    <p:bg>
+      <p:bgRef idx="1001">
+        <a:schemeClr val="bg1"/>
+      </p:bgRef>
+    </p:bg>
+    <p:spTree>
+      <p:nvGrpSpPr>
+        <p:cNvPr id="1" name=""/>
+        <p:cNvGrpSpPr/>
+        <p:nvPr/>
+      </p:nvGrpSpPr>
+      <p:grpSpPr>
+        <a:xfrm>
+          <a:off x="0" y="0"/>
+          <a:ext cx="0" cy="0"/>
+          <a:chOff x="0" y="0"/>
+          <a:chExt cx="0" cy="0"/>
+        </a:xfrm>
+      </p:grpSpPr>
+      <p:sp>
+        <p:nvSpPr>
+          <p:cNvPr id="2" name="Header Placeholder 1"/>
+          <p:cNvSpPr>
+            <a:spLocks noGrp="1"/>
+          </p:cNvSpPr>
+          <p:nvPr>
+            <p:ph type="hdr" sz="quarter"/>
+          </p:nvPr>
+        </p:nvSpPr>
+        <p:spPr>
+          <a:xfrm>
+            <a:off x="0" y="0"/>
+            <a:ext cx="2971800" cy="458788"/>
+          </a:xfrm>
+          <a:prstGeom prst="rect">
+            <a:avLst/>
+          </a:prstGeom>
+        </p:spPr>
+        <p:txBody>
+          <a:bodyPr vert="horz" lIns="91440" tIns="45720" rIns="91440" bIns="45720" rtlCol="0"/>
+          <a:lstStyle>
+            <a:lvl1pPr algn="l">
+              <a:defRPr sz="1200"/>
+            </a:lvl1pPr>
+          </a:lstStyle>
+          <a:p>
+            <a:endParaRPr lang="en-GB"/>
+          </a:p>
+        </p:txBody>
+      </p:sp>
+      <p:sp>
+        <p:nvSpPr>
+          <p:cNvPr id="3" name="Date Placeholder 2"/>
+          <p:cNvSpPr>
+            <a:spLocks noGrp="1"/>
+          </p:cNvSpPr>
+          <p:nvPr>
+            <p:ph type="dt" idx="1"/>
+          </p:nvPr>
+        </p:nvSpPr>
+        <p:spPr>
+          <a:xfrm>
+            <a:off x="3884613" y="0"/>
+            <a:ext cx="2971800" cy="458788"/>
+          </a:xfrm>
+          <a:prstGeom prst="rect">
+            <a:avLst/>
+          </a:prstGeom>
+        </p:spPr>
+        <p:txBody>
+          <a:bodyPr vert="horz" lIns="91440" tIns="45720" rIns="91440" bIns="45720" rtlCol="0"/>
+          <a:lstStyle>
+            <a:lvl1pPr algn="r">
+              <a:defRPr sz="1200"/>
+            </a:lvl1pPr>
+          </a:lstStyle>
+          <a:p>
+            <a:fld id="{5BEAC4C3-7F01-4D2F-B765-F2404496EEE9}" type="datetimeFigureOut">
+              <a:rPr lang="en-GB" smtClean="0"/>
+              <a:t>20/03/2026</a:t>
+            </a:fld>
+            <a:endParaRPr lang="en-GB"/>
+          </a:p>
+        </p:txBody>
+      </p:sp>
+      <p:sp>
+        <p:nvSpPr>
+          <p:cNvPr id="4" name="Slide Image Placeholder 3"/>
+          <p:cNvSpPr>
+            <a:spLocks noGrp="1" noRot="1" noChangeAspect="1"/>
+          </p:cNvSpPr>
+          <p:nvPr>
+            <p:ph type="sldImg" idx="2"/>
+          </p:nvPr>
+        </p:nvSpPr>
+        <p:spPr>
+          <a:xfrm>
+            <a:off x="685800" y="1143000"/>
+            <a:ext cx="5486400" cy="3086100"/>
+          </a:xfrm>
+          <a:prstGeom prst="rect">
+            <a:avLst/>
+          </a:prstGeom>
+          <a:noFill/>
+          <a:ln w="12700">
+            <a:solidFill>
+              <a:prstClr val="black"/>
+            </a:solidFill>
+          </a:ln>
+        </p:spPr>
+        <p:txBody>
+          <a:bodyPr vert="horz" lIns="91440" tIns="45720" rIns="91440" bIns="45720" rtlCol="0" anchor="ctr"/>
+          <a:lstStyle/>
+          <a:p>
+            <a:endParaRPr lang="en-GB"/>
+          </a:p>
+        </p:txBody>
+      </p:sp>
+      <p:sp>
+        <p:nvSpPr>
+          <p:cNvPr id="5" name="Notes Placeholder 4"/>
+          <p:cNvSpPr>
+            <a:spLocks noGrp="1"/>
+          </p:cNvSpPr>
+          <p:nvPr>
+            <p:ph type="body" sz="quarter" idx="3"/>
+          </p:nvPr>
+        </p:nvSpPr>
+        <p:spPr>
+          <a:xfrm>
+            <a:off x="685800" y="4400550"/>
+            <a:ext cx="5486400" cy="3600450"/>
+          </a:xfrm>
+          <a:prstGeom prst="rect">
+            <a:avLst/>
+          </a:prstGeom>
+        </p:spPr>
+        <p:txBody>
+          <a:bodyPr vert="horz" lIns="91440" tIns="45720" rIns="91440" bIns="45720" rtlCol="0"/>
+          <a:lstStyle/>
+          <a:p>
+            <a:pPr lvl="0"/>
+            <a:r>
+              <a:rPr lang="en-US"/>
+              <a:t>Click to edit Master text styles</a:t>
+            </a:r>
+          </a:p>
+          <a:p>
+            <a:pPr lvl="1"/>
+            <a:r>
+              <a:rPr lang="en-US"/>
+              <a:t>Second level</a:t>
+            </a:r>
+          </a:p>
+          <a:p>
+            <a:pPr lvl="2"/>
+            <a:r>
+              <a:rPr lang="en-US"/>
+              <a:t>Third level</a:t>
+            </a:r>
+          </a:p>
+          <a:p>
+            <a:pPr lvl="3"/>
+            <a:r>
+              <a:rPr lang="en-US"/>
+              <a:t>Fourth level</a:t>
+            </a:r>
+          </a:p>
+          <a:p>
+            <a:pPr lvl="4"/>
+            <a:r>
+              <a:rPr lang="en-US"/>
+              <a:t>Fifth level</a:t>
+            </a:r>
+            <a:endParaRPr lang="en-GB"/>
+          </a:p>
+        </p:txBody>
+      </p:sp>
+      <p:sp>
+        <p:nvSpPr>
+          <p:cNvPr id="6" name="Footer Placeholder 5"/>
+          <p:cNvSpPr>
+            <a:spLocks noGrp="1"/>
+          </p:cNvSpPr>
+          <p:nvPr>
+            <p:ph type="ftr" sz="quarter" idx="4"/>
+          </p:nvPr>
+        </p:nvSpPr>
+        <p:spPr>
+          <a:xfrm>
+            <a:off x="0" y="8685213"/>
+            <a:ext cx="2971800" cy="458787"/>
+          </a:xfrm>
+          <a:prstGeom prst="rect">
+            <a:avLst/>
+          </a:prstGeom>
+        </p:spPr>
+        <p:txBody>
+          <a:bodyPr vert="horz" lIns="91440" tIns="45720" rIns="91440" bIns="45720" rtlCol="0" anchor="b"/>
+          <a:lstStyle>
+            <a:lvl1pPr algn="l">
+              <a:defRPr sz="1200"/>
+            </a:lvl1pPr>
+          </a:lstStyle>
+          <a:p>
+            <a:endParaRPr lang="en-GB"/>
+          </a:p>
+        </p:txBody>
+      </p:sp>
+      <p:sp>
+        <p:nvSpPr>
+          <p:cNvPr id="7" name="Slide Number Placeholder 6"/>
+          <p:cNvSpPr>
+            <a:spLocks noGrp="1"/>
+          </p:cNvSpPr>
+          <p:nvPr>
+            <p:ph type="sldNum" sz="quarter" idx="5"/>
+          </p:nvPr>
+        </p:nvSpPr>
+        <p:spPr>
+          <a:xfrm>
+            <a:off x="3884613" y="8685213"/>
+            <a:ext cx="2971800" cy="458787"/>
+          </a:xfrm>
+          <a:prstGeom prst="rect">
+            <a:avLst/>
+          </a:prstGeom>
+        </p:spPr>
+        <p:txBody>
+          <a:bodyPr vert="horz" lIns="91440" tIns="45720" rIns="91440" bIns="45720" rtlCol="0" anchor="b"/>
+          <a:lstStyle>
+            <a:lvl1pPr algn="r">
+              <a:defRPr sz="1200"/>
+            </a:lvl1pPr>
+          </a:lstStyle>
+          <a:p>
+            <a:fld id="{6B1F1A07-D35D-4F36-A42D-BCCD994BE3A5}" type="slidenum">
+              <a:rPr lang="en-GB" smtClean="0"/>
+              <a:t>‹#›</a:t>
+            </a:fld>
+            <a:endParaRPr lang="en-GB"/>
+          </a:p>
+        </p:txBody>
+      </p:sp>
+    </p:spTree>
+    <p:extLst>
+      <p:ext uri="{BB962C8B-B14F-4D97-AF65-F5344CB8AC3E}">
+        <p14:creationId xmlns:p14="http://schemas.microsoft.com/office/powerpoint/2010/main" val="782347209"/>
+      </p:ext>
+    </p:extLst>
+  </p:cSld>
+  <p:clrMap bg1="lt1" tx1="dk1" bg2="lt2" tx2="dk2" accent1="accent1" accent2="accent2" accent3="accent3" accent4="accent4" accent5="accent5" accent6="accent6" hlink="hlink" folHlink="folHlink"/>
+  <p:notesStyle>
+    <a:lvl1pPr marL="0" algn="l" defTabSz="914400" rtl="0" eaLnBrk="1" latinLnBrk="0" hangingPunct="1">
+      <a:defRPr sz="1200" kern="1200">
+        <a:solidFill>
+          <a:schemeClr val="tx1"/>
+        </a:solidFill>
+        <a:latin typeface="+mn-lt"/>
+        <a:ea typeface="+mn-ea"/>
+        <a:cs typeface="+mn-cs"/>
+      </a:defRPr>
+    </a:lvl1pPr>
+    <a:lvl2pPr marL="457200" algn="l" defTabSz="914400" rtl="0" eaLnBrk="1" latinLnBrk="0" hangingPunct="1">
+      <a:defRPr sz="1200" kern="1200">
+        <a:solidFill>
+          <a:schemeClr val="tx1"/>
+        </a:solidFill>
+        <a:latin typeface="+mn-lt"/>
+        <a:ea typeface="+mn-ea"/>
+        <a:cs typeface="+mn-cs"/>
+      </a:defRPr>
+    </a:lvl2pPr>
+    <a:lvl3pPr marL="914400" algn="l" defTabSz="914400" rtl="0" eaLnBrk="1" latinLnBrk="0" hangingPunct="1">
+      <a:defRPr sz="1200" kern="1200">
+        <a:solidFill>
+          <a:schemeClr val="tx1"/>
+        </a:solidFill>
+        <a:latin typeface="+mn-lt"/>
+        <a:ea typeface="+mn-ea"/>
+        <a:cs typeface="+mn-cs"/>
+      </a:defRPr>
+    </a:lvl3pPr>
+    <a:lvl4pPr marL="1371600" algn="l" defTabSz="914400" rtl="0" eaLnBrk="1" latinLnBrk="0" hangingPunct="1">
+      <a:defRPr sz="1200" kern="1200">
+        <a:solidFill>
+          <a:schemeClr val="tx1"/>
+        </a:solidFill>
+        <a:latin typeface="+mn-lt"/>
+        <a:ea typeface="+mn-ea"/>
+        <a:cs typeface="+mn-cs"/>
+      </a:defRPr>
+    </a:lvl4pPr>
+    <a:lvl5pPr marL="1828800" algn="l" defTabSz="914400" rtl="0" eaLnBrk="1" latinLnBrk="0" hangingPunct="1">
+      <a:defRPr sz="1200" kern="1200">
+        <a:solidFill>
+          <a:schemeClr val="tx1"/>
+        </a:solidFill>
+        <a:latin typeface="+mn-lt"/>
+        <a:ea typeface="+mn-ea"/>
+        <a:cs typeface="+mn-cs"/>
+      </a:defRPr>
+    </a:lvl5pPr>
+    <a:lvl6pPr marL="2286000" algn="l" defTabSz="914400" rtl="0" eaLnBrk="1" latinLnBrk="0" hangingPunct="1">
+      <a:defRPr sz="1200" kern="1200">
+        <a:solidFill>
+          <a:schemeClr val="tx1"/>
+        </a:solidFill>
+        <a:latin typeface="+mn-lt"/>
+        <a:ea typeface="+mn-ea"/>
+        <a:cs typeface="+mn-cs"/>
+      </a:defRPr>
+    </a:lvl6pPr>
+    <a:lvl7pPr marL="2743200" algn="l" defTabSz="914400" rtl="0" eaLnBrk="1" latinLnBrk="0" hangingPunct="1">
+      <a:defRPr sz="1200" kern="1200">
+        <a:solidFill>
+          <a:schemeClr val="tx1"/>
+        </a:solidFill>
+        <a:latin typeface="+mn-lt"/>
+        <a:ea typeface="+mn-ea"/>
+        <a:cs typeface="+mn-cs"/>
+      </a:defRPr>
+    </a:lvl7pPr>
+    <a:lvl8pPr marL="3200400" algn="l" defTabSz="914400" rtl="0" eaLnBrk="1" latinLnBrk="0" hangingPunct="1">
+      <a:defRPr sz="1200" kern="1200">
+        <a:solidFill>
+          <a:schemeClr val="tx1"/>
+        </a:solidFill>
+        <a:latin typeface="+mn-lt"/>
+        <a:ea typeface="+mn-ea"/>
+        <a:cs typeface="+mn-cs"/>
+      </a:defRPr>
+    </a:lvl8pPr>
+    <a:lvl9pPr marL="3657600" algn="l" defTabSz="914400" rtl="0" eaLnBrk="1" latinLnBrk="0" hangingPunct="1">
+      <a:defRPr sz="1200" kern="1200">
+        <a:solidFill>
+          <a:schemeClr val="tx1"/>
+        </a:solidFill>
+        <a:latin typeface="+mn-lt"/>
+        <a:ea typeface="+mn-ea"/>
+        <a:cs typeface="+mn-cs"/>
+      </a:defRPr>
+    </a:lvl9pPr>
+  </p:notesStyle>
+</p:notesMaster>
+</file>
+
+<file path=ppt/notesSlides/notesSlide1.xml><?xml version="1.0" encoding="utf-8"?>
+<p:notes xmlns:a="http://schemas.openxmlformats.org/drawingml/2006/main" xmlns:r="http://schemas.openxmlformats.org/officeDocument/2006/relationships" xmlns:p="http://schemas.openxmlformats.org/presentationml/2006/main">
+  <p:cSld>
+    <p:spTree>
+      <p:nvGrpSpPr>
+        <p:cNvPr id="1" name=""/>
+        <p:cNvGrpSpPr/>
+        <p:nvPr/>
+      </p:nvGrpSpPr>
+      <p:grpSpPr>
+        <a:xfrm>
+          <a:off x="0" y="0"/>
+          <a:ext cx="0" cy="0"/>
+          <a:chOff x="0" y="0"/>
+          <a:chExt cx="0" cy="0"/>
+        </a:xfrm>
+      </p:grpSpPr>
+      <p:sp>
+        <p:nvSpPr>
+          <p:cNvPr id="2" name="Slide Image Placeholder 1"/>
+          <p:cNvSpPr>
+            <a:spLocks noGrp="1" noRot="1" noChangeAspect="1"/>
+          </p:cNvSpPr>
+          <p:nvPr>
+            <p:ph type="sldImg"/>
+          </p:nvPr>
+        </p:nvSpPr>
+        <p:spPr/>
+      </p:sp>
+      <p:sp>
+        <p:nvSpPr>
+          <p:cNvPr id="3" name="Notes Placeholder 2"/>
+          <p:cNvSpPr>
+            <a:spLocks noGrp="1"/>
+          </p:cNvSpPr>
+          <p:nvPr>
+            <p:ph type="body" idx="1"/>
+          </p:nvPr>
+        </p:nvSpPr>
+        <p:spPr/>
+        <p:txBody>
+          <a:bodyPr/>
+          <a:lstStyle/>
+          <a:p>
+            <a:r>
+              <a:rPr lang="en-GB" dirty="0"/>
+              <a:t>Lower learning rate = more epochs needed for full fitting (current problem here is underfitting). Could try a 300 epoch run? May take a while. Best bet is to start implementing callbacks.</a:t>
+            </a:r>
+          </a:p>
+        </p:txBody>
+      </p:sp>
+      <p:sp>
+        <p:nvSpPr>
+          <p:cNvPr id="4" name="Slide Number Placeholder 3"/>
+          <p:cNvSpPr>
+            <a:spLocks noGrp="1"/>
+          </p:cNvSpPr>
+          <p:nvPr>
+            <p:ph type="sldNum" sz="quarter" idx="5"/>
+          </p:nvPr>
+        </p:nvSpPr>
+        <p:spPr/>
+        <p:txBody>
+          <a:bodyPr/>
+          <a:lstStyle/>
+          <a:p>
+            <a:fld id="{6B1F1A07-D35D-4F36-A42D-BCCD994BE3A5}" type="slidenum">
+              <a:rPr lang="en-GB" smtClean="0"/>
+              <a:t>14</a:t>
+            </a:fld>
+            <a:endParaRPr lang="en-GB"/>
+          </a:p>
+        </p:txBody>
+      </p:sp>
+    </p:spTree>
+    <p:extLst>
+      <p:ext uri="{BB962C8B-B14F-4D97-AF65-F5344CB8AC3E}">
+        <p14:creationId xmlns:p14="http://schemas.microsoft.com/office/powerpoint/2010/main" val="2566482550"/>
+      </p:ext>
+    </p:extLst>
+  </p:cSld>
+  <p:clrMapOvr>
+    <a:masterClrMapping/>
+  </p:clrMapOvr>
+</p:notes>
 </file>
 
 <file path=ppt/slideLayouts/slideLayout1.xml><?xml version="1.0" encoding="utf-8"?>
@@ -266,7 +717,7 @@
           <a:p>
             <a:fld id="{1D725620-1185-4627-BCBE-4E695665A1FA}" type="datetimeFigureOut">
               <a:rPr lang="en-GB" smtClean="0"/>
-              <a:t>19/03/2026</a:t>
+              <a:t>20/03/2026</a:t>
             </a:fld>
             <a:endParaRPr lang="en-GB"/>
           </a:p>
@@ -466,7 +917,7 @@
           <a:p>
             <a:fld id="{1D725620-1185-4627-BCBE-4E695665A1FA}" type="datetimeFigureOut">
               <a:rPr lang="en-GB" smtClean="0"/>
-              <a:t>19/03/2026</a:t>
+              <a:t>20/03/2026</a:t>
             </a:fld>
             <a:endParaRPr lang="en-GB"/>
           </a:p>
@@ -676,7 +1127,7 @@
           <a:p>
             <a:fld id="{1D725620-1185-4627-BCBE-4E695665A1FA}" type="datetimeFigureOut">
               <a:rPr lang="en-GB" smtClean="0"/>
-              <a:t>19/03/2026</a:t>
+              <a:t>20/03/2026</a:t>
             </a:fld>
             <a:endParaRPr lang="en-GB"/>
           </a:p>
@@ -876,7 +1327,7 @@
           <a:p>
             <a:fld id="{1D725620-1185-4627-BCBE-4E695665A1FA}" type="datetimeFigureOut">
               <a:rPr lang="en-GB" smtClean="0"/>
-              <a:t>19/03/2026</a:t>
+              <a:t>20/03/2026</a:t>
             </a:fld>
             <a:endParaRPr lang="en-GB"/>
           </a:p>
@@ -1152,7 +1603,7 @@
           <a:p>
             <a:fld id="{1D725620-1185-4627-BCBE-4E695665A1FA}" type="datetimeFigureOut">
               <a:rPr lang="en-GB" smtClean="0"/>
-              <a:t>19/03/2026</a:t>
+              <a:t>20/03/2026</a:t>
             </a:fld>
             <a:endParaRPr lang="en-GB"/>
           </a:p>
@@ -1420,7 +1871,7 @@
           <a:p>
             <a:fld id="{1D725620-1185-4627-BCBE-4E695665A1FA}" type="datetimeFigureOut">
               <a:rPr lang="en-GB" smtClean="0"/>
-              <a:t>19/03/2026</a:t>
+              <a:t>20/03/2026</a:t>
             </a:fld>
             <a:endParaRPr lang="en-GB"/>
           </a:p>
@@ -1835,7 +2286,7 @@
           <a:p>
             <a:fld id="{1D725620-1185-4627-BCBE-4E695665A1FA}" type="datetimeFigureOut">
               <a:rPr lang="en-GB" smtClean="0"/>
-              <a:t>19/03/2026</a:t>
+              <a:t>20/03/2026</a:t>
             </a:fld>
             <a:endParaRPr lang="en-GB"/>
           </a:p>
@@ -1977,7 +2428,7 @@
           <a:p>
             <a:fld id="{1D725620-1185-4627-BCBE-4E695665A1FA}" type="datetimeFigureOut">
               <a:rPr lang="en-GB" smtClean="0"/>
-              <a:t>19/03/2026</a:t>
+              <a:t>20/03/2026</a:t>
             </a:fld>
             <a:endParaRPr lang="en-GB"/>
           </a:p>
@@ -2090,7 +2541,7 @@
           <a:p>
             <a:fld id="{1D725620-1185-4627-BCBE-4E695665A1FA}" type="datetimeFigureOut">
               <a:rPr lang="en-GB" smtClean="0"/>
-              <a:t>19/03/2026</a:t>
+              <a:t>20/03/2026</a:t>
             </a:fld>
             <a:endParaRPr lang="en-GB"/>
           </a:p>
@@ -2403,7 +2854,7 @@
           <a:p>
             <a:fld id="{1D725620-1185-4627-BCBE-4E695665A1FA}" type="datetimeFigureOut">
               <a:rPr lang="en-GB" smtClean="0"/>
-              <a:t>19/03/2026</a:t>
+              <a:t>20/03/2026</a:t>
             </a:fld>
             <a:endParaRPr lang="en-GB"/>
           </a:p>
@@ -2692,7 +3143,7 @@
           <a:p>
             <a:fld id="{1D725620-1185-4627-BCBE-4E695665A1FA}" type="datetimeFigureOut">
               <a:rPr lang="en-GB" smtClean="0"/>
-              <a:t>19/03/2026</a:t>
+              <a:t>20/03/2026</a:t>
             </a:fld>
             <a:endParaRPr lang="en-GB"/>
           </a:p>
@@ -2935,7 +3386,7 @@
           <a:p>
             <a:fld id="{1D725620-1185-4627-BCBE-4E695665A1FA}" type="datetimeFigureOut">
               <a:rPr lang="en-GB" smtClean="0"/>
-              <a:t>19/03/2026</a:t>
+              <a:t>20/03/2026</a:t>
             </a:fld>
             <a:endParaRPr lang="en-GB"/>
           </a:p>
@@ -3728,8 +4179,8 @@
         </p:nvSpPr>
         <p:spPr>
           <a:xfrm>
-            <a:off x="67733" y="93133"/>
-            <a:ext cx="10837333" cy="707886"/>
+            <a:off x="67734" y="93133"/>
+            <a:ext cx="4759100" cy="707886"/>
           </a:xfrm>
           <a:prstGeom prst="rect">
             <a:avLst/>
@@ -3887,7 +4338,7 @@
         <p:spPr>
           <a:xfrm>
             <a:off x="67733" y="93133"/>
-            <a:ext cx="10837333" cy="707886"/>
+            <a:ext cx="4451801" cy="707886"/>
           </a:xfrm>
           <a:prstGeom prst="rect">
             <a:avLst/>
@@ -3998,6 +4449,733 @@
     <p:extLst>
       <p:ext uri="{BB962C8B-B14F-4D97-AF65-F5344CB8AC3E}">
         <p14:creationId xmlns:p14="http://schemas.microsoft.com/office/powerpoint/2010/main" val="3014042196"/>
+      </p:ext>
+    </p:extLst>
+  </p:cSld>
+  <p:clrMapOvr>
+    <a:masterClrMapping/>
+  </p:clrMapOvr>
+</p:sld>
+</file>
+
+<file path=ppt/slides/slide12.xml><?xml version="1.0" encoding="utf-8"?>
+<p:sld xmlns:a="http://schemas.openxmlformats.org/drawingml/2006/main" xmlns:r="http://schemas.openxmlformats.org/officeDocument/2006/relationships" xmlns:p="http://schemas.openxmlformats.org/presentationml/2006/main">
+  <p:cSld>
+    <p:spTree>
+      <p:nvGrpSpPr>
+        <p:cNvPr id="1" name="">
+          <a:extLst>
+            <a:ext uri="{FF2B5EF4-FFF2-40B4-BE49-F238E27FC236}">
+              <a16:creationId xmlns:a16="http://schemas.microsoft.com/office/drawing/2014/main" id="{67BD29F8-80CB-632B-C416-CA25EB6AAB22}"/>
+            </a:ext>
+          </a:extLst>
+        </p:cNvPr>
+        <p:cNvGrpSpPr/>
+        <p:nvPr/>
+      </p:nvGrpSpPr>
+      <p:grpSpPr>
+        <a:xfrm>
+          <a:off x="0" y="0"/>
+          <a:ext cx="0" cy="0"/>
+          <a:chOff x="0" y="0"/>
+          <a:chExt cx="0" cy="0"/>
+        </a:xfrm>
+      </p:grpSpPr>
+      <p:sp>
+        <p:nvSpPr>
+          <p:cNvPr id="4" name="TextBox 3">
+            <a:extLst>
+              <a:ext uri="{FF2B5EF4-FFF2-40B4-BE49-F238E27FC236}">
+                <a16:creationId xmlns:a16="http://schemas.microsoft.com/office/drawing/2014/main" id="{10C1B140-53A4-C567-3841-D5F41EB83F17}"/>
+              </a:ext>
+            </a:extLst>
+          </p:cNvPr>
+          <p:cNvSpPr txBox="1"/>
+          <p:nvPr/>
+        </p:nvSpPr>
+        <p:spPr>
+          <a:xfrm>
+            <a:off x="552818" y="2905780"/>
+            <a:ext cx="6821375" cy="523220"/>
+          </a:xfrm>
+          <a:prstGeom prst="rect">
+            <a:avLst/>
+          </a:prstGeom>
+          <a:noFill/>
+        </p:spPr>
+        <p:txBody>
+          <a:bodyPr wrap="square" rtlCol="0">
+            <a:spAutoFit/>
+          </a:bodyPr>
+          <a:lstStyle/>
+          <a:p>
+            <a:r>
+              <a:rPr lang="en-GB" sz="2800" b="1" dirty="0">
+                <a:latin typeface="Arial" panose="020B0604020202020204" pitchFamily="34" charset="0"/>
+                <a:cs typeface="Arial" panose="020B0604020202020204" pitchFamily="34" charset="0"/>
+              </a:rPr>
+              <a:t>Decreasing LR to 1x10</a:t>
+            </a:r>
+            <a:r>
+              <a:rPr lang="en-GB" sz="2800" b="1" baseline="30000" dirty="0">
+                <a:latin typeface="Arial" panose="020B0604020202020204" pitchFamily="34" charset="0"/>
+                <a:cs typeface="Arial" panose="020B0604020202020204" pitchFamily="34" charset="0"/>
+              </a:rPr>
+              <a:t>-6</a:t>
+            </a:r>
+          </a:p>
+        </p:txBody>
+      </p:sp>
+    </p:spTree>
+    <p:extLst>
+      <p:ext uri="{BB962C8B-B14F-4D97-AF65-F5344CB8AC3E}">
+        <p14:creationId xmlns:p14="http://schemas.microsoft.com/office/powerpoint/2010/main" val="2469495228"/>
+      </p:ext>
+    </p:extLst>
+  </p:cSld>
+  <p:clrMapOvr>
+    <a:masterClrMapping/>
+  </p:clrMapOvr>
+</p:sld>
+</file>
+
+<file path=ppt/slides/slide13.xml><?xml version="1.0" encoding="utf-8"?>
+<p:sld xmlns:a="http://schemas.openxmlformats.org/drawingml/2006/main" xmlns:r="http://schemas.openxmlformats.org/officeDocument/2006/relationships" xmlns:p="http://schemas.openxmlformats.org/presentationml/2006/main">
+  <p:cSld>
+    <p:spTree>
+      <p:nvGrpSpPr>
+        <p:cNvPr id="1" name="">
+          <a:extLst>
+            <a:ext uri="{FF2B5EF4-FFF2-40B4-BE49-F238E27FC236}">
+              <a16:creationId xmlns:a16="http://schemas.microsoft.com/office/drawing/2014/main" id="{A5365B88-5116-DE11-E9C5-E7B663E24664}"/>
+            </a:ext>
+          </a:extLst>
+        </p:cNvPr>
+        <p:cNvGrpSpPr/>
+        <p:nvPr/>
+      </p:nvGrpSpPr>
+      <p:grpSpPr>
+        <a:xfrm>
+          <a:off x="0" y="0"/>
+          <a:ext cx="0" cy="0"/>
+          <a:chOff x="0" y="0"/>
+          <a:chExt cx="0" cy="0"/>
+        </a:xfrm>
+      </p:grpSpPr>
+      <p:sp>
+        <p:nvSpPr>
+          <p:cNvPr id="4" name="TextBox 3">
+            <a:extLst>
+              <a:ext uri="{FF2B5EF4-FFF2-40B4-BE49-F238E27FC236}">
+                <a16:creationId xmlns:a16="http://schemas.microsoft.com/office/drawing/2014/main" id="{9D3E2554-5942-817E-270B-A7F8FF2E5B6B}"/>
+              </a:ext>
+            </a:extLst>
+          </p:cNvPr>
+          <p:cNvSpPr txBox="1"/>
+          <p:nvPr/>
+        </p:nvSpPr>
+        <p:spPr>
+          <a:xfrm>
+            <a:off x="67734" y="93133"/>
+            <a:ext cx="4444306" cy="707886"/>
+          </a:xfrm>
+          <a:prstGeom prst="rect">
+            <a:avLst/>
+          </a:prstGeom>
+          <a:noFill/>
+        </p:spPr>
+        <p:txBody>
+          <a:bodyPr wrap="square" rtlCol="0">
+            <a:spAutoFit/>
+          </a:bodyPr>
+          <a:lstStyle/>
+          <a:p>
+            <a:r>
+              <a:rPr lang="en-GB" sz="2000" b="1" dirty="0">
+                <a:latin typeface="Arial" panose="020B0604020202020204" pitchFamily="34" charset="0"/>
+                <a:cs typeface="Arial" panose="020B0604020202020204" pitchFamily="34" charset="0"/>
+              </a:rPr>
+              <a:t>Model Comparison: </a:t>
+            </a:r>
+            <a:r>
+              <a:rPr lang="en-GB" sz="2000" b="1" dirty="0">
+                <a:solidFill>
+                  <a:srgbClr val="FF0000"/>
+                </a:solidFill>
+                <a:latin typeface="Arial" panose="020B0604020202020204" pitchFamily="34" charset="0"/>
+                <a:cs typeface="Arial" panose="020B0604020202020204" pitchFamily="34" charset="0"/>
+              </a:rPr>
+              <a:t>Epoch Size</a:t>
+            </a:r>
+          </a:p>
+          <a:p>
+            <a:r>
+              <a:rPr lang="en-GB" sz="2000" b="1" dirty="0">
+                <a:latin typeface="Arial" panose="020B0604020202020204" pitchFamily="34" charset="0"/>
+                <a:cs typeface="Arial" panose="020B0604020202020204" pitchFamily="34" charset="0"/>
+              </a:rPr>
+              <a:t>LR = 1x10</a:t>
+            </a:r>
+            <a:r>
+              <a:rPr lang="en-GB" sz="2000" b="1" baseline="30000" dirty="0">
+                <a:latin typeface="Arial" panose="020B0604020202020204" pitchFamily="34" charset="0"/>
+                <a:cs typeface="Arial" panose="020B0604020202020204" pitchFamily="34" charset="0"/>
+              </a:rPr>
+              <a:t>-6</a:t>
+            </a:r>
+            <a:r>
+              <a:rPr lang="en-GB" sz="2000" b="1" dirty="0">
+                <a:latin typeface="Arial" panose="020B0604020202020204" pitchFamily="34" charset="0"/>
+                <a:cs typeface="Arial" panose="020B0604020202020204" pitchFamily="34" charset="0"/>
+              </a:rPr>
+              <a:t> , ES = 10, 30, 45</a:t>
+            </a:r>
+          </a:p>
+        </p:txBody>
+      </p:sp>
+      <p:pic>
+        <p:nvPicPr>
+          <p:cNvPr id="3" name="Picture 2">
+            <a:extLst>
+              <a:ext uri="{FF2B5EF4-FFF2-40B4-BE49-F238E27FC236}">
+                <a16:creationId xmlns:a16="http://schemas.microsoft.com/office/drawing/2014/main" id="{C5D767F4-5580-DB54-923D-AC6FF4FC858E}"/>
+              </a:ext>
+            </a:extLst>
+          </p:cNvPr>
+          <p:cNvPicPr>
+            <a:picLocks noChangeAspect="1"/>
+          </p:cNvPicPr>
+          <p:nvPr/>
+        </p:nvPicPr>
+        <p:blipFill>
+          <a:blip r:embed="rId2">
+            <a:extLst>
+              <a:ext uri="{28A0092B-C50C-407E-A947-70E740481C1C}">
+                <a14:useLocalDpi xmlns:a14="http://schemas.microsoft.com/office/drawing/2010/main" val="0"/>
+              </a:ext>
+            </a:extLst>
+          </a:blip>
+          <a:srcRect t="4473" b="8409"/>
+          <a:stretch>
+            <a:fillRect/>
+          </a:stretch>
+        </p:blipFill>
+        <p:spPr>
+          <a:xfrm>
+            <a:off x="67734" y="1018095"/>
+            <a:ext cx="11853333" cy="5279010"/>
+          </a:xfrm>
+          <a:prstGeom prst="rect">
+            <a:avLst/>
+          </a:prstGeom>
+        </p:spPr>
+      </p:pic>
+    </p:spTree>
+    <p:extLst>
+      <p:ext uri="{BB962C8B-B14F-4D97-AF65-F5344CB8AC3E}">
+        <p14:creationId xmlns:p14="http://schemas.microsoft.com/office/powerpoint/2010/main" val="1457473928"/>
+      </p:ext>
+    </p:extLst>
+  </p:cSld>
+  <p:clrMapOvr>
+    <a:masterClrMapping/>
+  </p:clrMapOvr>
+</p:sld>
+</file>
+
+<file path=ppt/slides/slide14.xml><?xml version="1.0" encoding="utf-8"?>
+<p:sld xmlns:a="http://schemas.openxmlformats.org/drawingml/2006/main" xmlns:r="http://schemas.openxmlformats.org/officeDocument/2006/relationships" xmlns:p="http://schemas.openxmlformats.org/presentationml/2006/main">
+  <p:cSld>
+    <p:spTree>
+      <p:nvGrpSpPr>
+        <p:cNvPr id="1" name="">
+          <a:extLst>
+            <a:ext uri="{FF2B5EF4-FFF2-40B4-BE49-F238E27FC236}">
+              <a16:creationId xmlns:a16="http://schemas.microsoft.com/office/drawing/2014/main" id="{2299A1E6-A357-FF5C-9B35-F242B031AF87}"/>
+            </a:ext>
+          </a:extLst>
+        </p:cNvPr>
+        <p:cNvGrpSpPr/>
+        <p:nvPr/>
+      </p:nvGrpSpPr>
+      <p:grpSpPr>
+        <a:xfrm>
+          <a:off x="0" y="0"/>
+          <a:ext cx="0" cy="0"/>
+          <a:chOff x="0" y="0"/>
+          <a:chExt cx="0" cy="0"/>
+        </a:xfrm>
+      </p:grpSpPr>
+      <p:sp>
+        <p:nvSpPr>
+          <p:cNvPr id="4" name="TextBox 3">
+            <a:extLst>
+              <a:ext uri="{FF2B5EF4-FFF2-40B4-BE49-F238E27FC236}">
+                <a16:creationId xmlns:a16="http://schemas.microsoft.com/office/drawing/2014/main" id="{6192842A-46C2-4F3B-49B7-2DDBE0DBDAA6}"/>
+              </a:ext>
+            </a:extLst>
+          </p:cNvPr>
+          <p:cNvSpPr txBox="1"/>
+          <p:nvPr/>
+        </p:nvSpPr>
+        <p:spPr>
+          <a:xfrm>
+            <a:off x="67734" y="93133"/>
+            <a:ext cx="4444306" cy="707886"/>
+          </a:xfrm>
+          <a:prstGeom prst="rect">
+            <a:avLst/>
+          </a:prstGeom>
+          <a:noFill/>
+        </p:spPr>
+        <p:txBody>
+          <a:bodyPr wrap="square" rtlCol="0">
+            <a:spAutoFit/>
+          </a:bodyPr>
+          <a:lstStyle/>
+          <a:p>
+            <a:r>
+              <a:rPr lang="en-GB" sz="2000" b="1" dirty="0">
+                <a:latin typeface="Arial" panose="020B0604020202020204" pitchFamily="34" charset="0"/>
+                <a:cs typeface="Arial" panose="020B0604020202020204" pitchFamily="34" charset="0"/>
+              </a:rPr>
+              <a:t>Model Comparison: </a:t>
+            </a:r>
+            <a:r>
+              <a:rPr lang="en-GB" sz="2000" b="1" dirty="0">
+                <a:solidFill>
+                  <a:srgbClr val="FF0000"/>
+                </a:solidFill>
+                <a:latin typeface="Arial" panose="020B0604020202020204" pitchFamily="34" charset="0"/>
+                <a:cs typeface="Arial" panose="020B0604020202020204" pitchFamily="34" charset="0"/>
+              </a:rPr>
+              <a:t>Epoch Size</a:t>
+            </a:r>
+          </a:p>
+          <a:p>
+            <a:r>
+              <a:rPr lang="en-GB" sz="2000" b="1" dirty="0">
+                <a:latin typeface="Arial" panose="020B0604020202020204" pitchFamily="34" charset="0"/>
+                <a:cs typeface="Arial" panose="020B0604020202020204" pitchFamily="34" charset="0"/>
+              </a:rPr>
+              <a:t>LR = 1x10</a:t>
+            </a:r>
+            <a:r>
+              <a:rPr lang="en-GB" sz="2000" b="1" baseline="30000" dirty="0">
+                <a:latin typeface="Arial" panose="020B0604020202020204" pitchFamily="34" charset="0"/>
+                <a:cs typeface="Arial" panose="020B0604020202020204" pitchFamily="34" charset="0"/>
+              </a:rPr>
+              <a:t>-6</a:t>
+            </a:r>
+            <a:r>
+              <a:rPr lang="en-GB" sz="2000" b="1" dirty="0">
+                <a:latin typeface="Arial" panose="020B0604020202020204" pitchFamily="34" charset="0"/>
+                <a:cs typeface="Arial" panose="020B0604020202020204" pitchFamily="34" charset="0"/>
+              </a:rPr>
+              <a:t> , ES = 60, 100, 200</a:t>
+            </a:r>
+          </a:p>
+        </p:txBody>
+      </p:sp>
+      <p:pic>
+        <p:nvPicPr>
+          <p:cNvPr id="5" name="Picture 4">
+            <a:extLst>
+              <a:ext uri="{FF2B5EF4-FFF2-40B4-BE49-F238E27FC236}">
+                <a16:creationId xmlns:a16="http://schemas.microsoft.com/office/drawing/2014/main" id="{FEF97DAA-446C-3417-F234-7654DB3D97C4}"/>
+              </a:ext>
+            </a:extLst>
+          </p:cNvPr>
+          <p:cNvPicPr>
+            <a:picLocks noChangeAspect="1"/>
+          </p:cNvPicPr>
+          <p:nvPr/>
+        </p:nvPicPr>
+        <p:blipFill>
+          <a:blip r:embed="rId3">
+            <a:extLst>
+              <a:ext uri="{28A0092B-C50C-407E-A947-70E740481C1C}">
+                <a14:useLocalDpi xmlns:a14="http://schemas.microsoft.com/office/drawing/2010/main" val="0"/>
+              </a:ext>
+            </a:extLst>
+          </a:blip>
+          <a:srcRect t="4918" b="6969"/>
+          <a:stretch>
+            <a:fillRect/>
+          </a:stretch>
+        </p:blipFill>
+        <p:spPr>
+          <a:xfrm>
+            <a:off x="76112" y="935530"/>
+            <a:ext cx="12039775" cy="5399281"/>
+          </a:xfrm>
+          <a:prstGeom prst="rect">
+            <a:avLst/>
+          </a:prstGeom>
+        </p:spPr>
+      </p:pic>
+    </p:spTree>
+    <p:extLst>
+      <p:ext uri="{BB962C8B-B14F-4D97-AF65-F5344CB8AC3E}">
+        <p14:creationId xmlns:p14="http://schemas.microsoft.com/office/powerpoint/2010/main" val="208240160"/>
+      </p:ext>
+    </p:extLst>
+  </p:cSld>
+  <p:clrMapOvr>
+    <a:masterClrMapping/>
+  </p:clrMapOvr>
+</p:sld>
+</file>
+
+<file path=ppt/slides/slide15.xml><?xml version="1.0" encoding="utf-8"?>
+<p:sld xmlns:a="http://schemas.openxmlformats.org/drawingml/2006/main" xmlns:r="http://schemas.openxmlformats.org/officeDocument/2006/relationships" xmlns:p="http://schemas.openxmlformats.org/presentationml/2006/main">
+  <p:cSld>
+    <p:spTree>
+      <p:nvGrpSpPr>
+        <p:cNvPr id="1" name="">
+          <a:extLst>
+            <a:ext uri="{FF2B5EF4-FFF2-40B4-BE49-F238E27FC236}">
+              <a16:creationId xmlns:a16="http://schemas.microsoft.com/office/drawing/2014/main" id="{0995B2E1-28CC-4157-7781-EDF3FFC32E0A}"/>
+            </a:ext>
+          </a:extLst>
+        </p:cNvPr>
+        <p:cNvGrpSpPr/>
+        <p:nvPr/>
+      </p:nvGrpSpPr>
+      <p:grpSpPr>
+        <a:xfrm>
+          <a:off x="0" y="0"/>
+          <a:ext cx="0" cy="0"/>
+          <a:chOff x="0" y="0"/>
+          <a:chExt cx="0" cy="0"/>
+        </a:xfrm>
+      </p:grpSpPr>
+      <p:sp>
+        <p:nvSpPr>
+          <p:cNvPr id="4" name="TextBox 3">
+            <a:extLst>
+              <a:ext uri="{FF2B5EF4-FFF2-40B4-BE49-F238E27FC236}">
+                <a16:creationId xmlns:a16="http://schemas.microsoft.com/office/drawing/2014/main" id="{0FF58926-5077-2FC6-7F64-A613A789C169}"/>
+              </a:ext>
+            </a:extLst>
+          </p:cNvPr>
+          <p:cNvSpPr txBox="1"/>
+          <p:nvPr/>
+        </p:nvSpPr>
+        <p:spPr>
+          <a:xfrm>
+            <a:off x="552818" y="2905780"/>
+            <a:ext cx="6821375" cy="523220"/>
+          </a:xfrm>
+          <a:prstGeom prst="rect">
+            <a:avLst/>
+          </a:prstGeom>
+          <a:noFill/>
+        </p:spPr>
+        <p:txBody>
+          <a:bodyPr wrap="square" rtlCol="0">
+            <a:spAutoFit/>
+          </a:bodyPr>
+          <a:lstStyle/>
+          <a:p>
+            <a:r>
+              <a:rPr lang="en-GB" sz="2800" b="1" dirty="0">
+                <a:latin typeface="Arial" panose="020B0604020202020204" pitchFamily="34" charset="0"/>
+                <a:cs typeface="Arial" panose="020B0604020202020204" pitchFamily="34" charset="0"/>
+              </a:rPr>
+              <a:t>Implementing Callbacks</a:t>
+            </a:r>
+            <a:endParaRPr lang="en-GB" sz="2800" b="1" baseline="30000" dirty="0">
+              <a:latin typeface="Arial" panose="020B0604020202020204" pitchFamily="34" charset="0"/>
+              <a:cs typeface="Arial" panose="020B0604020202020204" pitchFamily="34" charset="0"/>
+            </a:endParaRPr>
+          </a:p>
+        </p:txBody>
+      </p:sp>
+    </p:spTree>
+    <p:extLst>
+      <p:ext uri="{BB962C8B-B14F-4D97-AF65-F5344CB8AC3E}">
+        <p14:creationId xmlns:p14="http://schemas.microsoft.com/office/powerpoint/2010/main" val="2691878336"/>
+      </p:ext>
+    </p:extLst>
+  </p:cSld>
+  <p:clrMapOvr>
+    <a:masterClrMapping/>
+  </p:clrMapOvr>
+</p:sld>
+</file>
+
+<file path=ppt/slides/slide16.xml><?xml version="1.0" encoding="utf-8"?>
+<p:sld xmlns:a="http://schemas.openxmlformats.org/drawingml/2006/main" xmlns:r="http://schemas.openxmlformats.org/officeDocument/2006/relationships" xmlns:p="http://schemas.openxmlformats.org/presentationml/2006/main">
+  <p:cSld>
+    <p:spTree>
+      <p:nvGrpSpPr>
+        <p:cNvPr id="1" name="">
+          <a:extLst>
+            <a:ext uri="{FF2B5EF4-FFF2-40B4-BE49-F238E27FC236}">
+              <a16:creationId xmlns:a16="http://schemas.microsoft.com/office/drawing/2014/main" id="{BDEDCE9A-AF3C-1F8A-AECA-F7F69F88B8BB}"/>
+            </a:ext>
+          </a:extLst>
+        </p:cNvPr>
+        <p:cNvGrpSpPr/>
+        <p:nvPr/>
+      </p:nvGrpSpPr>
+      <p:grpSpPr>
+        <a:xfrm>
+          <a:off x="0" y="0"/>
+          <a:ext cx="0" cy="0"/>
+          <a:chOff x="0" y="0"/>
+          <a:chExt cx="0" cy="0"/>
+        </a:xfrm>
+      </p:grpSpPr>
+      <p:sp>
+        <p:nvSpPr>
+          <p:cNvPr id="4" name="TextBox 3">
+            <a:extLst>
+              <a:ext uri="{FF2B5EF4-FFF2-40B4-BE49-F238E27FC236}">
+                <a16:creationId xmlns:a16="http://schemas.microsoft.com/office/drawing/2014/main" id="{17DDC0F6-76E1-49AC-E3FE-2E86353E757D}"/>
+              </a:ext>
+            </a:extLst>
+          </p:cNvPr>
+          <p:cNvSpPr txBox="1"/>
+          <p:nvPr/>
+        </p:nvSpPr>
+        <p:spPr>
+          <a:xfrm>
+            <a:off x="67732" y="93133"/>
+            <a:ext cx="10094363" cy="400110"/>
+          </a:xfrm>
+          <a:prstGeom prst="rect">
+            <a:avLst/>
+          </a:prstGeom>
+          <a:noFill/>
+        </p:spPr>
+        <p:txBody>
+          <a:bodyPr wrap="square" rtlCol="0">
+            <a:spAutoFit/>
+          </a:bodyPr>
+          <a:lstStyle/>
+          <a:p>
+            <a:r>
+              <a:rPr lang="en-GB" sz="2000" b="1" dirty="0">
+                <a:latin typeface="Arial" panose="020B0604020202020204" pitchFamily="34" charset="0"/>
+                <a:cs typeface="Arial" panose="020B0604020202020204" pitchFamily="34" charset="0"/>
+              </a:rPr>
+              <a:t>Callbacks: Reduce Learning Rate on Plateau (RLROP) and Early Stopping (ES)</a:t>
+            </a:r>
+          </a:p>
+        </p:txBody>
+      </p:sp>
+      <p:sp>
+        <p:nvSpPr>
+          <p:cNvPr id="2" name="TextBox 1">
+            <a:extLst>
+              <a:ext uri="{FF2B5EF4-FFF2-40B4-BE49-F238E27FC236}">
+                <a16:creationId xmlns:a16="http://schemas.microsoft.com/office/drawing/2014/main" id="{6FC8B760-98AB-E87A-46FF-4612AAC6C0FB}"/>
+              </a:ext>
+            </a:extLst>
+          </p:cNvPr>
+          <p:cNvSpPr txBox="1"/>
+          <p:nvPr/>
+        </p:nvSpPr>
+        <p:spPr>
+          <a:xfrm>
+            <a:off x="67732" y="688593"/>
+            <a:ext cx="11470675" cy="1631216"/>
+          </a:xfrm>
+          <a:prstGeom prst="rect">
+            <a:avLst/>
+          </a:prstGeom>
+          <a:noFill/>
+        </p:spPr>
+        <p:txBody>
+          <a:bodyPr wrap="square" rtlCol="0">
+            <a:spAutoFit/>
+          </a:bodyPr>
+          <a:lstStyle/>
+          <a:p>
+            <a:r>
+              <a:rPr lang="en-GB" sz="2000" i="1" dirty="0">
+                <a:latin typeface="Arial" panose="020B0604020202020204" pitchFamily="34" charset="0"/>
+                <a:cs typeface="Arial" panose="020B0604020202020204" pitchFamily="34" charset="0"/>
+              </a:rPr>
+              <a:t>Strategy</a:t>
+            </a:r>
+          </a:p>
+          <a:p>
+            <a:endParaRPr lang="en-GB" sz="2000" dirty="0">
+              <a:latin typeface="Arial" panose="020B0604020202020204" pitchFamily="34" charset="0"/>
+              <a:cs typeface="Arial" panose="020B0604020202020204" pitchFamily="34" charset="0"/>
+            </a:endParaRPr>
+          </a:p>
+          <a:p>
+            <a:pPr marL="342900" indent="-342900">
+              <a:buFont typeface="Arial" panose="020B0604020202020204" pitchFamily="34" charset="0"/>
+              <a:buChar char="•"/>
+            </a:pPr>
+            <a:r>
+              <a:rPr lang="en-GB" sz="2000" dirty="0">
+                <a:latin typeface="Arial" panose="020B0604020202020204" pitchFamily="34" charset="0"/>
+                <a:cs typeface="Arial" panose="020B0604020202020204" pitchFamily="34" charset="0"/>
+              </a:rPr>
+              <a:t>Create a model with a LR of 1x10-4 with lots of epochs (200-500 if necessary) and implement:</a:t>
+            </a:r>
+          </a:p>
+          <a:p>
+            <a:pPr marL="1828800" lvl="3" indent="-457200">
+              <a:buFont typeface="+mj-lt"/>
+              <a:buAutoNum type="arabicPeriod"/>
+            </a:pPr>
+            <a:r>
+              <a:rPr lang="en-GB" sz="2000" dirty="0">
+                <a:latin typeface="Arial" panose="020B0604020202020204" pitchFamily="34" charset="0"/>
+                <a:cs typeface="Arial" panose="020B0604020202020204" pitchFamily="34" charset="0"/>
+              </a:rPr>
+              <a:t>RLROP</a:t>
+            </a:r>
+          </a:p>
+          <a:p>
+            <a:pPr marL="1828800" lvl="3" indent="-457200">
+              <a:buFont typeface="+mj-lt"/>
+              <a:buAutoNum type="arabicPeriod"/>
+            </a:pPr>
+            <a:r>
+              <a:rPr lang="en-GB" sz="2000" dirty="0">
+                <a:latin typeface="Arial" panose="020B0604020202020204" pitchFamily="34" charset="0"/>
+                <a:cs typeface="Arial" panose="020B0604020202020204" pitchFamily="34" charset="0"/>
+              </a:rPr>
+              <a:t>RLROP + ES</a:t>
+            </a:r>
+          </a:p>
+        </p:txBody>
+      </p:sp>
+    </p:spTree>
+    <p:extLst>
+      <p:ext uri="{BB962C8B-B14F-4D97-AF65-F5344CB8AC3E}">
+        <p14:creationId xmlns:p14="http://schemas.microsoft.com/office/powerpoint/2010/main" val="951023884"/>
+      </p:ext>
+    </p:extLst>
+  </p:cSld>
+  <p:clrMapOvr>
+    <a:masterClrMapping/>
+  </p:clrMapOvr>
+</p:sld>
+</file>
+
+<file path=ppt/slides/slide17.xml><?xml version="1.0" encoding="utf-8"?>
+<p:sld xmlns:a="http://schemas.openxmlformats.org/drawingml/2006/main" xmlns:r="http://schemas.openxmlformats.org/officeDocument/2006/relationships" xmlns:p="http://schemas.openxmlformats.org/presentationml/2006/main">
+  <p:cSld>
+    <p:spTree>
+      <p:nvGrpSpPr>
+        <p:cNvPr id="1" name="">
+          <a:extLst>
+            <a:ext uri="{FF2B5EF4-FFF2-40B4-BE49-F238E27FC236}">
+              <a16:creationId xmlns:a16="http://schemas.microsoft.com/office/drawing/2014/main" id="{2B5C497E-879B-614E-F35B-439706E05739}"/>
+            </a:ext>
+          </a:extLst>
+        </p:cNvPr>
+        <p:cNvGrpSpPr/>
+        <p:nvPr/>
+      </p:nvGrpSpPr>
+      <p:grpSpPr>
+        <a:xfrm>
+          <a:off x="0" y="0"/>
+          <a:ext cx="0" cy="0"/>
+          <a:chOff x="0" y="0"/>
+          <a:chExt cx="0" cy="0"/>
+        </a:xfrm>
+      </p:grpSpPr>
+      <p:sp>
+        <p:nvSpPr>
+          <p:cNvPr id="4" name="TextBox 3">
+            <a:extLst>
+              <a:ext uri="{FF2B5EF4-FFF2-40B4-BE49-F238E27FC236}">
+                <a16:creationId xmlns:a16="http://schemas.microsoft.com/office/drawing/2014/main" id="{6D4C19E8-B7BF-27A9-7211-480633571906}"/>
+              </a:ext>
+            </a:extLst>
+          </p:cNvPr>
+          <p:cNvSpPr txBox="1"/>
+          <p:nvPr/>
+        </p:nvSpPr>
+        <p:spPr>
+          <a:xfrm>
+            <a:off x="67733" y="93133"/>
+            <a:ext cx="4451801" cy="707886"/>
+          </a:xfrm>
+          <a:prstGeom prst="rect">
+            <a:avLst/>
+          </a:prstGeom>
+          <a:noFill/>
+        </p:spPr>
+        <p:txBody>
+          <a:bodyPr wrap="square" rtlCol="0">
+            <a:spAutoFit/>
+          </a:bodyPr>
+          <a:lstStyle/>
+          <a:p>
+            <a:r>
+              <a:rPr lang="en-GB" sz="2000" b="1" dirty="0">
+                <a:latin typeface="Arial" panose="020B0604020202020204" pitchFamily="34" charset="0"/>
+                <a:cs typeface="Arial" panose="020B0604020202020204" pitchFamily="34" charset="0"/>
+              </a:rPr>
+              <a:t>Model Comparison</a:t>
+            </a:r>
+          </a:p>
+          <a:p>
+            <a:r>
+              <a:rPr lang="en-GB" sz="2000" b="1" dirty="0">
+                <a:solidFill>
+                  <a:srgbClr val="0070C0"/>
+                </a:solidFill>
+                <a:latin typeface="Arial" panose="020B0604020202020204" pitchFamily="34" charset="0"/>
+                <a:cs typeface="Arial" panose="020B0604020202020204" pitchFamily="34" charset="0"/>
+              </a:rPr>
+              <a:t>RLROP and ES</a:t>
+            </a:r>
+          </a:p>
+        </p:txBody>
+      </p:sp>
+      <p:pic>
+        <p:nvPicPr>
+          <p:cNvPr id="3" name="Picture 2">
+            <a:extLst>
+              <a:ext uri="{FF2B5EF4-FFF2-40B4-BE49-F238E27FC236}">
+                <a16:creationId xmlns:a16="http://schemas.microsoft.com/office/drawing/2014/main" id="{45437738-7D79-D434-F996-68E654728721}"/>
+              </a:ext>
+            </a:extLst>
+          </p:cNvPr>
+          <p:cNvPicPr>
+            <a:picLocks noChangeAspect="1"/>
+          </p:cNvPicPr>
+          <p:nvPr/>
+        </p:nvPicPr>
+        <p:blipFill>
+          <a:blip r:embed="rId2">
+            <a:extLst>
+              <a:ext uri="{28A0092B-C50C-407E-A947-70E740481C1C}">
+                <a14:useLocalDpi xmlns:a14="http://schemas.microsoft.com/office/drawing/2010/main" val="0"/>
+              </a:ext>
+            </a:extLst>
+          </a:blip>
+          <a:srcRect l="344" t="4536" r="281" b="8866"/>
+          <a:stretch>
+            <a:fillRect/>
+          </a:stretch>
+        </p:blipFill>
+        <p:spPr>
+          <a:xfrm>
+            <a:off x="307314" y="825980"/>
+            <a:ext cx="11577371" cy="5938887"/>
+          </a:xfrm>
+          <a:prstGeom prst="rect">
+            <a:avLst/>
+          </a:prstGeom>
+        </p:spPr>
+      </p:pic>
+    </p:spTree>
+    <p:extLst>
+      <p:ext uri="{BB962C8B-B14F-4D97-AF65-F5344CB8AC3E}">
+        <p14:creationId xmlns:p14="http://schemas.microsoft.com/office/powerpoint/2010/main" val="3847864492"/>
       </p:ext>
     </p:extLst>
   </p:cSld>
@@ -4261,8 +5439,8 @@
         </p:nvSpPr>
         <p:spPr>
           <a:xfrm>
-            <a:off x="67733" y="93133"/>
-            <a:ext cx="10837333" cy="707886"/>
+            <a:off x="67734" y="93133"/>
+            <a:ext cx="4444306" cy="707886"/>
           </a:xfrm>
           <a:prstGeom prst="rect">
             <a:avLst/>
@@ -4405,8 +5583,8 @@
         </p:nvSpPr>
         <p:spPr>
           <a:xfrm>
-            <a:off x="67733" y="93133"/>
-            <a:ext cx="10837333" cy="707886"/>
+            <a:off x="67734" y="93133"/>
+            <a:ext cx="4646674" cy="707886"/>
           </a:xfrm>
           <a:prstGeom prst="rect">
             <a:avLst/>
@@ -4550,7 +5728,7 @@
         <p:spPr>
           <a:xfrm>
             <a:off x="67733" y="93133"/>
-            <a:ext cx="10837333" cy="707886"/>
+            <a:ext cx="4354365" cy="707886"/>
           </a:xfrm>
           <a:prstGeom prst="rect">
             <a:avLst/>
@@ -4694,7 +5872,7 @@
         <p:spPr>
           <a:xfrm>
             <a:off x="67733" y="93133"/>
-            <a:ext cx="10837333" cy="707886"/>
+            <a:ext cx="4631683" cy="707886"/>
           </a:xfrm>
           <a:prstGeom prst="rect">
             <a:avLst/>
@@ -4838,7 +6016,7 @@
         <p:spPr>
           <a:xfrm>
             <a:off x="67733" y="93133"/>
-            <a:ext cx="10837333" cy="707886"/>
+            <a:ext cx="4729119" cy="707886"/>
           </a:xfrm>
           <a:prstGeom prst="rect">
             <a:avLst/>
@@ -4995,8 +6173,8 @@
         </p:nvSpPr>
         <p:spPr>
           <a:xfrm>
-            <a:off x="67733" y="93133"/>
-            <a:ext cx="10837333" cy="707886"/>
+            <a:off x="67734" y="93133"/>
+            <a:ext cx="5328726" cy="707886"/>
           </a:xfrm>
           <a:prstGeom prst="rect">
             <a:avLst/>
@@ -5153,8 +6331,8 @@
         </p:nvSpPr>
         <p:spPr>
           <a:xfrm>
-            <a:off x="67733" y="93133"/>
-            <a:ext cx="10837333" cy="707886"/>
+            <a:off x="67734" y="93133"/>
+            <a:ext cx="5456142" cy="707886"/>
           </a:xfrm>
           <a:prstGeom prst="rect">
             <a:avLst/>
@@ -5587,4 +6765,319 @@
     </a:ext>
   </a:extLst>
 </a:theme>
+</file>
+
+<file path=ppt/theme/theme2.xml><?xml version="1.0" encoding="utf-8"?>
+<a:theme xmlns:a="http://schemas.openxmlformats.org/drawingml/2006/main" name="Office Theme">
+  <a:themeElements>
+    <a:clrScheme name="Office">
+      <a:dk1>
+        <a:sysClr val="windowText" lastClr="000000"/>
+      </a:dk1>
+      <a:lt1>
+        <a:sysClr val="window" lastClr="FFFFFF"/>
+      </a:lt1>
+      <a:dk2>
+        <a:srgbClr val="0E2841"/>
+      </a:dk2>
+      <a:lt2>
+        <a:srgbClr val="E8E8E8"/>
+      </a:lt2>
+      <a:accent1>
+        <a:srgbClr val="156082"/>
+      </a:accent1>
+      <a:accent2>
+        <a:srgbClr val="E97132"/>
+      </a:accent2>
+      <a:accent3>
+        <a:srgbClr val="196B24"/>
+      </a:accent3>
+      <a:accent4>
+        <a:srgbClr val="0F9ED5"/>
+      </a:accent4>
+      <a:accent5>
+        <a:srgbClr val="A02B93"/>
+      </a:accent5>
+      <a:accent6>
+        <a:srgbClr val="4EA72E"/>
+      </a:accent6>
+      <a:hlink>
+        <a:srgbClr val="467886"/>
+      </a:hlink>
+      <a:folHlink>
+        <a:srgbClr val="96607D"/>
+      </a:folHlink>
+    </a:clrScheme>
+    <a:fontScheme name="Office">
+      <a:majorFont>
+        <a:latin typeface="Aptos Display" panose="02110004020202020204"/>
+        <a:ea typeface=""/>
+        <a:cs typeface=""/>
+        <a:font script="Jpan" typeface="游ゴシック Light"/>
+        <a:font script="Hang" typeface="맑은 고딕"/>
+        <a:font script="Hans" typeface="等线 Light"/>
+        <a:font script="Hant" typeface="新細明體"/>
+        <a:font script="Arab" typeface="Times New Roman"/>
+        <a:font script="Hebr" typeface="Times New Roman"/>
+        <a:font script="Thai" typeface="Angsana New"/>
+        <a:font script="Ethi" typeface="Nyala"/>
+        <a:font script="Beng" typeface="Vrinda"/>
+        <a:font script="Gujr" typeface="Shruti"/>
+        <a:font script="Khmr" typeface="MoolBoran"/>
+        <a:font script="Knda" typeface="Tunga"/>
+        <a:font script="Guru" typeface="Raavi"/>
+        <a:font script="Cans" typeface="Euphemia"/>
+        <a:font script="Cher" typeface="Plantagenet Cherokee"/>
+        <a:font script="Yiii" typeface="Microsoft Yi Baiti"/>
+        <a:font script="Tibt" typeface="Microsoft Himalaya"/>
+        <a:font script="Thaa" typeface="MV Boli"/>
+        <a:font script="Deva" typeface="Mangal"/>
+        <a:font script="Telu" typeface="Gautami"/>
+        <a:font script="Taml" typeface="Latha"/>
+        <a:font script="Syrc" typeface="Estrangelo Edessa"/>
+        <a:font script="Orya" typeface="Kalinga"/>
+        <a:font script="Mlym" typeface="Kartika"/>
+        <a:font script="Laoo" typeface="DokChampa"/>
+        <a:font script="Sinh" typeface="Iskoola Pota"/>
+        <a:font script="Mong" typeface="Mongolian Baiti"/>
+        <a:font script="Viet" typeface="Times New Roman"/>
+        <a:font script="Uigh" typeface="Microsoft Uighur"/>
+        <a:font script="Geor" typeface="Sylfaen"/>
+        <a:font script="Armn" typeface="Arial"/>
+        <a:font script="Bugi" typeface="Leelawadee UI"/>
+        <a:font script="Bopo" typeface="Microsoft JhengHei"/>
+        <a:font script="Java" typeface="Javanese Text"/>
+        <a:font script="Lisu" typeface="Segoe UI"/>
+        <a:font script="Mymr" typeface="Myanmar Text"/>
+        <a:font script="Nkoo" typeface="Ebrima"/>
+        <a:font script="Olck" typeface="Nirmala UI"/>
+        <a:font script="Osma" typeface="Ebrima"/>
+        <a:font script="Phag" typeface="Phagspa"/>
+        <a:font script="Syrn" typeface="Estrangelo Edessa"/>
+        <a:font script="Syrj" typeface="Estrangelo Edessa"/>
+        <a:font script="Syre" typeface="Estrangelo Edessa"/>
+        <a:font script="Sora" typeface="Nirmala UI"/>
+        <a:font script="Tale" typeface="Microsoft Tai Le"/>
+        <a:font script="Talu" typeface="Microsoft New Tai Lue"/>
+        <a:font script="Tfng" typeface="Ebrima"/>
+      </a:majorFont>
+      <a:minorFont>
+        <a:latin typeface="Aptos" panose="02110004020202020204"/>
+        <a:ea typeface=""/>
+        <a:cs typeface=""/>
+        <a:font script="Jpan" typeface="游ゴシック"/>
+        <a:font script="Hang" typeface="맑은 고딕"/>
+        <a:font script="Hans" typeface="等线"/>
+        <a:font script="Hant" typeface="新細明體"/>
+        <a:font script="Arab" typeface="Arial"/>
+        <a:font script="Hebr" typeface="Arial"/>
+        <a:font script="Thai" typeface="Cordia New"/>
+        <a:font script="Ethi" typeface="Nyala"/>
+        <a:font script="Beng" typeface="Vrinda"/>
+        <a:font script="Gujr" typeface="Shruti"/>
+        <a:font script="Khmr" typeface="DaunPenh"/>
+        <a:font script="Knda" typeface="Tunga"/>
+        <a:font script="Guru" typeface="Raavi"/>
+        <a:font script="Cans" typeface="Euphemia"/>
+        <a:font script="Cher" typeface="Plantagenet Cherokee"/>
+        <a:font script="Yiii" typeface="Microsoft Yi Baiti"/>
+        <a:font script="Tibt" typeface="Microsoft Himalaya"/>
+        <a:font script="Thaa" typeface="MV Boli"/>
+        <a:font script="Deva" typeface="Mangal"/>
+        <a:font script="Telu" typeface="Gautami"/>
+        <a:font script="Taml" typeface="Latha"/>
+        <a:font script="Syrc" typeface="Estrangelo Edessa"/>
+        <a:font script="Orya" typeface="Kalinga"/>
+        <a:font script="Mlym" typeface="Kartika"/>
+        <a:font script="Laoo" typeface="DokChampa"/>
+        <a:font script="Sinh" typeface="Iskoola Pota"/>
+        <a:font script="Mong" typeface="Mongolian Baiti"/>
+        <a:font script="Viet" typeface="Arial"/>
+        <a:font script="Uigh" typeface="Microsoft Uighur"/>
+        <a:font script="Geor" typeface="Sylfaen"/>
+        <a:font script="Armn" typeface="Arial"/>
+        <a:font script="Bugi" typeface="Leelawadee UI"/>
+        <a:font script="Bopo" typeface="Microsoft JhengHei"/>
+        <a:font script="Java" typeface="Javanese Text"/>
+        <a:font script="Lisu" typeface="Segoe UI"/>
+        <a:font script="Mymr" typeface="Myanmar Text"/>
+        <a:font script="Nkoo" typeface="Ebrima"/>
+        <a:font script="Olck" typeface="Nirmala UI"/>
+        <a:font script="Osma" typeface="Ebrima"/>
+        <a:font script="Phag" typeface="Phagspa"/>
+        <a:font script="Syrn" typeface="Estrangelo Edessa"/>
+        <a:font script="Syrj" typeface="Estrangelo Edessa"/>
+        <a:font script="Syre" typeface="Estrangelo Edessa"/>
+        <a:font script="Sora" typeface="Nirmala UI"/>
+        <a:font script="Tale" typeface="Microsoft Tai Le"/>
+        <a:font script="Talu" typeface="Microsoft New Tai Lue"/>
+        <a:font script="Tfng" typeface="Ebrima"/>
+      </a:minorFont>
+    </a:fontScheme>
+    <a:fmtScheme name="Office">
+      <a:fillStyleLst>
+        <a:solidFill>
+          <a:schemeClr val="phClr"/>
+        </a:solidFill>
+        <a:gradFill rotWithShape="1">
+          <a:gsLst>
+            <a:gs pos="0">
+              <a:schemeClr val="phClr">
+                <a:lumMod val="110000"/>
+                <a:satMod val="105000"/>
+                <a:tint val="67000"/>
+              </a:schemeClr>
+            </a:gs>
+            <a:gs pos="50000">
+              <a:schemeClr val="phClr">
+                <a:lumMod val="105000"/>
+                <a:satMod val="103000"/>
+                <a:tint val="73000"/>
+              </a:schemeClr>
+            </a:gs>
+            <a:gs pos="100000">
+              <a:schemeClr val="phClr">
+                <a:lumMod val="105000"/>
+                <a:satMod val="109000"/>
+                <a:tint val="81000"/>
+              </a:schemeClr>
+            </a:gs>
+          </a:gsLst>
+          <a:lin ang="5400000" scaled="0"/>
+        </a:gradFill>
+        <a:gradFill rotWithShape="1">
+          <a:gsLst>
+            <a:gs pos="0">
+              <a:schemeClr val="phClr">
+                <a:satMod val="103000"/>
+                <a:lumMod val="102000"/>
+                <a:tint val="94000"/>
+              </a:schemeClr>
+            </a:gs>
+            <a:gs pos="50000">
+              <a:schemeClr val="phClr">
+                <a:satMod val="110000"/>
+                <a:lumMod val="100000"/>
+                <a:shade val="100000"/>
+              </a:schemeClr>
+            </a:gs>
+            <a:gs pos="100000">
+              <a:schemeClr val="phClr">
+                <a:lumMod val="99000"/>
+                <a:satMod val="120000"/>
+                <a:shade val="78000"/>
+              </a:schemeClr>
+            </a:gs>
+          </a:gsLst>
+          <a:lin ang="5400000" scaled="0"/>
+        </a:gradFill>
+      </a:fillStyleLst>
+      <a:lnStyleLst>
+        <a:ln w="12700" cap="flat" cmpd="sng" algn="ctr">
+          <a:solidFill>
+            <a:schemeClr val="phClr"/>
+          </a:solidFill>
+          <a:prstDash val="solid"/>
+          <a:miter lim="800000"/>
+        </a:ln>
+        <a:ln w="19050" cap="flat" cmpd="sng" algn="ctr">
+          <a:solidFill>
+            <a:schemeClr val="phClr"/>
+          </a:solidFill>
+          <a:prstDash val="solid"/>
+          <a:miter lim="800000"/>
+        </a:ln>
+        <a:ln w="25400" cap="flat" cmpd="sng" algn="ctr">
+          <a:solidFill>
+            <a:schemeClr val="phClr"/>
+          </a:solidFill>
+          <a:prstDash val="solid"/>
+          <a:miter lim="800000"/>
+        </a:ln>
+      </a:lnStyleLst>
+      <a:effectStyleLst>
+        <a:effectStyle>
+          <a:effectLst/>
+        </a:effectStyle>
+        <a:effectStyle>
+          <a:effectLst/>
+        </a:effectStyle>
+        <a:effectStyle>
+          <a:effectLst>
+            <a:outerShdw blurRad="57150" dist="19050" dir="5400000" algn="ctr" rotWithShape="0">
+              <a:srgbClr val="000000">
+                <a:alpha val="63000"/>
+              </a:srgbClr>
+            </a:outerShdw>
+          </a:effectLst>
+        </a:effectStyle>
+      </a:effectStyleLst>
+      <a:bgFillStyleLst>
+        <a:solidFill>
+          <a:schemeClr val="phClr"/>
+        </a:solidFill>
+        <a:solidFill>
+          <a:schemeClr val="phClr">
+            <a:tint val="95000"/>
+            <a:satMod val="170000"/>
+          </a:schemeClr>
+        </a:solidFill>
+        <a:gradFill rotWithShape="1">
+          <a:gsLst>
+            <a:gs pos="0">
+              <a:schemeClr val="phClr">
+                <a:tint val="93000"/>
+                <a:satMod val="150000"/>
+                <a:shade val="98000"/>
+                <a:lumMod val="102000"/>
+              </a:schemeClr>
+            </a:gs>
+            <a:gs pos="50000">
+              <a:schemeClr val="phClr">
+                <a:tint val="98000"/>
+                <a:satMod val="130000"/>
+                <a:shade val="90000"/>
+                <a:lumMod val="103000"/>
+              </a:schemeClr>
+            </a:gs>
+            <a:gs pos="100000">
+              <a:schemeClr val="phClr">
+                <a:shade val="63000"/>
+                <a:satMod val="120000"/>
+              </a:schemeClr>
+            </a:gs>
+          </a:gsLst>
+          <a:lin ang="5400000" scaled="0"/>
+        </a:gradFill>
+      </a:bgFillStyleLst>
+    </a:fmtScheme>
+  </a:themeElements>
+  <a:objectDefaults>
+    <a:lnDef>
+      <a:spPr/>
+      <a:bodyPr/>
+      <a:lstStyle/>
+      <a:style>
+        <a:lnRef idx="2">
+          <a:schemeClr val="accent1"/>
+        </a:lnRef>
+        <a:fillRef idx="0">
+          <a:schemeClr val="accent1"/>
+        </a:fillRef>
+        <a:effectRef idx="1">
+          <a:schemeClr val="accent1"/>
+        </a:effectRef>
+        <a:fontRef idx="minor">
+          <a:schemeClr val="tx1"/>
+        </a:fontRef>
+      </a:style>
+    </a:lnDef>
+  </a:objectDefaults>
+  <a:extraClrSchemeLst/>
+  <a:extLst>
+    <a:ext uri="{05A4C25C-085E-4340-85A3-A5531E510DB2}">
+      <thm15:themeFamily xmlns:thm15="http://schemas.microsoft.com/office/thememl/2012/main" name="Office Theme" id="{2E142A2C-CD16-42D6-873A-C26D2A0506FA}" vid="{1BDDFF52-6CD6-40A5-AB3C-68EB2F1E4D0A}"/>
+    </a:ext>
+  </a:extLst>
+</a:theme>
 </file>
</xml_diff>

<commit_message>
Started development of the Streamlit-based front-end portion of the project along with further dissemination of model evaluation results.
</commit_message>
<xml_diff>
--- a/dissemination/Brain Tumor Classification Model Comparisons.pptx
+++ b/dissemination/Brain Tumor Classification Model Comparisons.pptx
@@ -5,7 +5,7 @@
     <p:sldMasterId id="2147483648" r:id="rId1"/>
   </p:sldMasterIdLst>
   <p:notesMasterIdLst>
-    <p:notesMasterId r:id="rId19"/>
+    <p:notesMasterId r:id="rId20"/>
   </p:notesMasterIdLst>
   <p:sldIdLst>
     <p:sldId id="257" r:id="rId2"/>
@@ -25,6 +25,7 @@
     <p:sldId id="272" r:id="rId16"/>
     <p:sldId id="273" r:id="rId17"/>
     <p:sldId id="268" r:id="rId18"/>
+    <p:sldId id="274" r:id="rId19"/>
   </p:sldIdLst>
   <p:sldSz cx="12192000" cy="6858000"/>
   <p:notesSz cx="6858000" cy="9144000"/>
@@ -213,7 +214,7 @@
           <a:p>
             <a:fld id="{5BEAC4C3-7F01-4D2F-B765-F2404496EEE9}" type="datetimeFigureOut">
               <a:rPr lang="en-GB" smtClean="0"/>
-              <a:t>20/03/2026</a:t>
+              <a:t>21/03/2026</a:t>
             </a:fld>
             <a:endParaRPr lang="en-GB"/>
           </a:p>
@@ -717,7 +718,7 @@
           <a:p>
             <a:fld id="{1D725620-1185-4627-BCBE-4E695665A1FA}" type="datetimeFigureOut">
               <a:rPr lang="en-GB" smtClean="0"/>
-              <a:t>20/03/2026</a:t>
+              <a:t>21/03/2026</a:t>
             </a:fld>
             <a:endParaRPr lang="en-GB"/>
           </a:p>
@@ -917,7 +918,7 @@
           <a:p>
             <a:fld id="{1D725620-1185-4627-BCBE-4E695665A1FA}" type="datetimeFigureOut">
               <a:rPr lang="en-GB" smtClean="0"/>
-              <a:t>20/03/2026</a:t>
+              <a:t>21/03/2026</a:t>
             </a:fld>
             <a:endParaRPr lang="en-GB"/>
           </a:p>
@@ -1127,7 +1128,7 @@
           <a:p>
             <a:fld id="{1D725620-1185-4627-BCBE-4E695665A1FA}" type="datetimeFigureOut">
               <a:rPr lang="en-GB" smtClean="0"/>
-              <a:t>20/03/2026</a:t>
+              <a:t>21/03/2026</a:t>
             </a:fld>
             <a:endParaRPr lang="en-GB"/>
           </a:p>
@@ -1327,7 +1328,7 @@
           <a:p>
             <a:fld id="{1D725620-1185-4627-BCBE-4E695665A1FA}" type="datetimeFigureOut">
               <a:rPr lang="en-GB" smtClean="0"/>
-              <a:t>20/03/2026</a:t>
+              <a:t>21/03/2026</a:t>
             </a:fld>
             <a:endParaRPr lang="en-GB"/>
           </a:p>
@@ -1603,7 +1604,7 @@
           <a:p>
             <a:fld id="{1D725620-1185-4627-BCBE-4E695665A1FA}" type="datetimeFigureOut">
               <a:rPr lang="en-GB" smtClean="0"/>
-              <a:t>20/03/2026</a:t>
+              <a:t>21/03/2026</a:t>
             </a:fld>
             <a:endParaRPr lang="en-GB"/>
           </a:p>
@@ -1871,7 +1872,7 @@
           <a:p>
             <a:fld id="{1D725620-1185-4627-BCBE-4E695665A1FA}" type="datetimeFigureOut">
               <a:rPr lang="en-GB" smtClean="0"/>
-              <a:t>20/03/2026</a:t>
+              <a:t>21/03/2026</a:t>
             </a:fld>
             <a:endParaRPr lang="en-GB"/>
           </a:p>
@@ -2286,7 +2287,7 @@
           <a:p>
             <a:fld id="{1D725620-1185-4627-BCBE-4E695665A1FA}" type="datetimeFigureOut">
               <a:rPr lang="en-GB" smtClean="0"/>
-              <a:t>20/03/2026</a:t>
+              <a:t>21/03/2026</a:t>
             </a:fld>
             <a:endParaRPr lang="en-GB"/>
           </a:p>
@@ -2428,7 +2429,7 @@
           <a:p>
             <a:fld id="{1D725620-1185-4627-BCBE-4E695665A1FA}" type="datetimeFigureOut">
               <a:rPr lang="en-GB" smtClean="0"/>
-              <a:t>20/03/2026</a:t>
+              <a:t>21/03/2026</a:t>
             </a:fld>
             <a:endParaRPr lang="en-GB"/>
           </a:p>
@@ -2541,7 +2542,7 @@
           <a:p>
             <a:fld id="{1D725620-1185-4627-BCBE-4E695665A1FA}" type="datetimeFigureOut">
               <a:rPr lang="en-GB" smtClean="0"/>
-              <a:t>20/03/2026</a:t>
+              <a:t>21/03/2026</a:t>
             </a:fld>
             <a:endParaRPr lang="en-GB"/>
           </a:p>
@@ -2854,7 +2855,7 @@
           <a:p>
             <a:fld id="{1D725620-1185-4627-BCBE-4E695665A1FA}" type="datetimeFigureOut">
               <a:rPr lang="en-GB" smtClean="0"/>
-              <a:t>20/03/2026</a:t>
+              <a:t>21/03/2026</a:t>
             </a:fld>
             <a:endParaRPr lang="en-GB"/>
           </a:p>
@@ -3143,7 +3144,7 @@
           <a:p>
             <a:fld id="{1D725620-1185-4627-BCBE-4E695665A1FA}" type="datetimeFigureOut">
               <a:rPr lang="en-GB" smtClean="0"/>
-              <a:t>20/03/2026</a:t>
+              <a:t>21/03/2026</a:t>
             </a:fld>
             <a:endParaRPr lang="en-GB"/>
           </a:p>
@@ -3386,7 +3387,7 @@
           <a:p>
             <a:fld id="{1D725620-1185-4627-BCBE-4E695665A1FA}" type="datetimeFigureOut">
               <a:rPr lang="en-GB" smtClean="0"/>
-              <a:t>20/03/2026</a:t>
+              <a:t>21/03/2026</a:t>
             </a:fld>
             <a:endParaRPr lang="en-GB"/>
           </a:p>
@@ -4037,7 +4038,7 @@
                 <a:latin typeface="Arial" panose="020B0604020202020204" pitchFamily="34" charset="0"/>
                 <a:cs typeface="Arial" panose="020B0604020202020204" pitchFamily="34" charset="0"/>
               </a:rPr>
-              <a:t>No callbacks are implemented:</a:t>
+              <a:t>No callbacks are implemented in the early stages:</a:t>
             </a:r>
           </a:p>
           <a:p>
@@ -4981,7 +4982,7 @@
         <p:spPr>
           <a:xfrm>
             <a:off x="67732" y="688593"/>
-            <a:ext cx="11470675" cy="1631216"/>
+            <a:ext cx="11470675" cy="1477328"/>
           </a:xfrm>
           <a:prstGeom prst="rect">
             <a:avLst/>
@@ -4995,7 +4996,7 @@
           <a:lstStyle/>
           <a:p>
             <a:r>
-              <a:rPr lang="en-GB" sz="2000" i="1" dirty="0">
+              <a:rPr lang="en-GB" i="1" dirty="0">
                 <a:latin typeface="Arial" panose="020B0604020202020204" pitchFamily="34" charset="0"/>
                 <a:cs typeface="Arial" panose="020B0604020202020204" pitchFamily="34" charset="0"/>
               </a:rPr>
@@ -5003,7 +5004,7 @@
             </a:r>
           </a:p>
           <a:p>
-            <a:endParaRPr lang="en-GB" sz="2000" dirty="0">
+            <a:endParaRPr lang="en-GB" dirty="0">
               <a:latin typeface="Arial" panose="020B0604020202020204" pitchFamily="34" charset="0"/>
               <a:cs typeface="Arial" panose="020B0604020202020204" pitchFamily="34" charset="0"/>
             </a:endParaRPr>
@@ -5014,11 +5015,11 @@
               <a:buChar char="•"/>
             </a:pPr>
             <a:r>
-              <a:rPr lang="en-GB" sz="2000" dirty="0">
-                <a:latin typeface="Arial" panose="020B0604020202020204" pitchFamily="34" charset="0"/>
-                <a:cs typeface="Arial" panose="020B0604020202020204" pitchFamily="34" charset="0"/>
-              </a:rPr>
-              <a:t>Create a model with a LR of 1x10-4 with lots of epochs (200-500 if necessary) and implement:</a:t>
+              <a:rPr lang="en-GB" dirty="0">
+                <a:latin typeface="Arial" panose="020B0604020202020204" pitchFamily="34" charset="0"/>
+                <a:cs typeface="Arial" panose="020B0604020202020204" pitchFamily="34" charset="0"/>
+              </a:rPr>
+              <a:t>Create a model with a LR of 1x10-4 with lots of epochs (100) and implement:</a:t>
             </a:r>
           </a:p>
           <a:p>
@@ -5027,7 +5028,7 @@
               <a:buAutoNum type="arabicPeriod"/>
             </a:pPr>
             <a:r>
-              <a:rPr lang="en-GB" sz="2000" dirty="0">
+              <a:rPr lang="en-GB" dirty="0">
                 <a:latin typeface="Arial" panose="020B0604020202020204" pitchFamily="34" charset="0"/>
                 <a:cs typeface="Arial" panose="020B0604020202020204" pitchFamily="34" charset="0"/>
               </a:rPr>
@@ -5040,7 +5041,7 @@
               <a:buAutoNum type="arabicPeriod"/>
             </a:pPr>
             <a:r>
-              <a:rPr lang="en-GB" sz="2000" dirty="0">
+              <a:rPr lang="en-GB" dirty="0">
                 <a:latin typeface="Arial" panose="020B0604020202020204" pitchFamily="34" charset="0"/>
                 <a:cs typeface="Arial" panose="020B0604020202020204" pitchFamily="34" charset="0"/>
               </a:rPr>
@@ -5049,6 +5050,42 @@
           </a:p>
         </p:txBody>
       </p:sp>
+      <p:pic>
+        <p:nvPicPr>
+          <p:cNvPr id="5" name="Picture 4">
+            <a:extLst>
+              <a:ext uri="{FF2B5EF4-FFF2-40B4-BE49-F238E27FC236}">
+                <a16:creationId xmlns:a16="http://schemas.microsoft.com/office/drawing/2014/main" id="{F7713169-48E4-985A-EF96-45C24EECBAB3}"/>
+              </a:ext>
+            </a:extLst>
+          </p:cNvPr>
+          <p:cNvPicPr>
+            <a:picLocks noChangeAspect="1"/>
+          </p:cNvPicPr>
+          <p:nvPr/>
+        </p:nvPicPr>
+        <p:blipFill>
+          <a:blip r:embed="rId2">
+            <a:extLst>
+              <a:ext uri="{28A0092B-C50C-407E-A947-70E740481C1C}">
+                <a14:useLocalDpi xmlns:a14="http://schemas.microsoft.com/office/drawing/2010/main" val="0"/>
+              </a:ext>
+            </a:extLst>
+          </a:blip>
+          <a:stretch>
+            <a:fillRect/>
+          </a:stretch>
+        </p:blipFill>
+        <p:spPr>
+          <a:xfrm>
+            <a:off x="2083037" y="2614499"/>
+            <a:ext cx="7440063" cy="1629002"/>
+          </a:xfrm>
+          <a:prstGeom prst="rect">
+            <a:avLst/>
+          </a:prstGeom>
+        </p:spPr>
+      </p:pic>
     </p:spTree>
     <p:extLst>
       <p:ext uri="{BB962C8B-B14F-4D97-AF65-F5344CB8AC3E}">
@@ -5185,6 +5222,119 @@
 </p:sld>
 </file>
 
+<file path=ppt/slides/slide18.xml><?xml version="1.0" encoding="utf-8"?>
+<p:sld xmlns:a="http://schemas.openxmlformats.org/drawingml/2006/main" xmlns:r="http://schemas.openxmlformats.org/officeDocument/2006/relationships" xmlns:p="http://schemas.openxmlformats.org/presentationml/2006/main">
+  <p:cSld>
+    <p:spTree>
+      <p:nvGrpSpPr>
+        <p:cNvPr id="1" name="">
+          <a:extLst>
+            <a:ext uri="{FF2B5EF4-FFF2-40B4-BE49-F238E27FC236}">
+              <a16:creationId xmlns:a16="http://schemas.microsoft.com/office/drawing/2014/main" id="{1A4D7C09-3349-B120-B02A-54A092F0A972}"/>
+            </a:ext>
+          </a:extLst>
+        </p:cNvPr>
+        <p:cNvGrpSpPr/>
+        <p:nvPr/>
+      </p:nvGrpSpPr>
+      <p:grpSpPr>
+        <a:xfrm>
+          <a:off x="0" y="0"/>
+          <a:ext cx="0" cy="0"/>
+          <a:chOff x="0" y="0"/>
+          <a:chExt cx="0" cy="0"/>
+        </a:xfrm>
+      </p:grpSpPr>
+      <p:sp>
+        <p:nvSpPr>
+          <p:cNvPr id="4" name="TextBox 3">
+            <a:extLst>
+              <a:ext uri="{FF2B5EF4-FFF2-40B4-BE49-F238E27FC236}">
+                <a16:creationId xmlns:a16="http://schemas.microsoft.com/office/drawing/2014/main" id="{9692C91D-7962-950A-AE13-DE523156BDEB}"/>
+              </a:ext>
+            </a:extLst>
+          </p:cNvPr>
+          <p:cNvSpPr txBox="1"/>
+          <p:nvPr/>
+        </p:nvSpPr>
+        <p:spPr>
+          <a:xfrm>
+            <a:off x="67733" y="93133"/>
+            <a:ext cx="4451801" cy="400110"/>
+          </a:xfrm>
+          <a:prstGeom prst="rect">
+            <a:avLst/>
+          </a:prstGeom>
+          <a:noFill/>
+        </p:spPr>
+        <p:txBody>
+          <a:bodyPr wrap="square" rtlCol="0">
+            <a:spAutoFit/>
+          </a:bodyPr>
+          <a:lstStyle/>
+          <a:p>
+            <a:r>
+              <a:rPr lang="en-GB" sz="2000" b="1" dirty="0">
+                <a:latin typeface="Arial" panose="020B0604020202020204" pitchFamily="34" charset="0"/>
+                <a:cs typeface="Arial" panose="020B0604020202020204" pitchFamily="34" charset="0"/>
+              </a:rPr>
+              <a:t>Comparison Summary</a:t>
+            </a:r>
+          </a:p>
+        </p:txBody>
+      </p:sp>
+      <p:sp>
+        <p:nvSpPr>
+          <p:cNvPr id="2" name="TextBox 1">
+            <a:extLst>
+              <a:ext uri="{FF2B5EF4-FFF2-40B4-BE49-F238E27FC236}">
+                <a16:creationId xmlns:a16="http://schemas.microsoft.com/office/drawing/2014/main" id="{0CED31DA-9AE5-1B55-DA8F-7C85080ABB73}"/>
+              </a:ext>
+            </a:extLst>
+          </p:cNvPr>
+          <p:cNvSpPr txBox="1"/>
+          <p:nvPr/>
+        </p:nvSpPr>
+        <p:spPr>
+          <a:xfrm>
+            <a:off x="4294513" y="3176833"/>
+            <a:ext cx="3602974" cy="369332"/>
+          </a:xfrm>
+          <a:prstGeom prst="rect">
+            <a:avLst/>
+          </a:prstGeom>
+          <a:noFill/>
+        </p:spPr>
+        <p:txBody>
+          <a:bodyPr wrap="none" rtlCol="0">
+            <a:spAutoFit/>
+          </a:bodyPr>
+          <a:lstStyle/>
+          <a:p>
+            <a:r>
+              <a:rPr lang="en-GB" i="1" dirty="0">
+                <a:solidFill>
+                  <a:srgbClr val="FF0000"/>
+                </a:solidFill>
+              </a:rPr>
+              <a:t>INSERT EXCEL BAR CHARTS HERE </a:t>
+            </a:r>
+          </a:p>
+        </p:txBody>
+      </p:sp>
+    </p:spTree>
+    <p:extLst>
+      <p:ext uri="{BB962C8B-B14F-4D97-AF65-F5344CB8AC3E}">
+        <p14:creationId xmlns:p14="http://schemas.microsoft.com/office/powerpoint/2010/main" val="1406476318"/>
+      </p:ext>
+    </p:extLst>
+  </p:cSld>
+  <p:clrMapOvr>
+    <a:masterClrMapping/>
+  </p:clrMapOvr>
+</p:sld>
+</file>
+
 <file path=ppt/slides/slide2.xml><?xml version="1.0" encoding="utf-8"?>
 <p:sld xmlns:a="http://schemas.openxmlformats.org/drawingml/2006/main" xmlns:r="http://schemas.openxmlformats.org/officeDocument/2006/relationships" xmlns:p="http://schemas.openxmlformats.org/presentationml/2006/main">
   <p:cSld>
@@ -5341,7 +5491,7 @@
         <p:spPr>
           <a:xfrm>
             <a:off x="-76200" y="6363128"/>
-            <a:ext cx="2556933" cy="307777"/>
+            <a:ext cx="2781693" cy="523220"/>
           </a:xfrm>
           <a:prstGeom prst="rect">
             <a:avLst/>
@@ -5376,7 +5526,7 @@
                   <a:srgbClr val="FF0000"/>
                 </a:solidFill>
               </a:rPr>
-              <a:t> or 1x10</a:t>
+              <a:t> , 1x10</a:t>
             </a:r>
             <a:r>
               <a:rPr lang="en-GB" sz="1400" baseline="30000" dirty="0">
@@ -5385,6 +5535,22 @@
                 </a:solidFill>
               </a:rPr>
               <a:t>-5</a:t>
+            </a:r>
+            <a:r>
+              <a:rPr lang="en-GB" sz="1400" dirty="0">
+                <a:solidFill>
+                  <a:srgbClr val="FF0000"/>
+                </a:solidFill>
+              </a:rPr>
+              <a:t> , 1x10</a:t>
+            </a:r>
+            <a:r>
+              <a:rPr lang="en-GB" sz="1400" baseline="30000" dirty="0">
+                <a:solidFill>
+                  <a:srgbClr val="FF0000"/>
+                </a:solidFill>
+              </a:rPr>
+              <a:t>-6</a:t>
             </a:r>
           </a:p>
         </p:txBody>

</xml_diff>

<commit_message>
Implement Streamlit front-end for brain tumor classification and enhance model loading functionality
</commit_message>
<xml_diff>
--- a/dissemination/Brain Tumor Classification Model Comparisons.pptx
+++ b/dissemination/Brain Tumor Classification Model Comparisons.pptx
@@ -132,6 +132,4093 @@
 </p:presentation>
 </file>
 
+<file path=ppt/charts/chart1.xml><?xml version="1.0" encoding="utf-8"?>
+<c:chartSpace xmlns:c="http://schemas.openxmlformats.org/drawingml/2006/chart" xmlns:a="http://schemas.openxmlformats.org/drawingml/2006/main" xmlns:r="http://schemas.openxmlformats.org/officeDocument/2006/relationships" xmlns:c16r2="http://schemas.microsoft.com/office/drawing/2015/06/chart">
+  <c:date1904 val="0"/>
+  <c:lang val="en-US"/>
+  <c:roundedCorners val="0"/>
+  <mc:AlternateContent xmlns:mc="http://schemas.openxmlformats.org/markup-compatibility/2006">
+    <mc:Choice xmlns:c14="http://schemas.microsoft.com/office/drawing/2007/8/2/chart" Requires="c14">
+      <c14:style val="102"/>
+    </mc:Choice>
+    <mc:Fallback>
+      <c:style val="2"/>
+    </mc:Fallback>
+  </mc:AlternateContent>
+  <c:chart>
+    <c:title>
+      <c:tx>
+        <c:rich>
+          <a:bodyPr rot="0" spcFirstLastPara="1" vertOverflow="ellipsis" vert="horz" wrap="square" anchor="ctr" anchorCtr="1"/>
+          <a:lstStyle/>
+          <a:p>
+            <a:pPr>
+              <a:defRPr sz="1400" b="1" i="1" u="none" strike="noStrike" kern="1200" spc="0" baseline="0">
+                <a:solidFill>
+                  <a:schemeClr val="bg2">
+                    <a:lumMod val="25000"/>
+                  </a:schemeClr>
+                </a:solidFill>
+                <a:latin typeface="Arial" panose="020B0604020202020204" pitchFamily="34" charset="0"/>
+                <a:ea typeface="+mn-ea"/>
+                <a:cs typeface="Arial" panose="020B0604020202020204" pitchFamily="34" charset="0"/>
+              </a:defRPr>
+            </a:pPr>
+            <a:r>
+              <a:rPr lang="en-US" b="1" i="1" baseline="0">
+                <a:solidFill>
+                  <a:schemeClr val="bg2">
+                    <a:lumMod val="25000"/>
+                  </a:schemeClr>
+                </a:solidFill>
+              </a:rPr>
+              <a:t>ES + RLROP</a:t>
+            </a:r>
+            <a:endParaRPr lang="en-US" b="1" i="1" baseline="30000">
+              <a:solidFill>
+                <a:schemeClr val="bg2">
+                  <a:lumMod val="25000"/>
+                </a:schemeClr>
+              </a:solidFill>
+            </a:endParaRPr>
+          </a:p>
+        </c:rich>
+      </c:tx>
+      <c:overlay val="0"/>
+      <c:spPr>
+        <a:noFill/>
+        <a:ln>
+          <a:noFill/>
+        </a:ln>
+        <a:effectLst/>
+      </c:spPr>
+      <c:txPr>
+        <a:bodyPr rot="0" spcFirstLastPara="1" vertOverflow="ellipsis" vert="horz" wrap="square" anchor="ctr" anchorCtr="1"/>
+        <a:lstStyle/>
+        <a:p>
+          <a:pPr>
+            <a:defRPr sz="1400" b="1" i="1" u="none" strike="noStrike" kern="1200" spc="0" baseline="0">
+              <a:solidFill>
+                <a:schemeClr val="bg2">
+                  <a:lumMod val="25000"/>
+                </a:schemeClr>
+              </a:solidFill>
+              <a:latin typeface="Arial" panose="020B0604020202020204" pitchFamily="34" charset="0"/>
+              <a:ea typeface="+mn-ea"/>
+              <a:cs typeface="Arial" panose="020B0604020202020204" pitchFamily="34" charset="0"/>
+            </a:defRPr>
+          </a:pPr>
+          <a:endParaRPr lang="en-US"/>
+        </a:p>
+      </c:txPr>
+    </c:title>
+    <c:autoTitleDeleted val="0"/>
+    <c:plotArea>
+      <c:layout>
+        <c:manualLayout>
+          <c:layoutTarget val="inner"/>
+          <c:xMode val="edge"/>
+          <c:yMode val="edge"/>
+          <c:x val="0.10491983682762546"/>
+          <c:y val="0.12263267998961098"/>
+          <c:w val="0.87299180975871993"/>
+          <c:h val="0.73306160682593824"/>
+        </c:manualLayout>
+      </c:layout>
+      <c:barChart>
+        <c:barDir val="col"/>
+        <c:grouping val="clustered"/>
+        <c:varyColors val="0"/>
+        <c:ser>
+          <c:idx val="0"/>
+          <c:order val="0"/>
+          <c:tx>
+            <c:strRef>
+              <c:f>Comparisons!$E$19</c:f>
+              <c:strCache>
+                <c:ptCount val="1"/>
+                <c:pt idx="0">
+                  <c:v>F1-Score</c:v>
+                </c:pt>
+              </c:strCache>
+            </c:strRef>
+          </c:tx>
+          <c:spPr>
+            <a:solidFill>
+              <a:schemeClr val="bg2">
+                <a:lumMod val="25000"/>
+              </a:schemeClr>
+            </a:solidFill>
+            <a:ln>
+              <a:noFill/>
+            </a:ln>
+            <a:effectLst/>
+          </c:spPr>
+          <c:invertIfNegative val="0"/>
+          <c:dLbls>
+            <c:spPr>
+              <a:noFill/>
+              <a:ln>
+                <a:noFill/>
+              </a:ln>
+              <a:effectLst/>
+            </c:spPr>
+            <c:txPr>
+              <a:bodyPr rot="0" spcFirstLastPara="1" vertOverflow="ellipsis" vert="horz" wrap="square" anchor="ctr" anchorCtr="1"/>
+              <a:lstStyle/>
+              <a:p>
+                <a:pPr>
+                  <a:defRPr sz="900" b="1" i="1" u="none" strike="noStrike" kern="1200" baseline="0">
+                    <a:solidFill>
+                      <a:schemeClr val="bg2">
+                        <a:lumMod val="25000"/>
+                      </a:schemeClr>
+                    </a:solidFill>
+                    <a:latin typeface="Arial" panose="020B0604020202020204" pitchFamily="34" charset="0"/>
+                    <a:ea typeface="+mn-ea"/>
+                    <a:cs typeface="Arial" panose="020B0604020202020204" pitchFamily="34" charset="0"/>
+                  </a:defRPr>
+                </a:pPr>
+                <a:endParaRPr lang="en-US"/>
+              </a:p>
+            </c:txPr>
+            <c:dLblPos val="outEnd"/>
+            <c:showLegendKey val="0"/>
+            <c:showVal val="1"/>
+            <c:showCatName val="0"/>
+            <c:showSerName val="0"/>
+            <c:showPercent val="0"/>
+            <c:showBubbleSize val="0"/>
+            <c:showLeaderLines val="0"/>
+            <c:extLst>
+              <c:ext xmlns:c15="http://schemas.microsoft.com/office/drawing/2012/chart" uri="{CE6537A1-D6FC-4f65-9D91-7224C49458BB}">
+                <c15:showLeaderLines val="1"/>
+                <c15:leaderLines>
+                  <c:spPr>
+                    <a:ln w="9525" cap="flat" cmpd="sng" algn="ctr">
+                      <a:solidFill>
+                        <a:schemeClr val="tx1">
+                          <a:lumMod val="35000"/>
+                          <a:lumOff val="65000"/>
+                        </a:schemeClr>
+                      </a:solidFill>
+                      <a:round/>
+                    </a:ln>
+                    <a:effectLst/>
+                  </c:spPr>
+                </c15:leaderLines>
+              </c:ext>
+            </c:extLst>
+          </c:dLbls>
+          <c:cat>
+            <c:strRef>
+              <c:f>Comparisons!$D$20:$D$21</c:f>
+              <c:strCache>
+                <c:ptCount val="2"/>
+                <c:pt idx="0">
+                  <c:v>RLROP</c:v>
+                </c:pt>
+                <c:pt idx="1">
+                  <c:v>RLROP + ES</c:v>
+                </c:pt>
+              </c:strCache>
+            </c:strRef>
+          </c:cat>
+          <c:val>
+            <c:numRef>
+              <c:f>Comparisons!$E$20:$E$21</c:f>
+              <c:numCache>
+                <c:formatCode>General</c:formatCode>
+                <c:ptCount val="2"/>
+                <c:pt idx="0">
+                  <c:v>0.9</c:v>
+                </c:pt>
+                <c:pt idx="1">
+                  <c:v>0.89</c:v>
+                </c:pt>
+              </c:numCache>
+            </c:numRef>
+          </c:val>
+          <c:extLst>
+            <c:ext xmlns:c16="http://schemas.microsoft.com/office/drawing/2014/chart" uri="{C3380CC4-5D6E-409C-BE32-E72D297353CC}">
+              <c16:uniqueId val="{00000000-4A44-4F8B-A459-260708811244}"/>
+            </c:ext>
+          </c:extLst>
+        </c:ser>
+        <c:dLbls>
+          <c:dLblPos val="outEnd"/>
+          <c:showLegendKey val="0"/>
+          <c:showVal val="1"/>
+          <c:showCatName val="0"/>
+          <c:showSerName val="0"/>
+          <c:showPercent val="0"/>
+          <c:showBubbleSize val="0"/>
+        </c:dLbls>
+        <c:gapWidth val="219"/>
+        <c:overlap val="-27"/>
+        <c:axId val="1892425040"/>
+        <c:axId val="1892420240"/>
+      </c:barChart>
+      <c:catAx>
+        <c:axId val="1892425040"/>
+        <c:scaling>
+          <c:orientation val="minMax"/>
+        </c:scaling>
+        <c:delete val="0"/>
+        <c:axPos val="b"/>
+        <c:numFmt formatCode="General" sourceLinked="1"/>
+        <c:majorTickMark val="none"/>
+        <c:minorTickMark val="none"/>
+        <c:tickLblPos val="nextTo"/>
+        <c:spPr>
+          <a:noFill/>
+          <a:ln w="9525" cap="flat" cmpd="sng" algn="ctr">
+            <a:solidFill>
+              <a:schemeClr val="tx1">
+                <a:lumMod val="15000"/>
+                <a:lumOff val="85000"/>
+              </a:schemeClr>
+            </a:solidFill>
+            <a:round/>
+          </a:ln>
+          <a:effectLst/>
+        </c:spPr>
+        <c:txPr>
+          <a:bodyPr rot="-60000000" spcFirstLastPara="1" vertOverflow="ellipsis" vert="horz" wrap="square" anchor="ctr" anchorCtr="1"/>
+          <a:lstStyle/>
+          <a:p>
+            <a:pPr>
+              <a:defRPr sz="900" b="0" i="0" u="none" strike="noStrike" kern="1200" baseline="0">
+                <a:solidFill>
+                  <a:schemeClr val="tx1">
+                    <a:lumMod val="65000"/>
+                    <a:lumOff val="35000"/>
+                  </a:schemeClr>
+                </a:solidFill>
+                <a:latin typeface="Arial" panose="020B0604020202020204" pitchFamily="34" charset="0"/>
+                <a:ea typeface="+mn-ea"/>
+                <a:cs typeface="Arial" panose="020B0604020202020204" pitchFamily="34" charset="0"/>
+              </a:defRPr>
+            </a:pPr>
+            <a:endParaRPr lang="en-US"/>
+          </a:p>
+        </c:txPr>
+        <c:crossAx val="1892420240"/>
+        <c:crosses val="autoZero"/>
+        <c:auto val="1"/>
+        <c:lblAlgn val="ctr"/>
+        <c:lblOffset val="100"/>
+        <c:noMultiLvlLbl val="0"/>
+      </c:catAx>
+      <c:valAx>
+        <c:axId val="1892420240"/>
+        <c:scaling>
+          <c:orientation val="minMax"/>
+          <c:max val="1"/>
+          <c:min val="0"/>
+        </c:scaling>
+        <c:delete val="0"/>
+        <c:axPos val="l"/>
+        <c:title>
+          <c:tx>
+            <c:rich>
+              <a:bodyPr rot="-5400000" spcFirstLastPara="1" vertOverflow="ellipsis" vert="horz" wrap="square" anchor="ctr" anchorCtr="1"/>
+              <a:lstStyle/>
+              <a:p>
+                <a:pPr>
+                  <a:defRPr sz="1000" b="1" i="0" u="none" strike="noStrike" kern="1200" baseline="0">
+                    <a:solidFill>
+                      <a:schemeClr val="tx1">
+                        <a:lumMod val="65000"/>
+                        <a:lumOff val="35000"/>
+                      </a:schemeClr>
+                    </a:solidFill>
+                    <a:latin typeface="Arial" panose="020B0604020202020204" pitchFamily="34" charset="0"/>
+                    <a:ea typeface="+mn-ea"/>
+                    <a:cs typeface="Arial" panose="020B0604020202020204" pitchFamily="34" charset="0"/>
+                  </a:defRPr>
+                </a:pPr>
+                <a:r>
+                  <a:rPr lang="en-GB" b="1"/>
+                  <a:t>F1-Score</a:t>
+                </a:r>
+              </a:p>
+            </c:rich>
+          </c:tx>
+          <c:layout>
+            <c:manualLayout>
+              <c:xMode val="edge"/>
+              <c:yMode val="edge"/>
+              <c:x val="2.1876740216860445E-2"/>
+              <c:y val="0.39214425435655359"/>
+            </c:manualLayout>
+          </c:layout>
+          <c:overlay val="0"/>
+          <c:spPr>
+            <a:noFill/>
+            <a:ln>
+              <a:noFill/>
+            </a:ln>
+            <a:effectLst/>
+          </c:spPr>
+          <c:txPr>
+            <a:bodyPr rot="-5400000" spcFirstLastPara="1" vertOverflow="ellipsis" vert="horz" wrap="square" anchor="ctr" anchorCtr="1"/>
+            <a:lstStyle/>
+            <a:p>
+              <a:pPr>
+                <a:defRPr sz="1000" b="1" i="0" u="none" strike="noStrike" kern="1200" baseline="0">
+                  <a:solidFill>
+                    <a:schemeClr val="tx1">
+                      <a:lumMod val="65000"/>
+                      <a:lumOff val="35000"/>
+                    </a:schemeClr>
+                  </a:solidFill>
+                  <a:latin typeface="Arial" panose="020B0604020202020204" pitchFamily="34" charset="0"/>
+                  <a:ea typeface="+mn-ea"/>
+                  <a:cs typeface="Arial" panose="020B0604020202020204" pitchFamily="34" charset="0"/>
+                </a:defRPr>
+              </a:pPr>
+              <a:endParaRPr lang="en-US"/>
+            </a:p>
+          </c:txPr>
+        </c:title>
+        <c:numFmt formatCode="General" sourceLinked="1"/>
+        <c:majorTickMark val="none"/>
+        <c:minorTickMark val="none"/>
+        <c:tickLblPos val="nextTo"/>
+        <c:spPr>
+          <a:noFill/>
+          <a:ln>
+            <a:noFill/>
+          </a:ln>
+          <a:effectLst/>
+        </c:spPr>
+        <c:txPr>
+          <a:bodyPr rot="-60000000" spcFirstLastPara="1" vertOverflow="ellipsis" vert="horz" wrap="square" anchor="ctr" anchorCtr="1"/>
+          <a:lstStyle/>
+          <a:p>
+            <a:pPr>
+              <a:defRPr sz="900" b="0" i="0" u="none" strike="noStrike" kern="1200" baseline="0">
+                <a:solidFill>
+                  <a:schemeClr val="tx1">
+                    <a:lumMod val="65000"/>
+                    <a:lumOff val="35000"/>
+                  </a:schemeClr>
+                </a:solidFill>
+                <a:latin typeface="Arial" panose="020B0604020202020204" pitchFamily="34" charset="0"/>
+                <a:ea typeface="+mn-ea"/>
+                <a:cs typeface="Arial" panose="020B0604020202020204" pitchFamily="34" charset="0"/>
+              </a:defRPr>
+            </a:pPr>
+            <a:endParaRPr lang="en-US"/>
+          </a:p>
+        </c:txPr>
+        <c:crossAx val="1892425040"/>
+        <c:crosses val="autoZero"/>
+        <c:crossBetween val="between"/>
+      </c:valAx>
+      <c:spPr>
+        <a:noFill/>
+        <a:ln>
+          <a:noFill/>
+        </a:ln>
+        <a:effectLst/>
+      </c:spPr>
+    </c:plotArea>
+    <c:plotVisOnly val="1"/>
+    <c:dispBlanksAs val="gap"/>
+    <c:showDLblsOverMax val="0"/>
+    <c:extLst>
+      <c:ext xmlns:c16r3="http://schemas.microsoft.com/office/drawing/2017/03/chart" uri="{56B9EC1D-385E-4148-901F-78D8002777C0}">
+        <c16r3:dataDisplayOptions16>
+          <c16r3:dispNaAsBlank val="1"/>
+        </c16r3:dataDisplayOptions16>
+      </c:ext>
+    </c:extLst>
+  </c:chart>
+  <c:spPr>
+    <a:noFill/>
+    <a:ln>
+      <a:noFill/>
+    </a:ln>
+    <a:effectLst/>
+  </c:spPr>
+  <c:txPr>
+    <a:bodyPr/>
+    <a:lstStyle/>
+    <a:p>
+      <a:pPr>
+        <a:defRPr>
+          <a:latin typeface="Arial" panose="020B0604020202020204" pitchFamily="34" charset="0"/>
+          <a:cs typeface="Arial" panose="020B0604020202020204" pitchFamily="34" charset="0"/>
+        </a:defRPr>
+      </a:pPr>
+      <a:endParaRPr lang="en-US"/>
+    </a:p>
+  </c:txPr>
+  <c:externalData r:id="rId3">
+    <c:autoUpdate val="0"/>
+  </c:externalData>
+</c:chartSpace>
+</file>
+
+<file path=ppt/charts/chart2.xml><?xml version="1.0" encoding="utf-8"?>
+<c:chartSpace xmlns:c="http://schemas.openxmlformats.org/drawingml/2006/chart" xmlns:a="http://schemas.openxmlformats.org/drawingml/2006/main" xmlns:r="http://schemas.openxmlformats.org/officeDocument/2006/relationships" xmlns:c16r2="http://schemas.microsoft.com/office/drawing/2015/06/chart">
+  <c:date1904 val="0"/>
+  <c:lang val="en-US"/>
+  <c:roundedCorners val="0"/>
+  <mc:AlternateContent xmlns:mc="http://schemas.openxmlformats.org/markup-compatibility/2006">
+    <mc:Choice xmlns:c14="http://schemas.microsoft.com/office/drawing/2007/8/2/chart" Requires="c14">
+      <c14:style val="102"/>
+    </mc:Choice>
+    <mc:Fallback>
+      <c:style val="2"/>
+    </mc:Fallback>
+  </mc:AlternateContent>
+  <c:chart>
+    <c:title>
+      <c:tx>
+        <c:rich>
+          <a:bodyPr rot="0" spcFirstLastPara="1" vertOverflow="ellipsis" vert="horz" wrap="square" anchor="ctr" anchorCtr="1"/>
+          <a:lstStyle/>
+          <a:p>
+            <a:pPr>
+              <a:defRPr sz="1400" b="1" i="1" u="none" strike="noStrike" kern="1200" spc="0" baseline="0">
+                <a:solidFill>
+                  <a:srgbClr val="FF0000"/>
+                </a:solidFill>
+                <a:latin typeface="Arial" panose="020B0604020202020204" pitchFamily="34" charset="0"/>
+                <a:ea typeface="+mn-ea"/>
+                <a:cs typeface="Arial" panose="020B0604020202020204" pitchFamily="34" charset="0"/>
+              </a:defRPr>
+            </a:pPr>
+            <a:r>
+              <a:rPr lang="en-US" b="1" i="1">
+                <a:solidFill>
+                  <a:srgbClr val="FF0000"/>
+                </a:solidFill>
+              </a:rPr>
+              <a:t>LR = 1x10</a:t>
+            </a:r>
+            <a:r>
+              <a:rPr lang="en-US" b="1" i="1" baseline="30000">
+                <a:solidFill>
+                  <a:srgbClr val="FF0000"/>
+                </a:solidFill>
+              </a:rPr>
+              <a:t>-4</a:t>
+            </a:r>
+          </a:p>
+        </c:rich>
+      </c:tx>
+      <c:overlay val="0"/>
+      <c:spPr>
+        <a:noFill/>
+        <a:ln>
+          <a:noFill/>
+        </a:ln>
+        <a:effectLst/>
+      </c:spPr>
+      <c:txPr>
+        <a:bodyPr rot="0" spcFirstLastPara="1" vertOverflow="ellipsis" vert="horz" wrap="square" anchor="ctr" anchorCtr="1"/>
+        <a:lstStyle/>
+        <a:p>
+          <a:pPr>
+            <a:defRPr sz="1400" b="1" i="1" u="none" strike="noStrike" kern="1200" spc="0" baseline="0">
+              <a:solidFill>
+                <a:srgbClr val="FF0000"/>
+              </a:solidFill>
+              <a:latin typeface="Arial" panose="020B0604020202020204" pitchFamily="34" charset="0"/>
+              <a:ea typeface="+mn-ea"/>
+              <a:cs typeface="Arial" panose="020B0604020202020204" pitchFamily="34" charset="0"/>
+            </a:defRPr>
+          </a:pPr>
+          <a:endParaRPr lang="en-US"/>
+        </a:p>
+      </c:txPr>
+    </c:title>
+    <c:autoTitleDeleted val="0"/>
+    <c:plotArea>
+      <c:layout>
+        <c:manualLayout>
+          <c:layoutTarget val="inner"/>
+          <c:xMode val="edge"/>
+          <c:yMode val="edge"/>
+          <c:x val="0.10491983682762546"/>
+          <c:y val="0.12263267998961098"/>
+          <c:w val="0.87299180975871993"/>
+          <c:h val="0.73306160682593824"/>
+        </c:manualLayout>
+      </c:layout>
+      <c:barChart>
+        <c:barDir val="col"/>
+        <c:grouping val="clustered"/>
+        <c:varyColors val="0"/>
+        <c:ser>
+          <c:idx val="0"/>
+          <c:order val="0"/>
+          <c:tx>
+            <c:strRef>
+              <c:f>Comparisons!$E$6</c:f>
+              <c:strCache>
+                <c:ptCount val="1"/>
+                <c:pt idx="0">
+                  <c:v>F1-Score</c:v>
+                </c:pt>
+              </c:strCache>
+            </c:strRef>
+          </c:tx>
+          <c:spPr>
+            <a:solidFill>
+              <a:srgbClr val="FF0000"/>
+            </a:solidFill>
+            <a:ln>
+              <a:noFill/>
+            </a:ln>
+            <a:effectLst/>
+          </c:spPr>
+          <c:invertIfNegative val="0"/>
+          <c:dLbls>
+            <c:spPr>
+              <a:noFill/>
+              <a:ln>
+                <a:noFill/>
+              </a:ln>
+              <a:effectLst/>
+            </c:spPr>
+            <c:txPr>
+              <a:bodyPr rot="0" spcFirstLastPara="1" vertOverflow="ellipsis" vert="horz" wrap="square" anchor="ctr" anchorCtr="1"/>
+              <a:lstStyle/>
+              <a:p>
+                <a:pPr>
+                  <a:defRPr sz="900" b="1" i="1" u="none" strike="noStrike" kern="1200" baseline="0">
+                    <a:solidFill>
+                      <a:srgbClr val="FF0000"/>
+                    </a:solidFill>
+                    <a:latin typeface="Arial" panose="020B0604020202020204" pitchFamily="34" charset="0"/>
+                    <a:ea typeface="+mn-ea"/>
+                    <a:cs typeface="Arial" panose="020B0604020202020204" pitchFamily="34" charset="0"/>
+                  </a:defRPr>
+                </a:pPr>
+                <a:endParaRPr lang="en-US"/>
+              </a:p>
+            </c:txPr>
+            <c:dLblPos val="outEnd"/>
+            <c:showLegendKey val="0"/>
+            <c:showVal val="1"/>
+            <c:showCatName val="0"/>
+            <c:showSerName val="0"/>
+            <c:showPercent val="0"/>
+            <c:showBubbleSize val="0"/>
+            <c:showLeaderLines val="0"/>
+            <c:extLst>
+              <c:ext xmlns:c15="http://schemas.microsoft.com/office/drawing/2012/chart" uri="{CE6537A1-D6FC-4f65-9D91-7224C49458BB}">
+                <c15:showLeaderLines val="1"/>
+                <c15:leaderLines>
+                  <c:spPr>
+                    <a:ln w="9525" cap="flat" cmpd="sng" algn="ctr">
+                      <a:solidFill>
+                        <a:schemeClr val="tx1">
+                          <a:lumMod val="35000"/>
+                          <a:lumOff val="65000"/>
+                        </a:schemeClr>
+                      </a:solidFill>
+                      <a:round/>
+                    </a:ln>
+                    <a:effectLst/>
+                  </c:spPr>
+                </c15:leaderLines>
+              </c:ext>
+            </c:extLst>
+          </c:dLbls>
+          <c:cat>
+            <c:numRef>
+              <c:f>Comparisons!$D$7:$D$11</c:f>
+              <c:numCache>
+                <c:formatCode>General</c:formatCode>
+                <c:ptCount val="5"/>
+                <c:pt idx="0">
+                  <c:v>10</c:v>
+                </c:pt>
+                <c:pt idx="1">
+                  <c:v>30</c:v>
+                </c:pt>
+                <c:pt idx="2">
+                  <c:v>45</c:v>
+                </c:pt>
+                <c:pt idx="3">
+                  <c:v>60</c:v>
+                </c:pt>
+                <c:pt idx="4">
+                  <c:v>100</c:v>
+                </c:pt>
+              </c:numCache>
+            </c:numRef>
+          </c:cat>
+          <c:val>
+            <c:numRef>
+              <c:f>Comparisons!$E$7:$E$11</c:f>
+              <c:numCache>
+                <c:formatCode>General</c:formatCode>
+                <c:ptCount val="5"/>
+                <c:pt idx="0">
+                  <c:v>0.55000000000000004</c:v>
+                </c:pt>
+                <c:pt idx="1">
+                  <c:v>0.89</c:v>
+                </c:pt>
+                <c:pt idx="2">
+                  <c:v>0.89</c:v>
+                </c:pt>
+                <c:pt idx="3">
+                  <c:v>0.88</c:v>
+                </c:pt>
+                <c:pt idx="4">
+                  <c:v>0.91</c:v>
+                </c:pt>
+              </c:numCache>
+            </c:numRef>
+          </c:val>
+          <c:extLst>
+            <c:ext xmlns:c16="http://schemas.microsoft.com/office/drawing/2014/chart" uri="{C3380CC4-5D6E-409C-BE32-E72D297353CC}">
+              <c16:uniqueId val="{00000000-D554-47F4-9F70-27718DBCFF75}"/>
+            </c:ext>
+          </c:extLst>
+        </c:ser>
+        <c:dLbls>
+          <c:dLblPos val="outEnd"/>
+          <c:showLegendKey val="0"/>
+          <c:showVal val="1"/>
+          <c:showCatName val="0"/>
+          <c:showSerName val="0"/>
+          <c:showPercent val="0"/>
+          <c:showBubbleSize val="0"/>
+        </c:dLbls>
+        <c:gapWidth val="219"/>
+        <c:overlap val="-27"/>
+        <c:axId val="1892425040"/>
+        <c:axId val="1892420240"/>
+      </c:barChart>
+      <c:catAx>
+        <c:axId val="1892425040"/>
+        <c:scaling>
+          <c:orientation val="minMax"/>
+        </c:scaling>
+        <c:delete val="0"/>
+        <c:axPos val="b"/>
+        <c:title>
+          <c:tx>
+            <c:rich>
+              <a:bodyPr rot="0" spcFirstLastPara="1" vertOverflow="ellipsis" vert="horz" wrap="square" anchor="ctr" anchorCtr="1"/>
+              <a:lstStyle/>
+              <a:p>
+                <a:pPr>
+                  <a:defRPr sz="1000" b="1" i="0" u="none" strike="noStrike" kern="1200" baseline="0">
+                    <a:solidFill>
+                      <a:schemeClr val="tx1">
+                        <a:lumMod val="65000"/>
+                        <a:lumOff val="35000"/>
+                      </a:schemeClr>
+                    </a:solidFill>
+                    <a:latin typeface="Arial" panose="020B0604020202020204" pitchFamily="34" charset="0"/>
+                    <a:ea typeface="+mn-ea"/>
+                    <a:cs typeface="Arial" panose="020B0604020202020204" pitchFamily="34" charset="0"/>
+                  </a:defRPr>
+                </a:pPr>
+                <a:r>
+                  <a:rPr lang="en-GB" b="1"/>
+                  <a:t>Epoch Size</a:t>
+                </a:r>
+              </a:p>
+            </c:rich>
+          </c:tx>
+          <c:overlay val="0"/>
+          <c:spPr>
+            <a:noFill/>
+            <a:ln>
+              <a:noFill/>
+            </a:ln>
+            <a:effectLst/>
+          </c:spPr>
+          <c:txPr>
+            <a:bodyPr rot="0" spcFirstLastPara="1" vertOverflow="ellipsis" vert="horz" wrap="square" anchor="ctr" anchorCtr="1"/>
+            <a:lstStyle/>
+            <a:p>
+              <a:pPr>
+                <a:defRPr sz="1000" b="1" i="0" u="none" strike="noStrike" kern="1200" baseline="0">
+                  <a:solidFill>
+                    <a:schemeClr val="tx1">
+                      <a:lumMod val="65000"/>
+                      <a:lumOff val="35000"/>
+                    </a:schemeClr>
+                  </a:solidFill>
+                  <a:latin typeface="Arial" panose="020B0604020202020204" pitchFamily="34" charset="0"/>
+                  <a:ea typeface="+mn-ea"/>
+                  <a:cs typeface="Arial" panose="020B0604020202020204" pitchFamily="34" charset="0"/>
+                </a:defRPr>
+              </a:pPr>
+              <a:endParaRPr lang="en-US"/>
+            </a:p>
+          </c:txPr>
+        </c:title>
+        <c:numFmt formatCode="General" sourceLinked="1"/>
+        <c:majorTickMark val="none"/>
+        <c:minorTickMark val="none"/>
+        <c:tickLblPos val="nextTo"/>
+        <c:spPr>
+          <a:noFill/>
+          <a:ln w="9525" cap="flat" cmpd="sng" algn="ctr">
+            <a:solidFill>
+              <a:schemeClr val="tx1">
+                <a:lumMod val="15000"/>
+                <a:lumOff val="85000"/>
+              </a:schemeClr>
+            </a:solidFill>
+            <a:round/>
+          </a:ln>
+          <a:effectLst/>
+        </c:spPr>
+        <c:txPr>
+          <a:bodyPr rot="-60000000" spcFirstLastPara="1" vertOverflow="ellipsis" vert="horz" wrap="square" anchor="ctr" anchorCtr="1"/>
+          <a:lstStyle/>
+          <a:p>
+            <a:pPr>
+              <a:defRPr sz="900" b="0" i="0" u="none" strike="noStrike" kern="1200" baseline="0">
+                <a:solidFill>
+                  <a:schemeClr val="tx1">
+                    <a:lumMod val="65000"/>
+                    <a:lumOff val="35000"/>
+                  </a:schemeClr>
+                </a:solidFill>
+                <a:latin typeface="Arial" panose="020B0604020202020204" pitchFamily="34" charset="0"/>
+                <a:ea typeface="+mn-ea"/>
+                <a:cs typeface="Arial" panose="020B0604020202020204" pitchFamily="34" charset="0"/>
+              </a:defRPr>
+            </a:pPr>
+            <a:endParaRPr lang="en-US"/>
+          </a:p>
+        </c:txPr>
+        <c:crossAx val="1892420240"/>
+        <c:crosses val="autoZero"/>
+        <c:auto val="1"/>
+        <c:lblAlgn val="ctr"/>
+        <c:lblOffset val="100"/>
+        <c:noMultiLvlLbl val="0"/>
+      </c:catAx>
+      <c:valAx>
+        <c:axId val="1892420240"/>
+        <c:scaling>
+          <c:orientation val="minMax"/>
+        </c:scaling>
+        <c:delete val="0"/>
+        <c:axPos val="l"/>
+        <c:title>
+          <c:tx>
+            <c:rich>
+              <a:bodyPr rot="-5400000" spcFirstLastPara="1" vertOverflow="ellipsis" vert="horz" wrap="square" anchor="ctr" anchorCtr="1"/>
+              <a:lstStyle/>
+              <a:p>
+                <a:pPr>
+                  <a:defRPr sz="1000" b="1" i="0" u="none" strike="noStrike" kern="1200" baseline="0">
+                    <a:solidFill>
+                      <a:schemeClr val="tx1">
+                        <a:lumMod val="65000"/>
+                        <a:lumOff val="35000"/>
+                      </a:schemeClr>
+                    </a:solidFill>
+                    <a:latin typeface="Arial" panose="020B0604020202020204" pitchFamily="34" charset="0"/>
+                    <a:ea typeface="+mn-ea"/>
+                    <a:cs typeface="Arial" panose="020B0604020202020204" pitchFamily="34" charset="0"/>
+                  </a:defRPr>
+                </a:pPr>
+                <a:r>
+                  <a:rPr lang="en-GB" b="1"/>
+                  <a:t>F1-Score</a:t>
+                </a:r>
+              </a:p>
+            </c:rich>
+          </c:tx>
+          <c:layout>
+            <c:manualLayout>
+              <c:xMode val="edge"/>
+              <c:yMode val="edge"/>
+              <c:x val="2.1876740216860445E-2"/>
+              <c:y val="0.39214425435655359"/>
+            </c:manualLayout>
+          </c:layout>
+          <c:overlay val="0"/>
+          <c:spPr>
+            <a:noFill/>
+            <a:ln>
+              <a:noFill/>
+            </a:ln>
+            <a:effectLst/>
+          </c:spPr>
+          <c:txPr>
+            <a:bodyPr rot="-5400000" spcFirstLastPara="1" vertOverflow="ellipsis" vert="horz" wrap="square" anchor="ctr" anchorCtr="1"/>
+            <a:lstStyle/>
+            <a:p>
+              <a:pPr>
+                <a:defRPr sz="1000" b="1" i="0" u="none" strike="noStrike" kern="1200" baseline="0">
+                  <a:solidFill>
+                    <a:schemeClr val="tx1">
+                      <a:lumMod val="65000"/>
+                      <a:lumOff val="35000"/>
+                    </a:schemeClr>
+                  </a:solidFill>
+                  <a:latin typeface="Arial" panose="020B0604020202020204" pitchFamily="34" charset="0"/>
+                  <a:ea typeface="+mn-ea"/>
+                  <a:cs typeface="Arial" panose="020B0604020202020204" pitchFamily="34" charset="0"/>
+                </a:defRPr>
+              </a:pPr>
+              <a:endParaRPr lang="en-US"/>
+            </a:p>
+          </c:txPr>
+        </c:title>
+        <c:numFmt formatCode="General" sourceLinked="1"/>
+        <c:majorTickMark val="none"/>
+        <c:minorTickMark val="none"/>
+        <c:tickLblPos val="nextTo"/>
+        <c:spPr>
+          <a:noFill/>
+          <a:ln>
+            <a:noFill/>
+          </a:ln>
+          <a:effectLst/>
+        </c:spPr>
+        <c:txPr>
+          <a:bodyPr rot="-60000000" spcFirstLastPara="1" vertOverflow="ellipsis" vert="horz" wrap="square" anchor="ctr" anchorCtr="1"/>
+          <a:lstStyle/>
+          <a:p>
+            <a:pPr>
+              <a:defRPr sz="900" b="0" i="0" u="none" strike="noStrike" kern="1200" baseline="0">
+                <a:solidFill>
+                  <a:schemeClr val="tx1">
+                    <a:lumMod val="65000"/>
+                    <a:lumOff val="35000"/>
+                  </a:schemeClr>
+                </a:solidFill>
+                <a:latin typeface="Arial" panose="020B0604020202020204" pitchFamily="34" charset="0"/>
+                <a:ea typeface="+mn-ea"/>
+                <a:cs typeface="Arial" panose="020B0604020202020204" pitchFamily="34" charset="0"/>
+              </a:defRPr>
+            </a:pPr>
+            <a:endParaRPr lang="en-US"/>
+          </a:p>
+        </c:txPr>
+        <c:crossAx val="1892425040"/>
+        <c:crosses val="autoZero"/>
+        <c:crossBetween val="between"/>
+      </c:valAx>
+      <c:spPr>
+        <a:noFill/>
+        <a:ln>
+          <a:noFill/>
+        </a:ln>
+        <a:effectLst/>
+      </c:spPr>
+    </c:plotArea>
+    <c:plotVisOnly val="1"/>
+    <c:dispBlanksAs val="gap"/>
+    <c:showDLblsOverMax val="0"/>
+    <c:extLst>
+      <c:ext xmlns:c16r3="http://schemas.microsoft.com/office/drawing/2017/03/chart" uri="{56B9EC1D-385E-4148-901F-78D8002777C0}">
+        <c16r3:dataDisplayOptions16>
+          <c16r3:dispNaAsBlank val="1"/>
+        </c16r3:dataDisplayOptions16>
+      </c:ext>
+    </c:extLst>
+  </c:chart>
+  <c:spPr>
+    <a:noFill/>
+    <a:ln>
+      <a:noFill/>
+    </a:ln>
+    <a:effectLst/>
+  </c:spPr>
+  <c:txPr>
+    <a:bodyPr/>
+    <a:lstStyle/>
+    <a:p>
+      <a:pPr>
+        <a:defRPr>
+          <a:latin typeface="Arial" panose="020B0604020202020204" pitchFamily="34" charset="0"/>
+          <a:cs typeface="Arial" panose="020B0604020202020204" pitchFamily="34" charset="0"/>
+        </a:defRPr>
+      </a:pPr>
+      <a:endParaRPr lang="en-US"/>
+    </a:p>
+  </c:txPr>
+  <c:externalData r:id="rId3">
+    <c:autoUpdate val="0"/>
+  </c:externalData>
+</c:chartSpace>
+</file>
+
+<file path=ppt/charts/chart3.xml><?xml version="1.0" encoding="utf-8"?>
+<c:chartSpace xmlns:c="http://schemas.openxmlformats.org/drawingml/2006/chart" xmlns:a="http://schemas.openxmlformats.org/drawingml/2006/main" xmlns:r="http://schemas.openxmlformats.org/officeDocument/2006/relationships" xmlns:c16r2="http://schemas.microsoft.com/office/drawing/2015/06/chart">
+  <c:date1904 val="0"/>
+  <c:lang val="en-US"/>
+  <c:roundedCorners val="0"/>
+  <mc:AlternateContent xmlns:mc="http://schemas.openxmlformats.org/markup-compatibility/2006">
+    <mc:Choice xmlns:c14="http://schemas.microsoft.com/office/drawing/2007/8/2/chart" Requires="c14">
+      <c14:style val="102"/>
+    </mc:Choice>
+    <mc:Fallback>
+      <c:style val="2"/>
+    </mc:Fallback>
+  </mc:AlternateContent>
+  <c:chart>
+    <c:title>
+      <c:tx>
+        <c:rich>
+          <a:bodyPr rot="0" spcFirstLastPara="1" vertOverflow="ellipsis" vert="horz" wrap="square" anchor="ctr" anchorCtr="1"/>
+          <a:lstStyle/>
+          <a:p>
+            <a:pPr>
+              <a:defRPr sz="1400" b="1" i="1" u="none" strike="noStrike" kern="1200" spc="0" baseline="0">
+                <a:solidFill>
+                  <a:srgbClr val="00B050"/>
+                </a:solidFill>
+                <a:latin typeface="Arial" panose="020B0604020202020204" pitchFamily="34" charset="0"/>
+                <a:ea typeface="+mn-ea"/>
+                <a:cs typeface="Arial" panose="020B0604020202020204" pitchFamily="34" charset="0"/>
+              </a:defRPr>
+            </a:pPr>
+            <a:r>
+              <a:rPr lang="en-US" b="1" i="1">
+                <a:solidFill>
+                  <a:srgbClr val="00B050"/>
+                </a:solidFill>
+              </a:rPr>
+              <a:t>LR = 1x10</a:t>
+            </a:r>
+            <a:r>
+              <a:rPr lang="en-US" b="1" i="1" baseline="30000">
+                <a:solidFill>
+                  <a:srgbClr val="00B050"/>
+                </a:solidFill>
+              </a:rPr>
+              <a:t>-5</a:t>
+            </a:r>
+          </a:p>
+        </c:rich>
+      </c:tx>
+      <c:overlay val="0"/>
+      <c:spPr>
+        <a:noFill/>
+        <a:ln>
+          <a:noFill/>
+        </a:ln>
+        <a:effectLst/>
+      </c:spPr>
+      <c:txPr>
+        <a:bodyPr rot="0" spcFirstLastPara="1" vertOverflow="ellipsis" vert="horz" wrap="square" anchor="ctr" anchorCtr="1"/>
+        <a:lstStyle/>
+        <a:p>
+          <a:pPr>
+            <a:defRPr sz="1400" b="1" i="1" u="none" strike="noStrike" kern="1200" spc="0" baseline="0">
+              <a:solidFill>
+                <a:srgbClr val="00B050"/>
+              </a:solidFill>
+              <a:latin typeface="Arial" panose="020B0604020202020204" pitchFamily="34" charset="0"/>
+              <a:ea typeface="+mn-ea"/>
+              <a:cs typeface="Arial" panose="020B0604020202020204" pitchFamily="34" charset="0"/>
+            </a:defRPr>
+          </a:pPr>
+          <a:endParaRPr lang="en-US"/>
+        </a:p>
+      </c:txPr>
+    </c:title>
+    <c:autoTitleDeleted val="0"/>
+    <c:plotArea>
+      <c:layout>
+        <c:manualLayout>
+          <c:layoutTarget val="inner"/>
+          <c:xMode val="edge"/>
+          <c:yMode val="edge"/>
+          <c:x val="0.10491983682762546"/>
+          <c:y val="0.12263267998961098"/>
+          <c:w val="0.87299180975871993"/>
+          <c:h val="0.73306160682593824"/>
+        </c:manualLayout>
+      </c:layout>
+      <c:barChart>
+        <c:barDir val="col"/>
+        <c:grouping val="clustered"/>
+        <c:varyColors val="0"/>
+        <c:ser>
+          <c:idx val="0"/>
+          <c:order val="0"/>
+          <c:tx>
+            <c:strRef>
+              <c:f>Comparisons!$H$6</c:f>
+              <c:strCache>
+                <c:ptCount val="1"/>
+                <c:pt idx="0">
+                  <c:v>F1-Score</c:v>
+                </c:pt>
+              </c:strCache>
+            </c:strRef>
+          </c:tx>
+          <c:spPr>
+            <a:solidFill>
+              <a:srgbClr val="00B050"/>
+            </a:solidFill>
+            <a:ln>
+              <a:noFill/>
+            </a:ln>
+            <a:effectLst/>
+          </c:spPr>
+          <c:invertIfNegative val="0"/>
+          <c:dLbls>
+            <c:spPr>
+              <a:noFill/>
+              <a:ln>
+                <a:noFill/>
+              </a:ln>
+              <a:effectLst/>
+            </c:spPr>
+            <c:txPr>
+              <a:bodyPr rot="0" spcFirstLastPara="1" vertOverflow="ellipsis" vert="horz" wrap="square" anchor="ctr" anchorCtr="1"/>
+              <a:lstStyle/>
+              <a:p>
+                <a:pPr>
+                  <a:defRPr sz="900" b="1" i="1" u="none" strike="noStrike" kern="1200" baseline="0">
+                    <a:solidFill>
+                      <a:srgbClr val="00B050"/>
+                    </a:solidFill>
+                    <a:latin typeface="Arial" panose="020B0604020202020204" pitchFamily="34" charset="0"/>
+                    <a:ea typeface="+mn-ea"/>
+                    <a:cs typeface="Arial" panose="020B0604020202020204" pitchFamily="34" charset="0"/>
+                  </a:defRPr>
+                </a:pPr>
+                <a:endParaRPr lang="en-US"/>
+              </a:p>
+            </c:txPr>
+            <c:dLblPos val="outEnd"/>
+            <c:showLegendKey val="0"/>
+            <c:showVal val="1"/>
+            <c:showCatName val="0"/>
+            <c:showSerName val="0"/>
+            <c:showPercent val="0"/>
+            <c:showBubbleSize val="0"/>
+            <c:showLeaderLines val="0"/>
+            <c:extLst>
+              <c:ext xmlns:c15="http://schemas.microsoft.com/office/drawing/2012/chart" uri="{CE6537A1-D6FC-4f65-9D91-7224C49458BB}">
+                <c15:showLeaderLines val="1"/>
+                <c15:leaderLines>
+                  <c:spPr>
+                    <a:ln w="9525" cap="flat" cmpd="sng" algn="ctr">
+                      <a:solidFill>
+                        <a:schemeClr val="tx1">
+                          <a:lumMod val="35000"/>
+                          <a:lumOff val="65000"/>
+                        </a:schemeClr>
+                      </a:solidFill>
+                      <a:round/>
+                    </a:ln>
+                    <a:effectLst/>
+                  </c:spPr>
+                </c15:leaderLines>
+              </c:ext>
+            </c:extLst>
+          </c:dLbls>
+          <c:cat>
+            <c:numRef>
+              <c:f>Comparisons!$G$7:$G$11</c:f>
+              <c:numCache>
+                <c:formatCode>General</c:formatCode>
+                <c:ptCount val="5"/>
+                <c:pt idx="0">
+                  <c:v>10</c:v>
+                </c:pt>
+                <c:pt idx="1">
+                  <c:v>30</c:v>
+                </c:pt>
+                <c:pt idx="2">
+                  <c:v>45</c:v>
+                </c:pt>
+                <c:pt idx="3">
+                  <c:v>60</c:v>
+                </c:pt>
+                <c:pt idx="4">
+                  <c:v>100</c:v>
+                </c:pt>
+              </c:numCache>
+            </c:numRef>
+          </c:cat>
+          <c:val>
+            <c:numRef>
+              <c:f>Comparisons!$H$7:$H$11</c:f>
+              <c:numCache>
+                <c:formatCode>General</c:formatCode>
+                <c:ptCount val="5"/>
+                <c:pt idx="0">
+                  <c:v>0.68</c:v>
+                </c:pt>
+                <c:pt idx="1">
+                  <c:v>0.82</c:v>
+                </c:pt>
+                <c:pt idx="2">
+                  <c:v>0.82</c:v>
+                </c:pt>
+                <c:pt idx="3">
+                  <c:v>0.86</c:v>
+                </c:pt>
+                <c:pt idx="4">
+                  <c:v>0.85</c:v>
+                </c:pt>
+              </c:numCache>
+            </c:numRef>
+          </c:val>
+          <c:extLst>
+            <c:ext xmlns:c16="http://schemas.microsoft.com/office/drawing/2014/chart" uri="{C3380CC4-5D6E-409C-BE32-E72D297353CC}">
+              <c16:uniqueId val="{00000000-5EFF-4263-AF16-54B00E3F1A13}"/>
+            </c:ext>
+          </c:extLst>
+        </c:ser>
+        <c:dLbls>
+          <c:dLblPos val="outEnd"/>
+          <c:showLegendKey val="0"/>
+          <c:showVal val="1"/>
+          <c:showCatName val="0"/>
+          <c:showSerName val="0"/>
+          <c:showPercent val="0"/>
+          <c:showBubbleSize val="0"/>
+        </c:dLbls>
+        <c:gapWidth val="219"/>
+        <c:overlap val="-27"/>
+        <c:axId val="1892425040"/>
+        <c:axId val="1892420240"/>
+      </c:barChart>
+      <c:catAx>
+        <c:axId val="1892425040"/>
+        <c:scaling>
+          <c:orientation val="minMax"/>
+        </c:scaling>
+        <c:delete val="0"/>
+        <c:axPos val="b"/>
+        <c:title>
+          <c:tx>
+            <c:rich>
+              <a:bodyPr rot="0" spcFirstLastPara="1" vertOverflow="ellipsis" vert="horz" wrap="square" anchor="ctr" anchorCtr="1"/>
+              <a:lstStyle/>
+              <a:p>
+                <a:pPr>
+                  <a:defRPr sz="1000" b="1" i="0" u="none" strike="noStrike" kern="1200" baseline="0">
+                    <a:solidFill>
+                      <a:schemeClr val="tx1">
+                        <a:lumMod val="65000"/>
+                        <a:lumOff val="35000"/>
+                      </a:schemeClr>
+                    </a:solidFill>
+                    <a:latin typeface="Arial" panose="020B0604020202020204" pitchFamily="34" charset="0"/>
+                    <a:ea typeface="+mn-ea"/>
+                    <a:cs typeface="Arial" panose="020B0604020202020204" pitchFamily="34" charset="0"/>
+                  </a:defRPr>
+                </a:pPr>
+                <a:r>
+                  <a:rPr lang="en-GB" b="1"/>
+                  <a:t>Epoch Size</a:t>
+                </a:r>
+              </a:p>
+            </c:rich>
+          </c:tx>
+          <c:overlay val="0"/>
+          <c:spPr>
+            <a:noFill/>
+            <a:ln>
+              <a:noFill/>
+            </a:ln>
+            <a:effectLst/>
+          </c:spPr>
+          <c:txPr>
+            <a:bodyPr rot="0" spcFirstLastPara="1" vertOverflow="ellipsis" vert="horz" wrap="square" anchor="ctr" anchorCtr="1"/>
+            <a:lstStyle/>
+            <a:p>
+              <a:pPr>
+                <a:defRPr sz="1000" b="1" i="0" u="none" strike="noStrike" kern="1200" baseline="0">
+                  <a:solidFill>
+                    <a:schemeClr val="tx1">
+                      <a:lumMod val="65000"/>
+                      <a:lumOff val="35000"/>
+                    </a:schemeClr>
+                  </a:solidFill>
+                  <a:latin typeface="Arial" panose="020B0604020202020204" pitchFamily="34" charset="0"/>
+                  <a:ea typeface="+mn-ea"/>
+                  <a:cs typeface="Arial" panose="020B0604020202020204" pitchFamily="34" charset="0"/>
+                </a:defRPr>
+              </a:pPr>
+              <a:endParaRPr lang="en-US"/>
+            </a:p>
+          </c:txPr>
+        </c:title>
+        <c:numFmt formatCode="General" sourceLinked="1"/>
+        <c:majorTickMark val="none"/>
+        <c:minorTickMark val="none"/>
+        <c:tickLblPos val="nextTo"/>
+        <c:spPr>
+          <a:noFill/>
+          <a:ln w="9525" cap="flat" cmpd="sng" algn="ctr">
+            <a:solidFill>
+              <a:schemeClr val="tx1">
+                <a:lumMod val="15000"/>
+                <a:lumOff val="85000"/>
+              </a:schemeClr>
+            </a:solidFill>
+            <a:round/>
+          </a:ln>
+          <a:effectLst/>
+        </c:spPr>
+        <c:txPr>
+          <a:bodyPr rot="-60000000" spcFirstLastPara="1" vertOverflow="ellipsis" vert="horz" wrap="square" anchor="ctr" anchorCtr="1"/>
+          <a:lstStyle/>
+          <a:p>
+            <a:pPr>
+              <a:defRPr sz="900" b="0" i="0" u="none" strike="noStrike" kern="1200" baseline="0">
+                <a:solidFill>
+                  <a:schemeClr val="tx1">
+                    <a:lumMod val="65000"/>
+                    <a:lumOff val="35000"/>
+                  </a:schemeClr>
+                </a:solidFill>
+                <a:latin typeface="Arial" panose="020B0604020202020204" pitchFamily="34" charset="0"/>
+                <a:ea typeface="+mn-ea"/>
+                <a:cs typeface="Arial" panose="020B0604020202020204" pitchFamily="34" charset="0"/>
+              </a:defRPr>
+            </a:pPr>
+            <a:endParaRPr lang="en-US"/>
+          </a:p>
+        </c:txPr>
+        <c:crossAx val="1892420240"/>
+        <c:crosses val="autoZero"/>
+        <c:auto val="1"/>
+        <c:lblAlgn val="ctr"/>
+        <c:lblOffset val="100"/>
+        <c:noMultiLvlLbl val="0"/>
+      </c:catAx>
+      <c:valAx>
+        <c:axId val="1892420240"/>
+        <c:scaling>
+          <c:orientation val="minMax"/>
+        </c:scaling>
+        <c:delete val="0"/>
+        <c:axPos val="l"/>
+        <c:title>
+          <c:tx>
+            <c:rich>
+              <a:bodyPr rot="-5400000" spcFirstLastPara="1" vertOverflow="ellipsis" vert="horz" wrap="square" anchor="ctr" anchorCtr="1"/>
+              <a:lstStyle/>
+              <a:p>
+                <a:pPr>
+                  <a:defRPr sz="1000" b="1" i="0" u="none" strike="noStrike" kern="1200" baseline="0">
+                    <a:solidFill>
+                      <a:schemeClr val="tx1">
+                        <a:lumMod val="65000"/>
+                        <a:lumOff val="35000"/>
+                      </a:schemeClr>
+                    </a:solidFill>
+                    <a:latin typeface="Arial" panose="020B0604020202020204" pitchFamily="34" charset="0"/>
+                    <a:ea typeface="+mn-ea"/>
+                    <a:cs typeface="Arial" panose="020B0604020202020204" pitchFamily="34" charset="0"/>
+                  </a:defRPr>
+                </a:pPr>
+                <a:r>
+                  <a:rPr lang="en-GB" b="1"/>
+                  <a:t>F1-Score</a:t>
+                </a:r>
+              </a:p>
+            </c:rich>
+          </c:tx>
+          <c:layout>
+            <c:manualLayout>
+              <c:xMode val="edge"/>
+              <c:yMode val="edge"/>
+              <c:x val="2.1876740216860445E-2"/>
+              <c:y val="0.39214425435655359"/>
+            </c:manualLayout>
+          </c:layout>
+          <c:overlay val="0"/>
+          <c:spPr>
+            <a:noFill/>
+            <a:ln>
+              <a:noFill/>
+            </a:ln>
+            <a:effectLst/>
+          </c:spPr>
+          <c:txPr>
+            <a:bodyPr rot="-5400000" spcFirstLastPara="1" vertOverflow="ellipsis" vert="horz" wrap="square" anchor="ctr" anchorCtr="1"/>
+            <a:lstStyle/>
+            <a:p>
+              <a:pPr>
+                <a:defRPr sz="1000" b="1" i="0" u="none" strike="noStrike" kern="1200" baseline="0">
+                  <a:solidFill>
+                    <a:schemeClr val="tx1">
+                      <a:lumMod val="65000"/>
+                      <a:lumOff val="35000"/>
+                    </a:schemeClr>
+                  </a:solidFill>
+                  <a:latin typeface="Arial" panose="020B0604020202020204" pitchFamily="34" charset="0"/>
+                  <a:ea typeface="+mn-ea"/>
+                  <a:cs typeface="Arial" panose="020B0604020202020204" pitchFamily="34" charset="0"/>
+                </a:defRPr>
+              </a:pPr>
+              <a:endParaRPr lang="en-US"/>
+            </a:p>
+          </c:txPr>
+        </c:title>
+        <c:numFmt formatCode="General" sourceLinked="1"/>
+        <c:majorTickMark val="none"/>
+        <c:minorTickMark val="none"/>
+        <c:tickLblPos val="nextTo"/>
+        <c:spPr>
+          <a:noFill/>
+          <a:ln>
+            <a:noFill/>
+          </a:ln>
+          <a:effectLst/>
+        </c:spPr>
+        <c:txPr>
+          <a:bodyPr rot="-60000000" spcFirstLastPara="1" vertOverflow="ellipsis" vert="horz" wrap="square" anchor="ctr" anchorCtr="1"/>
+          <a:lstStyle/>
+          <a:p>
+            <a:pPr>
+              <a:defRPr sz="900" b="0" i="0" u="none" strike="noStrike" kern="1200" baseline="0">
+                <a:solidFill>
+                  <a:schemeClr val="tx1">
+                    <a:lumMod val="65000"/>
+                    <a:lumOff val="35000"/>
+                  </a:schemeClr>
+                </a:solidFill>
+                <a:latin typeface="Arial" panose="020B0604020202020204" pitchFamily="34" charset="0"/>
+                <a:ea typeface="+mn-ea"/>
+                <a:cs typeface="Arial" panose="020B0604020202020204" pitchFamily="34" charset="0"/>
+              </a:defRPr>
+            </a:pPr>
+            <a:endParaRPr lang="en-US"/>
+          </a:p>
+        </c:txPr>
+        <c:crossAx val="1892425040"/>
+        <c:crosses val="autoZero"/>
+        <c:crossBetween val="between"/>
+      </c:valAx>
+      <c:spPr>
+        <a:noFill/>
+        <a:ln>
+          <a:noFill/>
+        </a:ln>
+        <a:effectLst/>
+      </c:spPr>
+    </c:plotArea>
+    <c:plotVisOnly val="1"/>
+    <c:dispBlanksAs val="gap"/>
+    <c:showDLblsOverMax val="0"/>
+    <c:extLst>
+      <c:ext xmlns:c16r3="http://schemas.microsoft.com/office/drawing/2017/03/chart" uri="{56B9EC1D-385E-4148-901F-78D8002777C0}">
+        <c16r3:dataDisplayOptions16>
+          <c16r3:dispNaAsBlank val="1"/>
+        </c16r3:dataDisplayOptions16>
+      </c:ext>
+    </c:extLst>
+  </c:chart>
+  <c:spPr>
+    <a:noFill/>
+    <a:ln>
+      <a:noFill/>
+    </a:ln>
+    <a:effectLst/>
+  </c:spPr>
+  <c:txPr>
+    <a:bodyPr/>
+    <a:lstStyle/>
+    <a:p>
+      <a:pPr>
+        <a:defRPr>
+          <a:latin typeface="Arial" panose="020B0604020202020204" pitchFamily="34" charset="0"/>
+          <a:cs typeface="Arial" panose="020B0604020202020204" pitchFamily="34" charset="0"/>
+        </a:defRPr>
+      </a:pPr>
+      <a:endParaRPr lang="en-US"/>
+    </a:p>
+  </c:txPr>
+  <c:externalData r:id="rId3">
+    <c:autoUpdate val="0"/>
+  </c:externalData>
+</c:chartSpace>
+</file>
+
+<file path=ppt/charts/chart4.xml><?xml version="1.0" encoding="utf-8"?>
+<c:chartSpace xmlns:c="http://schemas.openxmlformats.org/drawingml/2006/chart" xmlns:a="http://schemas.openxmlformats.org/drawingml/2006/main" xmlns:r="http://schemas.openxmlformats.org/officeDocument/2006/relationships" xmlns:c16r2="http://schemas.microsoft.com/office/drawing/2015/06/chart">
+  <c:date1904 val="0"/>
+  <c:lang val="en-US"/>
+  <c:roundedCorners val="0"/>
+  <mc:AlternateContent xmlns:mc="http://schemas.openxmlformats.org/markup-compatibility/2006">
+    <mc:Choice xmlns:c14="http://schemas.microsoft.com/office/drawing/2007/8/2/chart" Requires="c14">
+      <c14:style val="102"/>
+    </mc:Choice>
+    <mc:Fallback>
+      <c:style val="2"/>
+    </mc:Fallback>
+  </mc:AlternateContent>
+  <c:chart>
+    <c:title>
+      <c:tx>
+        <c:rich>
+          <a:bodyPr rot="0" spcFirstLastPara="1" vertOverflow="ellipsis" vert="horz" wrap="square" anchor="ctr" anchorCtr="1"/>
+          <a:lstStyle/>
+          <a:p>
+            <a:pPr>
+              <a:defRPr sz="1400" b="1" i="1" u="none" strike="noStrike" kern="1200" spc="0" baseline="0">
+                <a:solidFill>
+                  <a:srgbClr val="0070C0"/>
+                </a:solidFill>
+                <a:latin typeface="Arial" panose="020B0604020202020204" pitchFamily="34" charset="0"/>
+                <a:ea typeface="+mn-ea"/>
+                <a:cs typeface="Arial" panose="020B0604020202020204" pitchFamily="34" charset="0"/>
+              </a:defRPr>
+            </a:pPr>
+            <a:r>
+              <a:rPr lang="en-US" b="1" i="1">
+                <a:solidFill>
+                  <a:srgbClr val="0070C0"/>
+                </a:solidFill>
+              </a:rPr>
+              <a:t>LR = 1x10</a:t>
+            </a:r>
+            <a:r>
+              <a:rPr lang="en-US" b="1" i="1" baseline="30000">
+                <a:solidFill>
+                  <a:srgbClr val="0070C0"/>
+                </a:solidFill>
+              </a:rPr>
+              <a:t>-6</a:t>
+            </a:r>
+          </a:p>
+        </c:rich>
+      </c:tx>
+      <c:overlay val="0"/>
+      <c:spPr>
+        <a:noFill/>
+        <a:ln>
+          <a:noFill/>
+        </a:ln>
+        <a:effectLst/>
+      </c:spPr>
+      <c:txPr>
+        <a:bodyPr rot="0" spcFirstLastPara="1" vertOverflow="ellipsis" vert="horz" wrap="square" anchor="ctr" anchorCtr="1"/>
+        <a:lstStyle/>
+        <a:p>
+          <a:pPr>
+            <a:defRPr sz="1400" b="1" i="1" u="none" strike="noStrike" kern="1200" spc="0" baseline="0">
+              <a:solidFill>
+                <a:srgbClr val="0070C0"/>
+              </a:solidFill>
+              <a:latin typeface="Arial" panose="020B0604020202020204" pitchFamily="34" charset="0"/>
+              <a:ea typeface="+mn-ea"/>
+              <a:cs typeface="Arial" panose="020B0604020202020204" pitchFamily="34" charset="0"/>
+            </a:defRPr>
+          </a:pPr>
+          <a:endParaRPr lang="en-US"/>
+        </a:p>
+      </c:txPr>
+    </c:title>
+    <c:autoTitleDeleted val="0"/>
+    <c:plotArea>
+      <c:layout>
+        <c:manualLayout>
+          <c:layoutTarget val="inner"/>
+          <c:xMode val="edge"/>
+          <c:yMode val="edge"/>
+          <c:x val="0.10491983682762546"/>
+          <c:y val="0.12263267998961098"/>
+          <c:w val="0.87299180975871993"/>
+          <c:h val="0.73306160682593824"/>
+        </c:manualLayout>
+      </c:layout>
+      <c:barChart>
+        <c:barDir val="col"/>
+        <c:grouping val="clustered"/>
+        <c:varyColors val="0"/>
+        <c:ser>
+          <c:idx val="0"/>
+          <c:order val="0"/>
+          <c:tx>
+            <c:strRef>
+              <c:f>Comparisons!$K$6</c:f>
+              <c:strCache>
+                <c:ptCount val="1"/>
+                <c:pt idx="0">
+                  <c:v>F1-Score</c:v>
+                </c:pt>
+              </c:strCache>
+            </c:strRef>
+          </c:tx>
+          <c:spPr>
+            <a:solidFill>
+              <a:schemeClr val="accent1"/>
+            </a:solidFill>
+            <a:ln>
+              <a:noFill/>
+            </a:ln>
+            <a:effectLst/>
+          </c:spPr>
+          <c:invertIfNegative val="0"/>
+          <c:dLbls>
+            <c:spPr>
+              <a:noFill/>
+              <a:ln>
+                <a:noFill/>
+              </a:ln>
+              <a:effectLst/>
+            </c:spPr>
+            <c:txPr>
+              <a:bodyPr rot="0" spcFirstLastPara="1" vertOverflow="ellipsis" vert="horz" wrap="square" anchor="ctr" anchorCtr="1"/>
+              <a:lstStyle/>
+              <a:p>
+                <a:pPr>
+                  <a:defRPr sz="900" b="1" i="1" u="none" strike="noStrike" kern="1200" baseline="0">
+                    <a:solidFill>
+                      <a:srgbClr val="0070C0"/>
+                    </a:solidFill>
+                    <a:latin typeface="Arial" panose="020B0604020202020204" pitchFamily="34" charset="0"/>
+                    <a:ea typeface="+mn-ea"/>
+                    <a:cs typeface="Arial" panose="020B0604020202020204" pitchFamily="34" charset="0"/>
+                  </a:defRPr>
+                </a:pPr>
+                <a:endParaRPr lang="en-US"/>
+              </a:p>
+            </c:txPr>
+            <c:dLblPos val="outEnd"/>
+            <c:showLegendKey val="0"/>
+            <c:showVal val="1"/>
+            <c:showCatName val="0"/>
+            <c:showSerName val="0"/>
+            <c:showPercent val="0"/>
+            <c:showBubbleSize val="0"/>
+            <c:showLeaderLines val="0"/>
+            <c:extLst>
+              <c:ext xmlns:c15="http://schemas.microsoft.com/office/drawing/2012/chart" uri="{CE6537A1-D6FC-4f65-9D91-7224C49458BB}">
+                <c15:showLeaderLines val="1"/>
+                <c15:leaderLines>
+                  <c:spPr>
+                    <a:ln w="9525" cap="flat" cmpd="sng" algn="ctr">
+                      <a:solidFill>
+                        <a:schemeClr val="tx1">
+                          <a:lumMod val="35000"/>
+                          <a:lumOff val="65000"/>
+                        </a:schemeClr>
+                      </a:solidFill>
+                      <a:round/>
+                    </a:ln>
+                    <a:effectLst/>
+                  </c:spPr>
+                </c15:leaderLines>
+              </c:ext>
+            </c:extLst>
+          </c:dLbls>
+          <c:cat>
+            <c:numRef>
+              <c:f>Comparisons!$J$7:$J$12</c:f>
+              <c:numCache>
+                <c:formatCode>General</c:formatCode>
+                <c:ptCount val="6"/>
+                <c:pt idx="0">
+                  <c:v>10</c:v>
+                </c:pt>
+                <c:pt idx="1">
+                  <c:v>30</c:v>
+                </c:pt>
+                <c:pt idx="2">
+                  <c:v>45</c:v>
+                </c:pt>
+                <c:pt idx="3">
+                  <c:v>60</c:v>
+                </c:pt>
+                <c:pt idx="4">
+                  <c:v>100</c:v>
+                </c:pt>
+                <c:pt idx="5">
+                  <c:v>200</c:v>
+                </c:pt>
+              </c:numCache>
+            </c:numRef>
+          </c:cat>
+          <c:val>
+            <c:numRef>
+              <c:f>Comparisons!$K$7:$K$12</c:f>
+              <c:numCache>
+                <c:formatCode>General</c:formatCode>
+                <c:ptCount val="6"/>
+                <c:pt idx="0">
+                  <c:v>0.54</c:v>
+                </c:pt>
+                <c:pt idx="1">
+                  <c:v>0.69</c:v>
+                </c:pt>
+                <c:pt idx="2">
+                  <c:v>0.72</c:v>
+                </c:pt>
+                <c:pt idx="3">
+                  <c:v>0.74</c:v>
+                </c:pt>
+                <c:pt idx="4">
+                  <c:v>0.76</c:v>
+                </c:pt>
+                <c:pt idx="5">
+                  <c:v>0.81</c:v>
+                </c:pt>
+              </c:numCache>
+            </c:numRef>
+          </c:val>
+          <c:extLst>
+            <c:ext xmlns:c16="http://schemas.microsoft.com/office/drawing/2014/chart" uri="{C3380CC4-5D6E-409C-BE32-E72D297353CC}">
+              <c16:uniqueId val="{00000000-2488-40E0-BEA5-79C2DAD066AE}"/>
+            </c:ext>
+          </c:extLst>
+        </c:ser>
+        <c:dLbls>
+          <c:dLblPos val="outEnd"/>
+          <c:showLegendKey val="0"/>
+          <c:showVal val="1"/>
+          <c:showCatName val="0"/>
+          <c:showSerName val="0"/>
+          <c:showPercent val="0"/>
+          <c:showBubbleSize val="0"/>
+        </c:dLbls>
+        <c:gapWidth val="219"/>
+        <c:overlap val="-27"/>
+        <c:axId val="1892425040"/>
+        <c:axId val="1892420240"/>
+      </c:barChart>
+      <c:catAx>
+        <c:axId val="1892425040"/>
+        <c:scaling>
+          <c:orientation val="minMax"/>
+        </c:scaling>
+        <c:delete val="0"/>
+        <c:axPos val="b"/>
+        <c:title>
+          <c:tx>
+            <c:rich>
+              <a:bodyPr rot="0" spcFirstLastPara="1" vertOverflow="ellipsis" vert="horz" wrap="square" anchor="ctr" anchorCtr="1"/>
+              <a:lstStyle/>
+              <a:p>
+                <a:pPr>
+                  <a:defRPr sz="1000" b="1" i="0" u="none" strike="noStrike" kern="1200" baseline="0">
+                    <a:solidFill>
+                      <a:schemeClr val="tx1">
+                        <a:lumMod val="65000"/>
+                        <a:lumOff val="35000"/>
+                      </a:schemeClr>
+                    </a:solidFill>
+                    <a:latin typeface="Arial" panose="020B0604020202020204" pitchFamily="34" charset="0"/>
+                    <a:ea typeface="+mn-ea"/>
+                    <a:cs typeface="Arial" panose="020B0604020202020204" pitchFamily="34" charset="0"/>
+                  </a:defRPr>
+                </a:pPr>
+                <a:r>
+                  <a:rPr lang="en-GB" b="1"/>
+                  <a:t>Epoch Size</a:t>
+                </a:r>
+              </a:p>
+            </c:rich>
+          </c:tx>
+          <c:overlay val="0"/>
+          <c:spPr>
+            <a:noFill/>
+            <a:ln>
+              <a:noFill/>
+            </a:ln>
+            <a:effectLst/>
+          </c:spPr>
+          <c:txPr>
+            <a:bodyPr rot="0" spcFirstLastPara="1" vertOverflow="ellipsis" vert="horz" wrap="square" anchor="ctr" anchorCtr="1"/>
+            <a:lstStyle/>
+            <a:p>
+              <a:pPr>
+                <a:defRPr sz="1000" b="1" i="0" u="none" strike="noStrike" kern="1200" baseline="0">
+                  <a:solidFill>
+                    <a:schemeClr val="tx1">
+                      <a:lumMod val="65000"/>
+                      <a:lumOff val="35000"/>
+                    </a:schemeClr>
+                  </a:solidFill>
+                  <a:latin typeface="Arial" panose="020B0604020202020204" pitchFamily="34" charset="0"/>
+                  <a:ea typeface="+mn-ea"/>
+                  <a:cs typeface="Arial" panose="020B0604020202020204" pitchFamily="34" charset="0"/>
+                </a:defRPr>
+              </a:pPr>
+              <a:endParaRPr lang="en-US"/>
+            </a:p>
+          </c:txPr>
+        </c:title>
+        <c:numFmt formatCode="General" sourceLinked="1"/>
+        <c:majorTickMark val="none"/>
+        <c:minorTickMark val="none"/>
+        <c:tickLblPos val="nextTo"/>
+        <c:spPr>
+          <a:noFill/>
+          <a:ln w="9525" cap="flat" cmpd="sng" algn="ctr">
+            <a:solidFill>
+              <a:schemeClr val="tx1">
+                <a:lumMod val="15000"/>
+                <a:lumOff val="85000"/>
+              </a:schemeClr>
+            </a:solidFill>
+            <a:round/>
+          </a:ln>
+          <a:effectLst/>
+        </c:spPr>
+        <c:txPr>
+          <a:bodyPr rot="-60000000" spcFirstLastPara="1" vertOverflow="ellipsis" vert="horz" wrap="square" anchor="ctr" anchorCtr="1"/>
+          <a:lstStyle/>
+          <a:p>
+            <a:pPr>
+              <a:defRPr sz="900" b="0" i="0" u="none" strike="noStrike" kern="1200" baseline="0">
+                <a:solidFill>
+                  <a:schemeClr val="tx1">
+                    <a:lumMod val="65000"/>
+                    <a:lumOff val="35000"/>
+                  </a:schemeClr>
+                </a:solidFill>
+                <a:latin typeface="Arial" panose="020B0604020202020204" pitchFamily="34" charset="0"/>
+                <a:ea typeface="+mn-ea"/>
+                <a:cs typeface="Arial" panose="020B0604020202020204" pitchFamily="34" charset="0"/>
+              </a:defRPr>
+            </a:pPr>
+            <a:endParaRPr lang="en-US"/>
+          </a:p>
+        </c:txPr>
+        <c:crossAx val="1892420240"/>
+        <c:crosses val="autoZero"/>
+        <c:auto val="1"/>
+        <c:lblAlgn val="ctr"/>
+        <c:lblOffset val="100"/>
+        <c:noMultiLvlLbl val="0"/>
+      </c:catAx>
+      <c:valAx>
+        <c:axId val="1892420240"/>
+        <c:scaling>
+          <c:orientation val="minMax"/>
+        </c:scaling>
+        <c:delete val="0"/>
+        <c:axPos val="l"/>
+        <c:title>
+          <c:tx>
+            <c:rich>
+              <a:bodyPr rot="-5400000" spcFirstLastPara="1" vertOverflow="ellipsis" vert="horz" wrap="square" anchor="ctr" anchorCtr="1"/>
+              <a:lstStyle/>
+              <a:p>
+                <a:pPr>
+                  <a:defRPr sz="1000" b="1" i="0" u="none" strike="noStrike" kern="1200" baseline="0">
+                    <a:solidFill>
+                      <a:schemeClr val="tx1">
+                        <a:lumMod val="65000"/>
+                        <a:lumOff val="35000"/>
+                      </a:schemeClr>
+                    </a:solidFill>
+                    <a:latin typeface="Arial" panose="020B0604020202020204" pitchFamily="34" charset="0"/>
+                    <a:ea typeface="+mn-ea"/>
+                    <a:cs typeface="Arial" panose="020B0604020202020204" pitchFamily="34" charset="0"/>
+                  </a:defRPr>
+                </a:pPr>
+                <a:r>
+                  <a:rPr lang="en-GB" b="1"/>
+                  <a:t>F1-Score</a:t>
+                </a:r>
+              </a:p>
+            </c:rich>
+          </c:tx>
+          <c:layout>
+            <c:manualLayout>
+              <c:xMode val="edge"/>
+              <c:yMode val="edge"/>
+              <c:x val="2.1876740216860445E-2"/>
+              <c:y val="0.39214425435655359"/>
+            </c:manualLayout>
+          </c:layout>
+          <c:overlay val="0"/>
+          <c:spPr>
+            <a:noFill/>
+            <a:ln>
+              <a:noFill/>
+            </a:ln>
+            <a:effectLst/>
+          </c:spPr>
+          <c:txPr>
+            <a:bodyPr rot="-5400000" spcFirstLastPara="1" vertOverflow="ellipsis" vert="horz" wrap="square" anchor="ctr" anchorCtr="1"/>
+            <a:lstStyle/>
+            <a:p>
+              <a:pPr>
+                <a:defRPr sz="1000" b="1" i="0" u="none" strike="noStrike" kern="1200" baseline="0">
+                  <a:solidFill>
+                    <a:schemeClr val="tx1">
+                      <a:lumMod val="65000"/>
+                      <a:lumOff val="35000"/>
+                    </a:schemeClr>
+                  </a:solidFill>
+                  <a:latin typeface="Arial" panose="020B0604020202020204" pitchFamily="34" charset="0"/>
+                  <a:ea typeface="+mn-ea"/>
+                  <a:cs typeface="Arial" panose="020B0604020202020204" pitchFamily="34" charset="0"/>
+                </a:defRPr>
+              </a:pPr>
+              <a:endParaRPr lang="en-US"/>
+            </a:p>
+          </c:txPr>
+        </c:title>
+        <c:numFmt formatCode="General" sourceLinked="1"/>
+        <c:majorTickMark val="none"/>
+        <c:minorTickMark val="none"/>
+        <c:tickLblPos val="nextTo"/>
+        <c:spPr>
+          <a:noFill/>
+          <a:ln>
+            <a:noFill/>
+          </a:ln>
+          <a:effectLst/>
+        </c:spPr>
+        <c:txPr>
+          <a:bodyPr rot="-60000000" spcFirstLastPara="1" vertOverflow="ellipsis" vert="horz" wrap="square" anchor="ctr" anchorCtr="1"/>
+          <a:lstStyle/>
+          <a:p>
+            <a:pPr>
+              <a:defRPr sz="900" b="0" i="0" u="none" strike="noStrike" kern="1200" baseline="0">
+                <a:solidFill>
+                  <a:schemeClr val="tx1">
+                    <a:lumMod val="65000"/>
+                    <a:lumOff val="35000"/>
+                  </a:schemeClr>
+                </a:solidFill>
+                <a:latin typeface="Arial" panose="020B0604020202020204" pitchFamily="34" charset="0"/>
+                <a:ea typeface="+mn-ea"/>
+                <a:cs typeface="Arial" panose="020B0604020202020204" pitchFamily="34" charset="0"/>
+              </a:defRPr>
+            </a:pPr>
+            <a:endParaRPr lang="en-US"/>
+          </a:p>
+        </c:txPr>
+        <c:crossAx val="1892425040"/>
+        <c:crosses val="autoZero"/>
+        <c:crossBetween val="between"/>
+      </c:valAx>
+      <c:spPr>
+        <a:noFill/>
+        <a:ln>
+          <a:noFill/>
+        </a:ln>
+        <a:effectLst/>
+      </c:spPr>
+    </c:plotArea>
+    <c:plotVisOnly val="1"/>
+    <c:dispBlanksAs val="gap"/>
+    <c:showDLblsOverMax val="0"/>
+    <c:extLst>
+      <c:ext xmlns:c16r3="http://schemas.microsoft.com/office/drawing/2017/03/chart" uri="{56B9EC1D-385E-4148-901F-78D8002777C0}">
+        <c16r3:dataDisplayOptions16>
+          <c16r3:dispNaAsBlank val="1"/>
+        </c16r3:dataDisplayOptions16>
+      </c:ext>
+    </c:extLst>
+  </c:chart>
+  <c:spPr>
+    <a:noFill/>
+    <a:ln>
+      <a:noFill/>
+    </a:ln>
+    <a:effectLst/>
+  </c:spPr>
+  <c:txPr>
+    <a:bodyPr/>
+    <a:lstStyle/>
+    <a:p>
+      <a:pPr>
+        <a:defRPr>
+          <a:latin typeface="Arial" panose="020B0604020202020204" pitchFamily="34" charset="0"/>
+          <a:cs typeface="Arial" panose="020B0604020202020204" pitchFamily="34" charset="0"/>
+        </a:defRPr>
+      </a:pPr>
+      <a:endParaRPr lang="en-US"/>
+    </a:p>
+  </c:txPr>
+  <c:externalData r:id="rId3">
+    <c:autoUpdate val="0"/>
+  </c:externalData>
+</c:chartSpace>
+</file>
+
+<file path=ppt/charts/colors1.xml><?xml version="1.0" encoding="utf-8"?>
+<cs:colorStyle xmlns:cs="http://schemas.microsoft.com/office/drawing/2012/chartStyle" xmlns:a="http://schemas.openxmlformats.org/drawingml/2006/main" meth="cycle" id="10">
+  <a:schemeClr val="accent1"/>
+  <a:schemeClr val="accent2"/>
+  <a:schemeClr val="accent3"/>
+  <a:schemeClr val="accent4"/>
+  <a:schemeClr val="accent5"/>
+  <a:schemeClr val="accent6"/>
+  <cs:variation/>
+  <cs:variation>
+    <a:lumMod val="60000"/>
+  </cs:variation>
+  <cs:variation>
+    <a:lumMod val="80000"/>
+    <a:lumOff val="20000"/>
+  </cs:variation>
+  <cs:variation>
+    <a:lumMod val="80000"/>
+  </cs:variation>
+  <cs:variation>
+    <a:lumMod val="60000"/>
+    <a:lumOff val="40000"/>
+  </cs:variation>
+  <cs:variation>
+    <a:lumMod val="50000"/>
+  </cs:variation>
+  <cs:variation>
+    <a:lumMod val="70000"/>
+    <a:lumOff val="30000"/>
+  </cs:variation>
+  <cs:variation>
+    <a:lumMod val="70000"/>
+  </cs:variation>
+  <cs:variation>
+    <a:lumMod val="50000"/>
+    <a:lumOff val="50000"/>
+  </cs:variation>
+</cs:colorStyle>
+</file>
+
+<file path=ppt/charts/colors2.xml><?xml version="1.0" encoding="utf-8"?>
+<cs:colorStyle xmlns:cs="http://schemas.microsoft.com/office/drawing/2012/chartStyle" xmlns:a="http://schemas.openxmlformats.org/drawingml/2006/main" meth="cycle" id="10">
+  <a:schemeClr val="accent1"/>
+  <a:schemeClr val="accent2"/>
+  <a:schemeClr val="accent3"/>
+  <a:schemeClr val="accent4"/>
+  <a:schemeClr val="accent5"/>
+  <a:schemeClr val="accent6"/>
+  <cs:variation/>
+  <cs:variation>
+    <a:lumMod val="60000"/>
+  </cs:variation>
+  <cs:variation>
+    <a:lumMod val="80000"/>
+    <a:lumOff val="20000"/>
+  </cs:variation>
+  <cs:variation>
+    <a:lumMod val="80000"/>
+  </cs:variation>
+  <cs:variation>
+    <a:lumMod val="60000"/>
+    <a:lumOff val="40000"/>
+  </cs:variation>
+  <cs:variation>
+    <a:lumMod val="50000"/>
+  </cs:variation>
+  <cs:variation>
+    <a:lumMod val="70000"/>
+    <a:lumOff val="30000"/>
+  </cs:variation>
+  <cs:variation>
+    <a:lumMod val="70000"/>
+  </cs:variation>
+  <cs:variation>
+    <a:lumMod val="50000"/>
+    <a:lumOff val="50000"/>
+  </cs:variation>
+</cs:colorStyle>
+</file>
+
+<file path=ppt/charts/colors3.xml><?xml version="1.0" encoding="utf-8"?>
+<cs:colorStyle xmlns:cs="http://schemas.microsoft.com/office/drawing/2012/chartStyle" xmlns:a="http://schemas.openxmlformats.org/drawingml/2006/main" meth="cycle" id="10">
+  <a:schemeClr val="accent1"/>
+  <a:schemeClr val="accent2"/>
+  <a:schemeClr val="accent3"/>
+  <a:schemeClr val="accent4"/>
+  <a:schemeClr val="accent5"/>
+  <a:schemeClr val="accent6"/>
+  <cs:variation/>
+  <cs:variation>
+    <a:lumMod val="60000"/>
+  </cs:variation>
+  <cs:variation>
+    <a:lumMod val="80000"/>
+    <a:lumOff val="20000"/>
+  </cs:variation>
+  <cs:variation>
+    <a:lumMod val="80000"/>
+  </cs:variation>
+  <cs:variation>
+    <a:lumMod val="60000"/>
+    <a:lumOff val="40000"/>
+  </cs:variation>
+  <cs:variation>
+    <a:lumMod val="50000"/>
+  </cs:variation>
+  <cs:variation>
+    <a:lumMod val="70000"/>
+    <a:lumOff val="30000"/>
+  </cs:variation>
+  <cs:variation>
+    <a:lumMod val="70000"/>
+  </cs:variation>
+  <cs:variation>
+    <a:lumMod val="50000"/>
+    <a:lumOff val="50000"/>
+  </cs:variation>
+</cs:colorStyle>
+</file>
+
+<file path=ppt/charts/colors4.xml><?xml version="1.0" encoding="utf-8"?>
+<cs:colorStyle xmlns:cs="http://schemas.microsoft.com/office/drawing/2012/chartStyle" xmlns:a="http://schemas.openxmlformats.org/drawingml/2006/main" meth="cycle" id="10">
+  <a:schemeClr val="accent1"/>
+  <a:schemeClr val="accent2"/>
+  <a:schemeClr val="accent3"/>
+  <a:schemeClr val="accent4"/>
+  <a:schemeClr val="accent5"/>
+  <a:schemeClr val="accent6"/>
+  <cs:variation/>
+  <cs:variation>
+    <a:lumMod val="60000"/>
+  </cs:variation>
+  <cs:variation>
+    <a:lumMod val="80000"/>
+    <a:lumOff val="20000"/>
+  </cs:variation>
+  <cs:variation>
+    <a:lumMod val="80000"/>
+  </cs:variation>
+  <cs:variation>
+    <a:lumMod val="60000"/>
+    <a:lumOff val="40000"/>
+  </cs:variation>
+  <cs:variation>
+    <a:lumMod val="50000"/>
+  </cs:variation>
+  <cs:variation>
+    <a:lumMod val="70000"/>
+    <a:lumOff val="30000"/>
+  </cs:variation>
+  <cs:variation>
+    <a:lumMod val="70000"/>
+  </cs:variation>
+  <cs:variation>
+    <a:lumMod val="50000"/>
+    <a:lumOff val="50000"/>
+  </cs:variation>
+</cs:colorStyle>
+</file>
+
+<file path=ppt/charts/style1.xml><?xml version="1.0" encoding="utf-8"?>
+<cs:chartStyle xmlns:cs="http://schemas.microsoft.com/office/drawing/2012/chartStyle" xmlns:a="http://schemas.openxmlformats.org/drawingml/2006/main" id="201">
+  <cs:axisTitle>
+    <cs:lnRef idx="0"/>
+    <cs:fillRef idx="0"/>
+    <cs:effectRef idx="0"/>
+    <cs:fontRef idx="minor">
+      <a:schemeClr val="tx1">
+        <a:lumMod val="65000"/>
+        <a:lumOff val="35000"/>
+      </a:schemeClr>
+    </cs:fontRef>
+    <cs:defRPr sz="1000" kern="1200"/>
+  </cs:axisTitle>
+  <cs:categoryAxis>
+    <cs:lnRef idx="0"/>
+    <cs:fillRef idx="0"/>
+    <cs:effectRef idx="0"/>
+    <cs:fontRef idx="minor">
+      <a:schemeClr val="tx1">
+        <a:lumMod val="65000"/>
+        <a:lumOff val="35000"/>
+      </a:schemeClr>
+    </cs:fontRef>
+    <cs:spPr>
+      <a:ln w="9525" cap="flat" cmpd="sng" algn="ctr">
+        <a:solidFill>
+          <a:schemeClr val="tx1">
+            <a:lumMod val="15000"/>
+            <a:lumOff val="85000"/>
+          </a:schemeClr>
+        </a:solidFill>
+        <a:round/>
+      </a:ln>
+    </cs:spPr>
+    <cs:defRPr sz="900" kern="1200"/>
+  </cs:categoryAxis>
+  <cs:chartArea mods="allowNoFillOverride allowNoLineOverride">
+    <cs:lnRef idx="0"/>
+    <cs:fillRef idx="0"/>
+    <cs:effectRef idx="0"/>
+    <cs:fontRef idx="minor">
+      <a:schemeClr val="tx1"/>
+    </cs:fontRef>
+    <cs:spPr>
+      <a:solidFill>
+        <a:schemeClr val="bg1"/>
+      </a:solidFill>
+      <a:ln w="9525" cap="flat" cmpd="sng" algn="ctr">
+        <a:solidFill>
+          <a:schemeClr val="tx1">
+            <a:lumMod val="15000"/>
+            <a:lumOff val="85000"/>
+          </a:schemeClr>
+        </a:solidFill>
+        <a:round/>
+      </a:ln>
+    </cs:spPr>
+    <cs:defRPr sz="1000" kern="1200"/>
+  </cs:chartArea>
+  <cs:dataLabel>
+    <cs:lnRef idx="0"/>
+    <cs:fillRef idx="0"/>
+    <cs:effectRef idx="0"/>
+    <cs:fontRef idx="minor">
+      <a:schemeClr val="tx1">
+        <a:lumMod val="75000"/>
+        <a:lumOff val="25000"/>
+      </a:schemeClr>
+    </cs:fontRef>
+    <cs:defRPr sz="900" kern="1200"/>
+  </cs:dataLabel>
+  <cs:dataLabelCallout>
+    <cs:lnRef idx="0"/>
+    <cs:fillRef idx="0"/>
+    <cs:effectRef idx="0"/>
+    <cs:fontRef idx="minor">
+      <a:schemeClr val="dk1">
+        <a:lumMod val="65000"/>
+        <a:lumOff val="35000"/>
+      </a:schemeClr>
+    </cs:fontRef>
+    <cs:spPr>
+      <a:solidFill>
+        <a:schemeClr val="lt1"/>
+      </a:solidFill>
+      <a:ln>
+        <a:solidFill>
+          <a:schemeClr val="dk1">
+            <a:lumMod val="25000"/>
+            <a:lumOff val="75000"/>
+          </a:schemeClr>
+        </a:solidFill>
+      </a:ln>
+    </cs:spPr>
+    <cs:defRPr sz="900" kern="1200"/>
+    <cs:bodyPr rot="0" spcFirstLastPara="1" vertOverflow="clip" horzOverflow="clip" vert="horz" wrap="square" lIns="36576" tIns="18288" rIns="36576" bIns="18288" anchor="ctr" anchorCtr="1">
+      <a:spAutoFit/>
+    </cs:bodyPr>
+  </cs:dataLabelCallout>
+  <cs:dataPoint>
+    <cs:lnRef idx="0"/>
+    <cs:fillRef idx="1">
+      <cs:styleClr val="auto"/>
+    </cs:fillRef>
+    <cs:effectRef idx="0"/>
+    <cs:fontRef idx="minor">
+      <a:schemeClr val="tx1"/>
+    </cs:fontRef>
+  </cs:dataPoint>
+  <cs:dataPoint3D>
+    <cs:lnRef idx="0"/>
+    <cs:fillRef idx="1">
+      <cs:styleClr val="auto"/>
+    </cs:fillRef>
+    <cs:effectRef idx="0"/>
+    <cs:fontRef idx="minor">
+      <a:schemeClr val="tx1"/>
+    </cs:fontRef>
+  </cs:dataPoint3D>
+  <cs:dataPointLine>
+    <cs:lnRef idx="0">
+      <cs:styleClr val="auto"/>
+    </cs:lnRef>
+    <cs:fillRef idx="1"/>
+    <cs:effectRef idx="0"/>
+    <cs:fontRef idx="minor">
+      <a:schemeClr val="tx1"/>
+    </cs:fontRef>
+    <cs:spPr>
+      <a:ln w="28575" cap="rnd">
+        <a:solidFill>
+          <a:schemeClr val="phClr"/>
+        </a:solidFill>
+        <a:round/>
+      </a:ln>
+    </cs:spPr>
+  </cs:dataPointLine>
+  <cs:dataPointMarker>
+    <cs:lnRef idx="0">
+      <cs:styleClr val="auto"/>
+    </cs:lnRef>
+    <cs:fillRef idx="1">
+      <cs:styleClr val="auto"/>
+    </cs:fillRef>
+    <cs:effectRef idx="0"/>
+    <cs:fontRef idx="minor">
+      <a:schemeClr val="tx1"/>
+    </cs:fontRef>
+    <cs:spPr>
+      <a:ln w="9525">
+        <a:solidFill>
+          <a:schemeClr val="phClr"/>
+        </a:solidFill>
+      </a:ln>
+    </cs:spPr>
+  </cs:dataPointMarker>
+  <cs:dataPointMarkerLayout symbol="circle" size="5"/>
+  <cs:dataPointWireframe>
+    <cs:lnRef idx="0">
+      <cs:styleClr val="auto"/>
+    </cs:lnRef>
+    <cs:fillRef idx="1"/>
+    <cs:effectRef idx="0"/>
+    <cs:fontRef idx="minor">
+      <a:schemeClr val="tx1"/>
+    </cs:fontRef>
+    <cs:spPr>
+      <a:ln w="9525" cap="rnd">
+        <a:solidFill>
+          <a:schemeClr val="phClr"/>
+        </a:solidFill>
+        <a:round/>
+      </a:ln>
+    </cs:spPr>
+  </cs:dataPointWireframe>
+  <cs:dataTable>
+    <cs:lnRef idx="0"/>
+    <cs:fillRef idx="0"/>
+    <cs:effectRef idx="0"/>
+    <cs:fontRef idx="minor">
+      <a:schemeClr val="tx1">
+        <a:lumMod val="65000"/>
+        <a:lumOff val="35000"/>
+      </a:schemeClr>
+    </cs:fontRef>
+    <cs:spPr>
+      <a:noFill/>
+      <a:ln w="9525" cap="flat" cmpd="sng" algn="ctr">
+        <a:solidFill>
+          <a:schemeClr val="tx1">
+            <a:lumMod val="15000"/>
+            <a:lumOff val="85000"/>
+          </a:schemeClr>
+        </a:solidFill>
+        <a:round/>
+      </a:ln>
+    </cs:spPr>
+    <cs:defRPr sz="900" kern="1200"/>
+  </cs:dataTable>
+  <cs:downBar>
+    <cs:lnRef idx="0"/>
+    <cs:fillRef idx="0"/>
+    <cs:effectRef idx="0"/>
+    <cs:fontRef idx="minor">
+      <a:schemeClr val="dk1"/>
+    </cs:fontRef>
+    <cs:spPr>
+      <a:solidFill>
+        <a:schemeClr val="dk1">
+          <a:lumMod val="65000"/>
+          <a:lumOff val="35000"/>
+        </a:schemeClr>
+      </a:solidFill>
+      <a:ln w="9525">
+        <a:solidFill>
+          <a:schemeClr val="tx1">
+            <a:lumMod val="65000"/>
+            <a:lumOff val="35000"/>
+          </a:schemeClr>
+        </a:solidFill>
+      </a:ln>
+    </cs:spPr>
+  </cs:downBar>
+  <cs:dropLine>
+    <cs:lnRef idx="0"/>
+    <cs:fillRef idx="0"/>
+    <cs:effectRef idx="0"/>
+    <cs:fontRef idx="minor">
+      <a:schemeClr val="tx1"/>
+    </cs:fontRef>
+    <cs:spPr>
+      <a:ln w="9525" cap="flat" cmpd="sng" algn="ctr">
+        <a:solidFill>
+          <a:schemeClr val="tx1">
+            <a:lumMod val="35000"/>
+            <a:lumOff val="65000"/>
+          </a:schemeClr>
+        </a:solidFill>
+        <a:round/>
+      </a:ln>
+    </cs:spPr>
+  </cs:dropLine>
+  <cs:errorBar>
+    <cs:lnRef idx="0"/>
+    <cs:fillRef idx="0"/>
+    <cs:effectRef idx="0"/>
+    <cs:fontRef idx="minor">
+      <a:schemeClr val="tx1"/>
+    </cs:fontRef>
+    <cs:spPr>
+      <a:ln w="9525" cap="flat" cmpd="sng" algn="ctr">
+        <a:solidFill>
+          <a:schemeClr val="tx1">
+            <a:lumMod val="65000"/>
+            <a:lumOff val="35000"/>
+          </a:schemeClr>
+        </a:solidFill>
+        <a:round/>
+      </a:ln>
+    </cs:spPr>
+  </cs:errorBar>
+  <cs:floor>
+    <cs:lnRef idx="0"/>
+    <cs:fillRef idx="0"/>
+    <cs:effectRef idx="0"/>
+    <cs:fontRef idx="minor">
+      <a:schemeClr val="tx1"/>
+    </cs:fontRef>
+    <cs:spPr>
+      <a:noFill/>
+      <a:ln>
+        <a:noFill/>
+      </a:ln>
+    </cs:spPr>
+  </cs:floor>
+  <cs:gridlineMajor>
+    <cs:lnRef idx="0"/>
+    <cs:fillRef idx="0"/>
+    <cs:effectRef idx="0"/>
+    <cs:fontRef idx="minor">
+      <a:schemeClr val="tx1"/>
+    </cs:fontRef>
+    <cs:spPr>
+      <a:ln w="9525" cap="flat" cmpd="sng" algn="ctr">
+        <a:solidFill>
+          <a:schemeClr val="tx1">
+            <a:lumMod val="15000"/>
+            <a:lumOff val="85000"/>
+          </a:schemeClr>
+        </a:solidFill>
+        <a:round/>
+      </a:ln>
+    </cs:spPr>
+  </cs:gridlineMajor>
+  <cs:gridlineMinor>
+    <cs:lnRef idx="0"/>
+    <cs:fillRef idx="0"/>
+    <cs:effectRef idx="0"/>
+    <cs:fontRef idx="minor">
+      <a:schemeClr val="tx1"/>
+    </cs:fontRef>
+    <cs:spPr>
+      <a:ln w="9525" cap="flat" cmpd="sng" algn="ctr">
+        <a:solidFill>
+          <a:schemeClr val="tx1">
+            <a:lumMod val="5000"/>
+            <a:lumOff val="95000"/>
+          </a:schemeClr>
+        </a:solidFill>
+        <a:round/>
+      </a:ln>
+    </cs:spPr>
+  </cs:gridlineMinor>
+  <cs:hiLoLine>
+    <cs:lnRef idx="0"/>
+    <cs:fillRef idx="0"/>
+    <cs:effectRef idx="0"/>
+    <cs:fontRef idx="minor">
+      <a:schemeClr val="tx1"/>
+    </cs:fontRef>
+    <cs:spPr>
+      <a:ln w="9525" cap="flat" cmpd="sng" algn="ctr">
+        <a:solidFill>
+          <a:schemeClr val="tx1">
+            <a:lumMod val="75000"/>
+            <a:lumOff val="25000"/>
+          </a:schemeClr>
+        </a:solidFill>
+        <a:round/>
+      </a:ln>
+    </cs:spPr>
+  </cs:hiLoLine>
+  <cs:leaderLine>
+    <cs:lnRef idx="0"/>
+    <cs:fillRef idx="0"/>
+    <cs:effectRef idx="0"/>
+    <cs:fontRef idx="minor">
+      <a:schemeClr val="tx1"/>
+    </cs:fontRef>
+    <cs:spPr>
+      <a:ln w="9525" cap="flat" cmpd="sng" algn="ctr">
+        <a:solidFill>
+          <a:schemeClr val="tx1">
+            <a:lumMod val="35000"/>
+            <a:lumOff val="65000"/>
+          </a:schemeClr>
+        </a:solidFill>
+        <a:round/>
+      </a:ln>
+    </cs:spPr>
+  </cs:leaderLine>
+  <cs:legend>
+    <cs:lnRef idx="0"/>
+    <cs:fillRef idx="0"/>
+    <cs:effectRef idx="0"/>
+    <cs:fontRef idx="minor">
+      <a:schemeClr val="tx1">
+        <a:lumMod val="65000"/>
+        <a:lumOff val="35000"/>
+      </a:schemeClr>
+    </cs:fontRef>
+    <cs:defRPr sz="900" kern="1200"/>
+  </cs:legend>
+  <cs:plotArea mods="allowNoFillOverride allowNoLineOverride">
+    <cs:lnRef idx="0"/>
+    <cs:fillRef idx="0"/>
+    <cs:effectRef idx="0"/>
+    <cs:fontRef idx="minor">
+      <a:schemeClr val="tx1"/>
+    </cs:fontRef>
+  </cs:plotArea>
+  <cs:plotArea3D mods="allowNoFillOverride allowNoLineOverride">
+    <cs:lnRef idx="0"/>
+    <cs:fillRef idx="0"/>
+    <cs:effectRef idx="0"/>
+    <cs:fontRef idx="minor">
+      <a:schemeClr val="tx1"/>
+    </cs:fontRef>
+  </cs:plotArea3D>
+  <cs:seriesAxis>
+    <cs:lnRef idx="0"/>
+    <cs:fillRef idx="0"/>
+    <cs:effectRef idx="0"/>
+    <cs:fontRef idx="minor">
+      <a:schemeClr val="tx1">
+        <a:lumMod val="65000"/>
+        <a:lumOff val="35000"/>
+      </a:schemeClr>
+    </cs:fontRef>
+    <cs:defRPr sz="900" kern="1200"/>
+  </cs:seriesAxis>
+  <cs:seriesLine>
+    <cs:lnRef idx="0"/>
+    <cs:fillRef idx="0"/>
+    <cs:effectRef idx="0"/>
+    <cs:fontRef idx="minor">
+      <a:schemeClr val="tx1"/>
+    </cs:fontRef>
+    <cs:spPr>
+      <a:ln w="9525" cap="flat" cmpd="sng" algn="ctr">
+        <a:solidFill>
+          <a:schemeClr val="tx1">
+            <a:lumMod val="35000"/>
+            <a:lumOff val="65000"/>
+          </a:schemeClr>
+        </a:solidFill>
+        <a:round/>
+      </a:ln>
+    </cs:spPr>
+  </cs:seriesLine>
+  <cs:title>
+    <cs:lnRef idx="0"/>
+    <cs:fillRef idx="0"/>
+    <cs:effectRef idx="0"/>
+    <cs:fontRef idx="minor">
+      <a:schemeClr val="tx1">
+        <a:lumMod val="65000"/>
+        <a:lumOff val="35000"/>
+      </a:schemeClr>
+    </cs:fontRef>
+    <cs:defRPr sz="1400" b="0" kern="1200" spc="0" baseline="0"/>
+  </cs:title>
+  <cs:trendline>
+    <cs:lnRef idx="0">
+      <cs:styleClr val="auto"/>
+    </cs:lnRef>
+    <cs:fillRef idx="0"/>
+    <cs:effectRef idx="0"/>
+    <cs:fontRef idx="minor">
+      <a:schemeClr val="tx1"/>
+    </cs:fontRef>
+    <cs:spPr>
+      <a:ln w="19050" cap="rnd">
+        <a:solidFill>
+          <a:schemeClr val="phClr"/>
+        </a:solidFill>
+        <a:prstDash val="sysDot"/>
+      </a:ln>
+    </cs:spPr>
+  </cs:trendline>
+  <cs:trendlineLabel>
+    <cs:lnRef idx="0"/>
+    <cs:fillRef idx="0"/>
+    <cs:effectRef idx="0"/>
+    <cs:fontRef idx="minor">
+      <a:schemeClr val="tx1">
+        <a:lumMod val="65000"/>
+        <a:lumOff val="35000"/>
+      </a:schemeClr>
+    </cs:fontRef>
+    <cs:defRPr sz="900" kern="1200"/>
+  </cs:trendlineLabel>
+  <cs:upBar>
+    <cs:lnRef idx="0"/>
+    <cs:fillRef idx="0"/>
+    <cs:effectRef idx="0"/>
+    <cs:fontRef idx="minor">
+      <a:schemeClr val="dk1"/>
+    </cs:fontRef>
+    <cs:spPr>
+      <a:solidFill>
+        <a:schemeClr val="lt1"/>
+      </a:solidFill>
+      <a:ln w="9525">
+        <a:solidFill>
+          <a:schemeClr val="tx1">
+            <a:lumMod val="15000"/>
+            <a:lumOff val="85000"/>
+          </a:schemeClr>
+        </a:solidFill>
+      </a:ln>
+    </cs:spPr>
+  </cs:upBar>
+  <cs:valueAxis>
+    <cs:lnRef idx="0"/>
+    <cs:fillRef idx="0"/>
+    <cs:effectRef idx="0"/>
+    <cs:fontRef idx="minor">
+      <a:schemeClr val="tx1">
+        <a:lumMod val="65000"/>
+        <a:lumOff val="35000"/>
+      </a:schemeClr>
+    </cs:fontRef>
+    <cs:defRPr sz="900" kern="1200"/>
+  </cs:valueAxis>
+  <cs:wall>
+    <cs:lnRef idx="0"/>
+    <cs:fillRef idx="0"/>
+    <cs:effectRef idx="0"/>
+    <cs:fontRef idx="minor">
+      <a:schemeClr val="tx1"/>
+    </cs:fontRef>
+    <cs:spPr>
+      <a:noFill/>
+      <a:ln>
+        <a:noFill/>
+      </a:ln>
+    </cs:spPr>
+  </cs:wall>
+</cs:chartStyle>
+</file>
+
+<file path=ppt/charts/style2.xml><?xml version="1.0" encoding="utf-8"?>
+<cs:chartStyle xmlns:cs="http://schemas.microsoft.com/office/drawing/2012/chartStyle" xmlns:a="http://schemas.openxmlformats.org/drawingml/2006/main" id="201">
+  <cs:axisTitle>
+    <cs:lnRef idx="0"/>
+    <cs:fillRef idx="0"/>
+    <cs:effectRef idx="0"/>
+    <cs:fontRef idx="minor">
+      <a:schemeClr val="tx1">
+        <a:lumMod val="65000"/>
+        <a:lumOff val="35000"/>
+      </a:schemeClr>
+    </cs:fontRef>
+    <cs:defRPr sz="1000" kern="1200"/>
+  </cs:axisTitle>
+  <cs:categoryAxis>
+    <cs:lnRef idx="0"/>
+    <cs:fillRef idx="0"/>
+    <cs:effectRef idx="0"/>
+    <cs:fontRef idx="minor">
+      <a:schemeClr val="tx1">
+        <a:lumMod val="65000"/>
+        <a:lumOff val="35000"/>
+      </a:schemeClr>
+    </cs:fontRef>
+    <cs:spPr>
+      <a:ln w="9525" cap="flat" cmpd="sng" algn="ctr">
+        <a:solidFill>
+          <a:schemeClr val="tx1">
+            <a:lumMod val="15000"/>
+            <a:lumOff val="85000"/>
+          </a:schemeClr>
+        </a:solidFill>
+        <a:round/>
+      </a:ln>
+    </cs:spPr>
+    <cs:defRPr sz="900" kern="1200"/>
+  </cs:categoryAxis>
+  <cs:chartArea mods="allowNoFillOverride allowNoLineOverride">
+    <cs:lnRef idx="0"/>
+    <cs:fillRef idx="0"/>
+    <cs:effectRef idx="0"/>
+    <cs:fontRef idx="minor">
+      <a:schemeClr val="tx1"/>
+    </cs:fontRef>
+    <cs:spPr>
+      <a:solidFill>
+        <a:schemeClr val="bg1"/>
+      </a:solidFill>
+      <a:ln w="9525" cap="flat" cmpd="sng" algn="ctr">
+        <a:solidFill>
+          <a:schemeClr val="tx1">
+            <a:lumMod val="15000"/>
+            <a:lumOff val="85000"/>
+          </a:schemeClr>
+        </a:solidFill>
+        <a:round/>
+      </a:ln>
+    </cs:spPr>
+    <cs:defRPr sz="1000" kern="1200"/>
+  </cs:chartArea>
+  <cs:dataLabel>
+    <cs:lnRef idx="0"/>
+    <cs:fillRef idx="0"/>
+    <cs:effectRef idx="0"/>
+    <cs:fontRef idx="minor">
+      <a:schemeClr val="tx1">
+        <a:lumMod val="75000"/>
+        <a:lumOff val="25000"/>
+      </a:schemeClr>
+    </cs:fontRef>
+    <cs:defRPr sz="900" kern="1200"/>
+  </cs:dataLabel>
+  <cs:dataLabelCallout>
+    <cs:lnRef idx="0"/>
+    <cs:fillRef idx="0"/>
+    <cs:effectRef idx="0"/>
+    <cs:fontRef idx="minor">
+      <a:schemeClr val="dk1">
+        <a:lumMod val="65000"/>
+        <a:lumOff val="35000"/>
+      </a:schemeClr>
+    </cs:fontRef>
+    <cs:spPr>
+      <a:solidFill>
+        <a:schemeClr val="lt1"/>
+      </a:solidFill>
+      <a:ln>
+        <a:solidFill>
+          <a:schemeClr val="dk1">
+            <a:lumMod val="25000"/>
+            <a:lumOff val="75000"/>
+          </a:schemeClr>
+        </a:solidFill>
+      </a:ln>
+    </cs:spPr>
+    <cs:defRPr sz="900" kern="1200"/>
+    <cs:bodyPr rot="0" spcFirstLastPara="1" vertOverflow="clip" horzOverflow="clip" vert="horz" wrap="square" lIns="36576" tIns="18288" rIns="36576" bIns="18288" anchor="ctr" anchorCtr="1">
+      <a:spAutoFit/>
+    </cs:bodyPr>
+  </cs:dataLabelCallout>
+  <cs:dataPoint>
+    <cs:lnRef idx="0"/>
+    <cs:fillRef idx="1">
+      <cs:styleClr val="auto"/>
+    </cs:fillRef>
+    <cs:effectRef idx="0"/>
+    <cs:fontRef idx="minor">
+      <a:schemeClr val="tx1"/>
+    </cs:fontRef>
+  </cs:dataPoint>
+  <cs:dataPoint3D>
+    <cs:lnRef idx="0"/>
+    <cs:fillRef idx="1">
+      <cs:styleClr val="auto"/>
+    </cs:fillRef>
+    <cs:effectRef idx="0"/>
+    <cs:fontRef idx="minor">
+      <a:schemeClr val="tx1"/>
+    </cs:fontRef>
+  </cs:dataPoint3D>
+  <cs:dataPointLine>
+    <cs:lnRef idx="0">
+      <cs:styleClr val="auto"/>
+    </cs:lnRef>
+    <cs:fillRef idx="1"/>
+    <cs:effectRef idx="0"/>
+    <cs:fontRef idx="minor">
+      <a:schemeClr val="tx1"/>
+    </cs:fontRef>
+    <cs:spPr>
+      <a:ln w="28575" cap="rnd">
+        <a:solidFill>
+          <a:schemeClr val="phClr"/>
+        </a:solidFill>
+        <a:round/>
+      </a:ln>
+    </cs:spPr>
+  </cs:dataPointLine>
+  <cs:dataPointMarker>
+    <cs:lnRef idx="0">
+      <cs:styleClr val="auto"/>
+    </cs:lnRef>
+    <cs:fillRef idx="1">
+      <cs:styleClr val="auto"/>
+    </cs:fillRef>
+    <cs:effectRef idx="0"/>
+    <cs:fontRef idx="minor">
+      <a:schemeClr val="tx1"/>
+    </cs:fontRef>
+    <cs:spPr>
+      <a:ln w="9525">
+        <a:solidFill>
+          <a:schemeClr val="phClr"/>
+        </a:solidFill>
+      </a:ln>
+    </cs:spPr>
+  </cs:dataPointMarker>
+  <cs:dataPointMarkerLayout symbol="circle" size="5"/>
+  <cs:dataPointWireframe>
+    <cs:lnRef idx="0">
+      <cs:styleClr val="auto"/>
+    </cs:lnRef>
+    <cs:fillRef idx="1"/>
+    <cs:effectRef idx="0"/>
+    <cs:fontRef idx="minor">
+      <a:schemeClr val="tx1"/>
+    </cs:fontRef>
+    <cs:spPr>
+      <a:ln w="9525" cap="rnd">
+        <a:solidFill>
+          <a:schemeClr val="phClr"/>
+        </a:solidFill>
+        <a:round/>
+      </a:ln>
+    </cs:spPr>
+  </cs:dataPointWireframe>
+  <cs:dataTable>
+    <cs:lnRef idx="0"/>
+    <cs:fillRef idx="0"/>
+    <cs:effectRef idx="0"/>
+    <cs:fontRef idx="minor">
+      <a:schemeClr val="tx1">
+        <a:lumMod val="65000"/>
+        <a:lumOff val="35000"/>
+      </a:schemeClr>
+    </cs:fontRef>
+    <cs:spPr>
+      <a:noFill/>
+      <a:ln w="9525" cap="flat" cmpd="sng" algn="ctr">
+        <a:solidFill>
+          <a:schemeClr val="tx1">
+            <a:lumMod val="15000"/>
+            <a:lumOff val="85000"/>
+          </a:schemeClr>
+        </a:solidFill>
+        <a:round/>
+      </a:ln>
+    </cs:spPr>
+    <cs:defRPr sz="900" kern="1200"/>
+  </cs:dataTable>
+  <cs:downBar>
+    <cs:lnRef idx="0"/>
+    <cs:fillRef idx="0"/>
+    <cs:effectRef idx="0"/>
+    <cs:fontRef idx="minor">
+      <a:schemeClr val="dk1"/>
+    </cs:fontRef>
+    <cs:spPr>
+      <a:solidFill>
+        <a:schemeClr val="dk1">
+          <a:lumMod val="65000"/>
+          <a:lumOff val="35000"/>
+        </a:schemeClr>
+      </a:solidFill>
+      <a:ln w="9525">
+        <a:solidFill>
+          <a:schemeClr val="tx1">
+            <a:lumMod val="65000"/>
+            <a:lumOff val="35000"/>
+          </a:schemeClr>
+        </a:solidFill>
+      </a:ln>
+    </cs:spPr>
+  </cs:downBar>
+  <cs:dropLine>
+    <cs:lnRef idx="0"/>
+    <cs:fillRef idx="0"/>
+    <cs:effectRef idx="0"/>
+    <cs:fontRef idx="minor">
+      <a:schemeClr val="tx1"/>
+    </cs:fontRef>
+    <cs:spPr>
+      <a:ln w="9525" cap="flat" cmpd="sng" algn="ctr">
+        <a:solidFill>
+          <a:schemeClr val="tx1">
+            <a:lumMod val="35000"/>
+            <a:lumOff val="65000"/>
+          </a:schemeClr>
+        </a:solidFill>
+        <a:round/>
+      </a:ln>
+    </cs:spPr>
+  </cs:dropLine>
+  <cs:errorBar>
+    <cs:lnRef idx="0"/>
+    <cs:fillRef idx="0"/>
+    <cs:effectRef idx="0"/>
+    <cs:fontRef idx="minor">
+      <a:schemeClr val="tx1"/>
+    </cs:fontRef>
+    <cs:spPr>
+      <a:ln w="9525" cap="flat" cmpd="sng" algn="ctr">
+        <a:solidFill>
+          <a:schemeClr val="tx1">
+            <a:lumMod val="65000"/>
+            <a:lumOff val="35000"/>
+          </a:schemeClr>
+        </a:solidFill>
+        <a:round/>
+      </a:ln>
+    </cs:spPr>
+  </cs:errorBar>
+  <cs:floor>
+    <cs:lnRef idx="0"/>
+    <cs:fillRef idx="0"/>
+    <cs:effectRef idx="0"/>
+    <cs:fontRef idx="minor">
+      <a:schemeClr val="tx1"/>
+    </cs:fontRef>
+    <cs:spPr>
+      <a:noFill/>
+      <a:ln>
+        <a:noFill/>
+      </a:ln>
+    </cs:spPr>
+  </cs:floor>
+  <cs:gridlineMajor>
+    <cs:lnRef idx="0"/>
+    <cs:fillRef idx="0"/>
+    <cs:effectRef idx="0"/>
+    <cs:fontRef idx="minor">
+      <a:schemeClr val="tx1"/>
+    </cs:fontRef>
+    <cs:spPr>
+      <a:ln w="9525" cap="flat" cmpd="sng" algn="ctr">
+        <a:solidFill>
+          <a:schemeClr val="tx1">
+            <a:lumMod val="15000"/>
+            <a:lumOff val="85000"/>
+          </a:schemeClr>
+        </a:solidFill>
+        <a:round/>
+      </a:ln>
+    </cs:spPr>
+  </cs:gridlineMajor>
+  <cs:gridlineMinor>
+    <cs:lnRef idx="0"/>
+    <cs:fillRef idx="0"/>
+    <cs:effectRef idx="0"/>
+    <cs:fontRef idx="minor">
+      <a:schemeClr val="tx1"/>
+    </cs:fontRef>
+    <cs:spPr>
+      <a:ln w="9525" cap="flat" cmpd="sng" algn="ctr">
+        <a:solidFill>
+          <a:schemeClr val="tx1">
+            <a:lumMod val="5000"/>
+            <a:lumOff val="95000"/>
+          </a:schemeClr>
+        </a:solidFill>
+        <a:round/>
+      </a:ln>
+    </cs:spPr>
+  </cs:gridlineMinor>
+  <cs:hiLoLine>
+    <cs:lnRef idx="0"/>
+    <cs:fillRef idx="0"/>
+    <cs:effectRef idx="0"/>
+    <cs:fontRef idx="minor">
+      <a:schemeClr val="tx1"/>
+    </cs:fontRef>
+    <cs:spPr>
+      <a:ln w="9525" cap="flat" cmpd="sng" algn="ctr">
+        <a:solidFill>
+          <a:schemeClr val="tx1">
+            <a:lumMod val="75000"/>
+            <a:lumOff val="25000"/>
+          </a:schemeClr>
+        </a:solidFill>
+        <a:round/>
+      </a:ln>
+    </cs:spPr>
+  </cs:hiLoLine>
+  <cs:leaderLine>
+    <cs:lnRef idx="0"/>
+    <cs:fillRef idx="0"/>
+    <cs:effectRef idx="0"/>
+    <cs:fontRef idx="minor">
+      <a:schemeClr val="tx1"/>
+    </cs:fontRef>
+    <cs:spPr>
+      <a:ln w="9525" cap="flat" cmpd="sng" algn="ctr">
+        <a:solidFill>
+          <a:schemeClr val="tx1">
+            <a:lumMod val="35000"/>
+            <a:lumOff val="65000"/>
+          </a:schemeClr>
+        </a:solidFill>
+        <a:round/>
+      </a:ln>
+    </cs:spPr>
+  </cs:leaderLine>
+  <cs:legend>
+    <cs:lnRef idx="0"/>
+    <cs:fillRef idx="0"/>
+    <cs:effectRef idx="0"/>
+    <cs:fontRef idx="minor">
+      <a:schemeClr val="tx1">
+        <a:lumMod val="65000"/>
+        <a:lumOff val="35000"/>
+      </a:schemeClr>
+    </cs:fontRef>
+    <cs:defRPr sz="900" kern="1200"/>
+  </cs:legend>
+  <cs:plotArea mods="allowNoFillOverride allowNoLineOverride">
+    <cs:lnRef idx="0"/>
+    <cs:fillRef idx="0"/>
+    <cs:effectRef idx="0"/>
+    <cs:fontRef idx="minor">
+      <a:schemeClr val="tx1"/>
+    </cs:fontRef>
+  </cs:plotArea>
+  <cs:plotArea3D mods="allowNoFillOverride allowNoLineOverride">
+    <cs:lnRef idx="0"/>
+    <cs:fillRef idx="0"/>
+    <cs:effectRef idx="0"/>
+    <cs:fontRef idx="minor">
+      <a:schemeClr val="tx1"/>
+    </cs:fontRef>
+  </cs:plotArea3D>
+  <cs:seriesAxis>
+    <cs:lnRef idx="0"/>
+    <cs:fillRef idx="0"/>
+    <cs:effectRef idx="0"/>
+    <cs:fontRef idx="minor">
+      <a:schemeClr val="tx1">
+        <a:lumMod val="65000"/>
+        <a:lumOff val="35000"/>
+      </a:schemeClr>
+    </cs:fontRef>
+    <cs:defRPr sz="900" kern="1200"/>
+  </cs:seriesAxis>
+  <cs:seriesLine>
+    <cs:lnRef idx="0"/>
+    <cs:fillRef idx="0"/>
+    <cs:effectRef idx="0"/>
+    <cs:fontRef idx="minor">
+      <a:schemeClr val="tx1"/>
+    </cs:fontRef>
+    <cs:spPr>
+      <a:ln w="9525" cap="flat" cmpd="sng" algn="ctr">
+        <a:solidFill>
+          <a:schemeClr val="tx1">
+            <a:lumMod val="35000"/>
+            <a:lumOff val="65000"/>
+          </a:schemeClr>
+        </a:solidFill>
+        <a:round/>
+      </a:ln>
+    </cs:spPr>
+  </cs:seriesLine>
+  <cs:title>
+    <cs:lnRef idx="0"/>
+    <cs:fillRef idx="0"/>
+    <cs:effectRef idx="0"/>
+    <cs:fontRef idx="minor">
+      <a:schemeClr val="tx1">
+        <a:lumMod val="65000"/>
+        <a:lumOff val="35000"/>
+      </a:schemeClr>
+    </cs:fontRef>
+    <cs:defRPr sz="1400" b="0" kern="1200" spc="0" baseline="0"/>
+  </cs:title>
+  <cs:trendline>
+    <cs:lnRef idx="0">
+      <cs:styleClr val="auto"/>
+    </cs:lnRef>
+    <cs:fillRef idx="0"/>
+    <cs:effectRef idx="0"/>
+    <cs:fontRef idx="minor">
+      <a:schemeClr val="tx1"/>
+    </cs:fontRef>
+    <cs:spPr>
+      <a:ln w="19050" cap="rnd">
+        <a:solidFill>
+          <a:schemeClr val="phClr"/>
+        </a:solidFill>
+        <a:prstDash val="sysDot"/>
+      </a:ln>
+    </cs:spPr>
+  </cs:trendline>
+  <cs:trendlineLabel>
+    <cs:lnRef idx="0"/>
+    <cs:fillRef idx="0"/>
+    <cs:effectRef idx="0"/>
+    <cs:fontRef idx="minor">
+      <a:schemeClr val="tx1">
+        <a:lumMod val="65000"/>
+        <a:lumOff val="35000"/>
+      </a:schemeClr>
+    </cs:fontRef>
+    <cs:defRPr sz="900" kern="1200"/>
+  </cs:trendlineLabel>
+  <cs:upBar>
+    <cs:lnRef idx="0"/>
+    <cs:fillRef idx="0"/>
+    <cs:effectRef idx="0"/>
+    <cs:fontRef idx="minor">
+      <a:schemeClr val="dk1"/>
+    </cs:fontRef>
+    <cs:spPr>
+      <a:solidFill>
+        <a:schemeClr val="lt1"/>
+      </a:solidFill>
+      <a:ln w="9525">
+        <a:solidFill>
+          <a:schemeClr val="tx1">
+            <a:lumMod val="15000"/>
+            <a:lumOff val="85000"/>
+          </a:schemeClr>
+        </a:solidFill>
+      </a:ln>
+    </cs:spPr>
+  </cs:upBar>
+  <cs:valueAxis>
+    <cs:lnRef idx="0"/>
+    <cs:fillRef idx="0"/>
+    <cs:effectRef idx="0"/>
+    <cs:fontRef idx="minor">
+      <a:schemeClr val="tx1">
+        <a:lumMod val="65000"/>
+        <a:lumOff val="35000"/>
+      </a:schemeClr>
+    </cs:fontRef>
+    <cs:defRPr sz="900" kern="1200"/>
+  </cs:valueAxis>
+  <cs:wall>
+    <cs:lnRef idx="0"/>
+    <cs:fillRef idx="0"/>
+    <cs:effectRef idx="0"/>
+    <cs:fontRef idx="minor">
+      <a:schemeClr val="tx1"/>
+    </cs:fontRef>
+    <cs:spPr>
+      <a:noFill/>
+      <a:ln>
+        <a:noFill/>
+      </a:ln>
+    </cs:spPr>
+  </cs:wall>
+</cs:chartStyle>
+</file>
+
+<file path=ppt/charts/style3.xml><?xml version="1.0" encoding="utf-8"?>
+<cs:chartStyle xmlns:cs="http://schemas.microsoft.com/office/drawing/2012/chartStyle" xmlns:a="http://schemas.openxmlformats.org/drawingml/2006/main" id="201">
+  <cs:axisTitle>
+    <cs:lnRef idx="0"/>
+    <cs:fillRef idx="0"/>
+    <cs:effectRef idx="0"/>
+    <cs:fontRef idx="minor">
+      <a:schemeClr val="tx1">
+        <a:lumMod val="65000"/>
+        <a:lumOff val="35000"/>
+      </a:schemeClr>
+    </cs:fontRef>
+    <cs:defRPr sz="1000" kern="1200"/>
+  </cs:axisTitle>
+  <cs:categoryAxis>
+    <cs:lnRef idx="0"/>
+    <cs:fillRef idx="0"/>
+    <cs:effectRef idx="0"/>
+    <cs:fontRef idx="minor">
+      <a:schemeClr val="tx1">
+        <a:lumMod val="65000"/>
+        <a:lumOff val="35000"/>
+      </a:schemeClr>
+    </cs:fontRef>
+    <cs:spPr>
+      <a:ln w="9525" cap="flat" cmpd="sng" algn="ctr">
+        <a:solidFill>
+          <a:schemeClr val="tx1">
+            <a:lumMod val="15000"/>
+            <a:lumOff val="85000"/>
+          </a:schemeClr>
+        </a:solidFill>
+        <a:round/>
+      </a:ln>
+    </cs:spPr>
+    <cs:defRPr sz="900" kern="1200"/>
+  </cs:categoryAxis>
+  <cs:chartArea mods="allowNoFillOverride allowNoLineOverride">
+    <cs:lnRef idx="0"/>
+    <cs:fillRef idx="0"/>
+    <cs:effectRef idx="0"/>
+    <cs:fontRef idx="minor">
+      <a:schemeClr val="tx1"/>
+    </cs:fontRef>
+    <cs:spPr>
+      <a:solidFill>
+        <a:schemeClr val="bg1"/>
+      </a:solidFill>
+      <a:ln w="9525" cap="flat" cmpd="sng" algn="ctr">
+        <a:solidFill>
+          <a:schemeClr val="tx1">
+            <a:lumMod val="15000"/>
+            <a:lumOff val="85000"/>
+          </a:schemeClr>
+        </a:solidFill>
+        <a:round/>
+      </a:ln>
+    </cs:spPr>
+    <cs:defRPr sz="1000" kern="1200"/>
+  </cs:chartArea>
+  <cs:dataLabel>
+    <cs:lnRef idx="0"/>
+    <cs:fillRef idx="0"/>
+    <cs:effectRef idx="0"/>
+    <cs:fontRef idx="minor">
+      <a:schemeClr val="tx1">
+        <a:lumMod val="75000"/>
+        <a:lumOff val="25000"/>
+      </a:schemeClr>
+    </cs:fontRef>
+    <cs:defRPr sz="900" kern="1200"/>
+  </cs:dataLabel>
+  <cs:dataLabelCallout>
+    <cs:lnRef idx="0"/>
+    <cs:fillRef idx="0"/>
+    <cs:effectRef idx="0"/>
+    <cs:fontRef idx="minor">
+      <a:schemeClr val="dk1">
+        <a:lumMod val="65000"/>
+        <a:lumOff val="35000"/>
+      </a:schemeClr>
+    </cs:fontRef>
+    <cs:spPr>
+      <a:solidFill>
+        <a:schemeClr val="lt1"/>
+      </a:solidFill>
+      <a:ln>
+        <a:solidFill>
+          <a:schemeClr val="dk1">
+            <a:lumMod val="25000"/>
+            <a:lumOff val="75000"/>
+          </a:schemeClr>
+        </a:solidFill>
+      </a:ln>
+    </cs:spPr>
+    <cs:defRPr sz="900" kern="1200"/>
+    <cs:bodyPr rot="0" spcFirstLastPara="1" vertOverflow="clip" horzOverflow="clip" vert="horz" wrap="square" lIns="36576" tIns="18288" rIns="36576" bIns="18288" anchor="ctr" anchorCtr="1">
+      <a:spAutoFit/>
+    </cs:bodyPr>
+  </cs:dataLabelCallout>
+  <cs:dataPoint>
+    <cs:lnRef idx="0"/>
+    <cs:fillRef idx="1">
+      <cs:styleClr val="auto"/>
+    </cs:fillRef>
+    <cs:effectRef idx="0"/>
+    <cs:fontRef idx="minor">
+      <a:schemeClr val="tx1"/>
+    </cs:fontRef>
+  </cs:dataPoint>
+  <cs:dataPoint3D>
+    <cs:lnRef idx="0"/>
+    <cs:fillRef idx="1">
+      <cs:styleClr val="auto"/>
+    </cs:fillRef>
+    <cs:effectRef idx="0"/>
+    <cs:fontRef idx="minor">
+      <a:schemeClr val="tx1"/>
+    </cs:fontRef>
+  </cs:dataPoint3D>
+  <cs:dataPointLine>
+    <cs:lnRef idx="0">
+      <cs:styleClr val="auto"/>
+    </cs:lnRef>
+    <cs:fillRef idx="1"/>
+    <cs:effectRef idx="0"/>
+    <cs:fontRef idx="minor">
+      <a:schemeClr val="tx1"/>
+    </cs:fontRef>
+    <cs:spPr>
+      <a:ln w="28575" cap="rnd">
+        <a:solidFill>
+          <a:schemeClr val="phClr"/>
+        </a:solidFill>
+        <a:round/>
+      </a:ln>
+    </cs:spPr>
+  </cs:dataPointLine>
+  <cs:dataPointMarker>
+    <cs:lnRef idx="0">
+      <cs:styleClr val="auto"/>
+    </cs:lnRef>
+    <cs:fillRef idx="1">
+      <cs:styleClr val="auto"/>
+    </cs:fillRef>
+    <cs:effectRef idx="0"/>
+    <cs:fontRef idx="minor">
+      <a:schemeClr val="tx1"/>
+    </cs:fontRef>
+    <cs:spPr>
+      <a:ln w="9525">
+        <a:solidFill>
+          <a:schemeClr val="phClr"/>
+        </a:solidFill>
+      </a:ln>
+    </cs:spPr>
+  </cs:dataPointMarker>
+  <cs:dataPointMarkerLayout symbol="circle" size="5"/>
+  <cs:dataPointWireframe>
+    <cs:lnRef idx="0">
+      <cs:styleClr val="auto"/>
+    </cs:lnRef>
+    <cs:fillRef idx="1"/>
+    <cs:effectRef idx="0"/>
+    <cs:fontRef idx="minor">
+      <a:schemeClr val="tx1"/>
+    </cs:fontRef>
+    <cs:spPr>
+      <a:ln w="9525" cap="rnd">
+        <a:solidFill>
+          <a:schemeClr val="phClr"/>
+        </a:solidFill>
+        <a:round/>
+      </a:ln>
+    </cs:spPr>
+  </cs:dataPointWireframe>
+  <cs:dataTable>
+    <cs:lnRef idx="0"/>
+    <cs:fillRef idx="0"/>
+    <cs:effectRef idx="0"/>
+    <cs:fontRef idx="minor">
+      <a:schemeClr val="tx1">
+        <a:lumMod val="65000"/>
+        <a:lumOff val="35000"/>
+      </a:schemeClr>
+    </cs:fontRef>
+    <cs:spPr>
+      <a:noFill/>
+      <a:ln w="9525" cap="flat" cmpd="sng" algn="ctr">
+        <a:solidFill>
+          <a:schemeClr val="tx1">
+            <a:lumMod val="15000"/>
+            <a:lumOff val="85000"/>
+          </a:schemeClr>
+        </a:solidFill>
+        <a:round/>
+      </a:ln>
+    </cs:spPr>
+    <cs:defRPr sz="900" kern="1200"/>
+  </cs:dataTable>
+  <cs:downBar>
+    <cs:lnRef idx="0"/>
+    <cs:fillRef idx="0"/>
+    <cs:effectRef idx="0"/>
+    <cs:fontRef idx="minor">
+      <a:schemeClr val="dk1"/>
+    </cs:fontRef>
+    <cs:spPr>
+      <a:solidFill>
+        <a:schemeClr val="dk1">
+          <a:lumMod val="65000"/>
+          <a:lumOff val="35000"/>
+        </a:schemeClr>
+      </a:solidFill>
+      <a:ln w="9525">
+        <a:solidFill>
+          <a:schemeClr val="tx1">
+            <a:lumMod val="65000"/>
+            <a:lumOff val="35000"/>
+          </a:schemeClr>
+        </a:solidFill>
+      </a:ln>
+    </cs:spPr>
+  </cs:downBar>
+  <cs:dropLine>
+    <cs:lnRef idx="0"/>
+    <cs:fillRef idx="0"/>
+    <cs:effectRef idx="0"/>
+    <cs:fontRef idx="minor">
+      <a:schemeClr val="tx1"/>
+    </cs:fontRef>
+    <cs:spPr>
+      <a:ln w="9525" cap="flat" cmpd="sng" algn="ctr">
+        <a:solidFill>
+          <a:schemeClr val="tx1">
+            <a:lumMod val="35000"/>
+            <a:lumOff val="65000"/>
+          </a:schemeClr>
+        </a:solidFill>
+        <a:round/>
+      </a:ln>
+    </cs:spPr>
+  </cs:dropLine>
+  <cs:errorBar>
+    <cs:lnRef idx="0"/>
+    <cs:fillRef idx="0"/>
+    <cs:effectRef idx="0"/>
+    <cs:fontRef idx="minor">
+      <a:schemeClr val="tx1"/>
+    </cs:fontRef>
+    <cs:spPr>
+      <a:ln w="9525" cap="flat" cmpd="sng" algn="ctr">
+        <a:solidFill>
+          <a:schemeClr val="tx1">
+            <a:lumMod val="65000"/>
+            <a:lumOff val="35000"/>
+          </a:schemeClr>
+        </a:solidFill>
+        <a:round/>
+      </a:ln>
+    </cs:spPr>
+  </cs:errorBar>
+  <cs:floor>
+    <cs:lnRef idx="0"/>
+    <cs:fillRef idx="0"/>
+    <cs:effectRef idx="0"/>
+    <cs:fontRef idx="minor">
+      <a:schemeClr val="tx1"/>
+    </cs:fontRef>
+    <cs:spPr>
+      <a:noFill/>
+      <a:ln>
+        <a:noFill/>
+      </a:ln>
+    </cs:spPr>
+  </cs:floor>
+  <cs:gridlineMajor>
+    <cs:lnRef idx="0"/>
+    <cs:fillRef idx="0"/>
+    <cs:effectRef idx="0"/>
+    <cs:fontRef idx="minor">
+      <a:schemeClr val="tx1"/>
+    </cs:fontRef>
+    <cs:spPr>
+      <a:ln w="9525" cap="flat" cmpd="sng" algn="ctr">
+        <a:solidFill>
+          <a:schemeClr val="tx1">
+            <a:lumMod val="15000"/>
+            <a:lumOff val="85000"/>
+          </a:schemeClr>
+        </a:solidFill>
+        <a:round/>
+      </a:ln>
+    </cs:spPr>
+  </cs:gridlineMajor>
+  <cs:gridlineMinor>
+    <cs:lnRef idx="0"/>
+    <cs:fillRef idx="0"/>
+    <cs:effectRef idx="0"/>
+    <cs:fontRef idx="minor">
+      <a:schemeClr val="tx1"/>
+    </cs:fontRef>
+    <cs:spPr>
+      <a:ln w="9525" cap="flat" cmpd="sng" algn="ctr">
+        <a:solidFill>
+          <a:schemeClr val="tx1">
+            <a:lumMod val="5000"/>
+            <a:lumOff val="95000"/>
+          </a:schemeClr>
+        </a:solidFill>
+        <a:round/>
+      </a:ln>
+    </cs:spPr>
+  </cs:gridlineMinor>
+  <cs:hiLoLine>
+    <cs:lnRef idx="0"/>
+    <cs:fillRef idx="0"/>
+    <cs:effectRef idx="0"/>
+    <cs:fontRef idx="minor">
+      <a:schemeClr val="tx1"/>
+    </cs:fontRef>
+    <cs:spPr>
+      <a:ln w="9525" cap="flat" cmpd="sng" algn="ctr">
+        <a:solidFill>
+          <a:schemeClr val="tx1">
+            <a:lumMod val="75000"/>
+            <a:lumOff val="25000"/>
+          </a:schemeClr>
+        </a:solidFill>
+        <a:round/>
+      </a:ln>
+    </cs:spPr>
+  </cs:hiLoLine>
+  <cs:leaderLine>
+    <cs:lnRef idx="0"/>
+    <cs:fillRef idx="0"/>
+    <cs:effectRef idx="0"/>
+    <cs:fontRef idx="minor">
+      <a:schemeClr val="tx1"/>
+    </cs:fontRef>
+    <cs:spPr>
+      <a:ln w="9525" cap="flat" cmpd="sng" algn="ctr">
+        <a:solidFill>
+          <a:schemeClr val="tx1">
+            <a:lumMod val="35000"/>
+            <a:lumOff val="65000"/>
+          </a:schemeClr>
+        </a:solidFill>
+        <a:round/>
+      </a:ln>
+    </cs:spPr>
+  </cs:leaderLine>
+  <cs:legend>
+    <cs:lnRef idx="0"/>
+    <cs:fillRef idx="0"/>
+    <cs:effectRef idx="0"/>
+    <cs:fontRef idx="minor">
+      <a:schemeClr val="tx1">
+        <a:lumMod val="65000"/>
+        <a:lumOff val="35000"/>
+      </a:schemeClr>
+    </cs:fontRef>
+    <cs:defRPr sz="900" kern="1200"/>
+  </cs:legend>
+  <cs:plotArea mods="allowNoFillOverride allowNoLineOverride">
+    <cs:lnRef idx="0"/>
+    <cs:fillRef idx="0"/>
+    <cs:effectRef idx="0"/>
+    <cs:fontRef idx="minor">
+      <a:schemeClr val="tx1"/>
+    </cs:fontRef>
+  </cs:plotArea>
+  <cs:plotArea3D mods="allowNoFillOverride allowNoLineOverride">
+    <cs:lnRef idx="0"/>
+    <cs:fillRef idx="0"/>
+    <cs:effectRef idx="0"/>
+    <cs:fontRef idx="minor">
+      <a:schemeClr val="tx1"/>
+    </cs:fontRef>
+  </cs:plotArea3D>
+  <cs:seriesAxis>
+    <cs:lnRef idx="0"/>
+    <cs:fillRef idx="0"/>
+    <cs:effectRef idx="0"/>
+    <cs:fontRef idx="minor">
+      <a:schemeClr val="tx1">
+        <a:lumMod val="65000"/>
+        <a:lumOff val="35000"/>
+      </a:schemeClr>
+    </cs:fontRef>
+    <cs:defRPr sz="900" kern="1200"/>
+  </cs:seriesAxis>
+  <cs:seriesLine>
+    <cs:lnRef idx="0"/>
+    <cs:fillRef idx="0"/>
+    <cs:effectRef idx="0"/>
+    <cs:fontRef idx="minor">
+      <a:schemeClr val="tx1"/>
+    </cs:fontRef>
+    <cs:spPr>
+      <a:ln w="9525" cap="flat" cmpd="sng" algn="ctr">
+        <a:solidFill>
+          <a:schemeClr val="tx1">
+            <a:lumMod val="35000"/>
+            <a:lumOff val="65000"/>
+          </a:schemeClr>
+        </a:solidFill>
+        <a:round/>
+      </a:ln>
+    </cs:spPr>
+  </cs:seriesLine>
+  <cs:title>
+    <cs:lnRef idx="0"/>
+    <cs:fillRef idx="0"/>
+    <cs:effectRef idx="0"/>
+    <cs:fontRef idx="minor">
+      <a:schemeClr val="tx1">
+        <a:lumMod val="65000"/>
+        <a:lumOff val="35000"/>
+      </a:schemeClr>
+    </cs:fontRef>
+    <cs:defRPr sz="1400" b="0" kern="1200" spc="0" baseline="0"/>
+  </cs:title>
+  <cs:trendline>
+    <cs:lnRef idx="0">
+      <cs:styleClr val="auto"/>
+    </cs:lnRef>
+    <cs:fillRef idx="0"/>
+    <cs:effectRef idx="0"/>
+    <cs:fontRef idx="minor">
+      <a:schemeClr val="tx1"/>
+    </cs:fontRef>
+    <cs:spPr>
+      <a:ln w="19050" cap="rnd">
+        <a:solidFill>
+          <a:schemeClr val="phClr"/>
+        </a:solidFill>
+        <a:prstDash val="sysDot"/>
+      </a:ln>
+    </cs:spPr>
+  </cs:trendline>
+  <cs:trendlineLabel>
+    <cs:lnRef idx="0"/>
+    <cs:fillRef idx="0"/>
+    <cs:effectRef idx="0"/>
+    <cs:fontRef idx="minor">
+      <a:schemeClr val="tx1">
+        <a:lumMod val="65000"/>
+        <a:lumOff val="35000"/>
+      </a:schemeClr>
+    </cs:fontRef>
+    <cs:defRPr sz="900" kern="1200"/>
+  </cs:trendlineLabel>
+  <cs:upBar>
+    <cs:lnRef idx="0"/>
+    <cs:fillRef idx="0"/>
+    <cs:effectRef idx="0"/>
+    <cs:fontRef idx="minor">
+      <a:schemeClr val="dk1"/>
+    </cs:fontRef>
+    <cs:spPr>
+      <a:solidFill>
+        <a:schemeClr val="lt1"/>
+      </a:solidFill>
+      <a:ln w="9525">
+        <a:solidFill>
+          <a:schemeClr val="tx1">
+            <a:lumMod val="15000"/>
+            <a:lumOff val="85000"/>
+          </a:schemeClr>
+        </a:solidFill>
+      </a:ln>
+    </cs:spPr>
+  </cs:upBar>
+  <cs:valueAxis>
+    <cs:lnRef idx="0"/>
+    <cs:fillRef idx="0"/>
+    <cs:effectRef idx="0"/>
+    <cs:fontRef idx="minor">
+      <a:schemeClr val="tx1">
+        <a:lumMod val="65000"/>
+        <a:lumOff val="35000"/>
+      </a:schemeClr>
+    </cs:fontRef>
+    <cs:defRPr sz="900" kern="1200"/>
+  </cs:valueAxis>
+  <cs:wall>
+    <cs:lnRef idx="0"/>
+    <cs:fillRef idx="0"/>
+    <cs:effectRef idx="0"/>
+    <cs:fontRef idx="minor">
+      <a:schemeClr val="tx1"/>
+    </cs:fontRef>
+    <cs:spPr>
+      <a:noFill/>
+      <a:ln>
+        <a:noFill/>
+      </a:ln>
+    </cs:spPr>
+  </cs:wall>
+</cs:chartStyle>
+</file>
+
+<file path=ppt/charts/style4.xml><?xml version="1.0" encoding="utf-8"?>
+<cs:chartStyle xmlns:cs="http://schemas.microsoft.com/office/drawing/2012/chartStyle" xmlns:a="http://schemas.openxmlformats.org/drawingml/2006/main" id="201">
+  <cs:axisTitle>
+    <cs:lnRef idx="0"/>
+    <cs:fillRef idx="0"/>
+    <cs:effectRef idx="0"/>
+    <cs:fontRef idx="minor">
+      <a:schemeClr val="tx1">
+        <a:lumMod val="65000"/>
+        <a:lumOff val="35000"/>
+      </a:schemeClr>
+    </cs:fontRef>
+    <cs:defRPr sz="1000" kern="1200"/>
+  </cs:axisTitle>
+  <cs:categoryAxis>
+    <cs:lnRef idx="0"/>
+    <cs:fillRef idx="0"/>
+    <cs:effectRef idx="0"/>
+    <cs:fontRef idx="minor">
+      <a:schemeClr val="tx1">
+        <a:lumMod val="65000"/>
+        <a:lumOff val="35000"/>
+      </a:schemeClr>
+    </cs:fontRef>
+    <cs:spPr>
+      <a:ln w="9525" cap="flat" cmpd="sng" algn="ctr">
+        <a:solidFill>
+          <a:schemeClr val="tx1">
+            <a:lumMod val="15000"/>
+            <a:lumOff val="85000"/>
+          </a:schemeClr>
+        </a:solidFill>
+        <a:round/>
+      </a:ln>
+    </cs:spPr>
+    <cs:defRPr sz="900" kern="1200"/>
+  </cs:categoryAxis>
+  <cs:chartArea mods="allowNoFillOverride allowNoLineOverride">
+    <cs:lnRef idx="0"/>
+    <cs:fillRef idx="0"/>
+    <cs:effectRef idx="0"/>
+    <cs:fontRef idx="minor">
+      <a:schemeClr val="tx1"/>
+    </cs:fontRef>
+    <cs:spPr>
+      <a:solidFill>
+        <a:schemeClr val="bg1"/>
+      </a:solidFill>
+      <a:ln w="9525" cap="flat" cmpd="sng" algn="ctr">
+        <a:solidFill>
+          <a:schemeClr val="tx1">
+            <a:lumMod val="15000"/>
+            <a:lumOff val="85000"/>
+          </a:schemeClr>
+        </a:solidFill>
+        <a:round/>
+      </a:ln>
+    </cs:spPr>
+    <cs:defRPr sz="1000" kern="1200"/>
+  </cs:chartArea>
+  <cs:dataLabel>
+    <cs:lnRef idx="0"/>
+    <cs:fillRef idx="0"/>
+    <cs:effectRef idx="0"/>
+    <cs:fontRef idx="minor">
+      <a:schemeClr val="tx1">
+        <a:lumMod val="75000"/>
+        <a:lumOff val="25000"/>
+      </a:schemeClr>
+    </cs:fontRef>
+    <cs:defRPr sz="900" kern="1200"/>
+  </cs:dataLabel>
+  <cs:dataLabelCallout>
+    <cs:lnRef idx="0"/>
+    <cs:fillRef idx="0"/>
+    <cs:effectRef idx="0"/>
+    <cs:fontRef idx="minor">
+      <a:schemeClr val="dk1">
+        <a:lumMod val="65000"/>
+        <a:lumOff val="35000"/>
+      </a:schemeClr>
+    </cs:fontRef>
+    <cs:spPr>
+      <a:solidFill>
+        <a:schemeClr val="lt1"/>
+      </a:solidFill>
+      <a:ln>
+        <a:solidFill>
+          <a:schemeClr val="dk1">
+            <a:lumMod val="25000"/>
+            <a:lumOff val="75000"/>
+          </a:schemeClr>
+        </a:solidFill>
+      </a:ln>
+    </cs:spPr>
+    <cs:defRPr sz="900" kern="1200"/>
+    <cs:bodyPr rot="0" spcFirstLastPara="1" vertOverflow="clip" horzOverflow="clip" vert="horz" wrap="square" lIns="36576" tIns="18288" rIns="36576" bIns="18288" anchor="ctr" anchorCtr="1">
+      <a:spAutoFit/>
+    </cs:bodyPr>
+  </cs:dataLabelCallout>
+  <cs:dataPoint>
+    <cs:lnRef idx="0"/>
+    <cs:fillRef idx="1">
+      <cs:styleClr val="auto"/>
+    </cs:fillRef>
+    <cs:effectRef idx="0"/>
+    <cs:fontRef idx="minor">
+      <a:schemeClr val="tx1"/>
+    </cs:fontRef>
+  </cs:dataPoint>
+  <cs:dataPoint3D>
+    <cs:lnRef idx="0"/>
+    <cs:fillRef idx="1">
+      <cs:styleClr val="auto"/>
+    </cs:fillRef>
+    <cs:effectRef idx="0"/>
+    <cs:fontRef idx="minor">
+      <a:schemeClr val="tx1"/>
+    </cs:fontRef>
+  </cs:dataPoint3D>
+  <cs:dataPointLine>
+    <cs:lnRef idx="0">
+      <cs:styleClr val="auto"/>
+    </cs:lnRef>
+    <cs:fillRef idx="1"/>
+    <cs:effectRef idx="0"/>
+    <cs:fontRef idx="minor">
+      <a:schemeClr val="tx1"/>
+    </cs:fontRef>
+    <cs:spPr>
+      <a:ln w="28575" cap="rnd">
+        <a:solidFill>
+          <a:schemeClr val="phClr"/>
+        </a:solidFill>
+        <a:round/>
+      </a:ln>
+    </cs:spPr>
+  </cs:dataPointLine>
+  <cs:dataPointMarker>
+    <cs:lnRef idx="0">
+      <cs:styleClr val="auto"/>
+    </cs:lnRef>
+    <cs:fillRef idx="1">
+      <cs:styleClr val="auto"/>
+    </cs:fillRef>
+    <cs:effectRef idx="0"/>
+    <cs:fontRef idx="minor">
+      <a:schemeClr val="tx1"/>
+    </cs:fontRef>
+    <cs:spPr>
+      <a:ln w="9525">
+        <a:solidFill>
+          <a:schemeClr val="phClr"/>
+        </a:solidFill>
+      </a:ln>
+    </cs:spPr>
+  </cs:dataPointMarker>
+  <cs:dataPointMarkerLayout symbol="circle" size="5"/>
+  <cs:dataPointWireframe>
+    <cs:lnRef idx="0">
+      <cs:styleClr val="auto"/>
+    </cs:lnRef>
+    <cs:fillRef idx="1"/>
+    <cs:effectRef idx="0"/>
+    <cs:fontRef idx="minor">
+      <a:schemeClr val="tx1"/>
+    </cs:fontRef>
+    <cs:spPr>
+      <a:ln w="9525" cap="rnd">
+        <a:solidFill>
+          <a:schemeClr val="phClr"/>
+        </a:solidFill>
+        <a:round/>
+      </a:ln>
+    </cs:spPr>
+  </cs:dataPointWireframe>
+  <cs:dataTable>
+    <cs:lnRef idx="0"/>
+    <cs:fillRef idx="0"/>
+    <cs:effectRef idx="0"/>
+    <cs:fontRef idx="minor">
+      <a:schemeClr val="tx1">
+        <a:lumMod val="65000"/>
+        <a:lumOff val="35000"/>
+      </a:schemeClr>
+    </cs:fontRef>
+    <cs:spPr>
+      <a:noFill/>
+      <a:ln w="9525" cap="flat" cmpd="sng" algn="ctr">
+        <a:solidFill>
+          <a:schemeClr val="tx1">
+            <a:lumMod val="15000"/>
+            <a:lumOff val="85000"/>
+          </a:schemeClr>
+        </a:solidFill>
+        <a:round/>
+      </a:ln>
+    </cs:spPr>
+    <cs:defRPr sz="900" kern="1200"/>
+  </cs:dataTable>
+  <cs:downBar>
+    <cs:lnRef idx="0"/>
+    <cs:fillRef idx="0"/>
+    <cs:effectRef idx="0"/>
+    <cs:fontRef idx="minor">
+      <a:schemeClr val="dk1"/>
+    </cs:fontRef>
+    <cs:spPr>
+      <a:solidFill>
+        <a:schemeClr val="dk1">
+          <a:lumMod val="65000"/>
+          <a:lumOff val="35000"/>
+        </a:schemeClr>
+      </a:solidFill>
+      <a:ln w="9525">
+        <a:solidFill>
+          <a:schemeClr val="tx1">
+            <a:lumMod val="65000"/>
+            <a:lumOff val="35000"/>
+          </a:schemeClr>
+        </a:solidFill>
+      </a:ln>
+    </cs:spPr>
+  </cs:downBar>
+  <cs:dropLine>
+    <cs:lnRef idx="0"/>
+    <cs:fillRef idx="0"/>
+    <cs:effectRef idx="0"/>
+    <cs:fontRef idx="minor">
+      <a:schemeClr val="tx1"/>
+    </cs:fontRef>
+    <cs:spPr>
+      <a:ln w="9525" cap="flat" cmpd="sng" algn="ctr">
+        <a:solidFill>
+          <a:schemeClr val="tx1">
+            <a:lumMod val="35000"/>
+            <a:lumOff val="65000"/>
+          </a:schemeClr>
+        </a:solidFill>
+        <a:round/>
+      </a:ln>
+    </cs:spPr>
+  </cs:dropLine>
+  <cs:errorBar>
+    <cs:lnRef idx="0"/>
+    <cs:fillRef idx="0"/>
+    <cs:effectRef idx="0"/>
+    <cs:fontRef idx="minor">
+      <a:schemeClr val="tx1"/>
+    </cs:fontRef>
+    <cs:spPr>
+      <a:ln w="9525" cap="flat" cmpd="sng" algn="ctr">
+        <a:solidFill>
+          <a:schemeClr val="tx1">
+            <a:lumMod val="65000"/>
+            <a:lumOff val="35000"/>
+          </a:schemeClr>
+        </a:solidFill>
+        <a:round/>
+      </a:ln>
+    </cs:spPr>
+  </cs:errorBar>
+  <cs:floor>
+    <cs:lnRef idx="0"/>
+    <cs:fillRef idx="0"/>
+    <cs:effectRef idx="0"/>
+    <cs:fontRef idx="minor">
+      <a:schemeClr val="tx1"/>
+    </cs:fontRef>
+    <cs:spPr>
+      <a:noFill/>
+      <a:ln>
+        <a:noFill/>
+      </a:ln>
+    </cs:spPr>
+  </cs:floor>
+  <cs:gridlineMajor>
+    <cs:lnRef idx="0"/>
+    <cs:fillRef idx="0"/>
+    <cs:effectRef idx="0"/>
+    <cs:fontRef idx="minor">
+      <a:schemeClr val="tx1"/>
+    </cs:fontRef>
+    <cs:spPr>
+      <a:ln w="9525" cap="flat" cmpd="sng" algn="ctr">
+        <a:solidFill>
+          <a:schemeClr val="tx1">
+            <a:lumMod val="15000"/>
+            <a:lumOff val="85000"/>
+          </a:schemeClr>
+        </a:solidFill>
+        <a:round/>
+      </a:ln>
+    </cs:spPr>
+  </cs:gridlineMajor>
+  <cs:gridlineMinor>
+    <cs:lnRef idx="0"/>
+    <cs:fillRef idx="0"/>
+    <cs:effectRef idx="0"/>
+    <cs:fontRef idx="minor">
+      <a:schemeClr val="tx1"/>
+    </cs:fontRef>
+    <cs:spPr>
+      <a:ln w="9525" cap="flat" cmpd="sng" algn="ctr">
+        <a:solidFill>
+          <a:schemeClr val="tx1">
+            <a:lumMod val="5000"/>
+            <a:lumOff val="95000"/>
+          </a:schemeClr>
+        </a:solidFill>
+        <a:round/>
+      </a:ln>
+    </cs:spPr>
+  </cs:gridlineMinor>
+  <cs:hiLoLine>
+    <cs:lnRef idx="0"/>
+    <cs:fillRef idx="0"/>
+    <cs:effectRef idx="0"/>
+    <cs:fontRef idx="minor">
+      <a:schemeClr val="tx1"/>
+    </cs:fontRef>
+    <cs:spPr>
+      <a:ln w="9525" cap="flat" cmpd="sng" algn="ctr">
+        <a:solidFill>
+          <a:schemeClr val="tx1">
+            <a:lumMod val="75000"/>
+            <a:lumOff val="25000"/>
+          </a:schemeClr>
+        </a:solidFill>
+        <a:round/>
+      </a:ln>
+    </cs:spPr>
+  </cs:hiLoLine>
+  <cs:leaderLine>
+    <cs:lnRef idx="0"/>
+    <cs:fillRef idx="0"/>
+    <cs:effectRef idx="0"/>
+    <cs:fontRef idx="minor">
+      <a:schemeClr val="tx1"/>
+    </cs:fontRef>
+    <cs:spPr>
+      <a:ln w="9525" cap="flat" cmpd="sng" algn="ctr">
+        <a:solidFill>
+          <a:schemeClr val="tx1">
+            <a:lumMod val="35000"/>
+            <a:lumOff val="65000"/>
+          </a:schemeClr>
+        </a:solidFill>
+        <a:round/>
+      </a:ln>
+    </cs:spPr>
+  </cs:leaderLine>
+  <cs:legend>
+    <cs:lnRef idx="0"/>
+    <cs:fillRef idx="0"/>
+    <cs:effectRef idx="0"/>
+    <cs:fontRef idx="minor">
+      <a:schemeClr val="tx1">
+        <a:lumMod val="65000"/>
+        <a:lumOff val="35000"/>
+      </a:schemeClr>
+    </cs:fontRef>
+    <cs:defRPr sz="900" kern="1200"/>
+  </cs:legend>
+  <cs:plotArea mods="allowNoFillOverride allowNoLineOverride">
+    <cs:lnRef idx="0"/>
+    <cs:fillRef idx="0"/>
+    <cs:effectRef idx="0"/>
+    <cs:fontRef idx="minor">
+      <a:schemeClr val="tx1"/>
+    </cs:fontRef>
+  </cs:plotArea>
+  <cs:plotArea3D mods="allowNoFillOverride allowNoLineOverride">
+    <cs:lnRef idx="0"/>
+    <cs:fillRef idx="0"/>
+    <cs:effectRef idx="0"/>
+    <cs:fontRef idx="minor">
+      <a:schemeClr val="tx1"/>
+    </cs:fontRef>
+  </cs:plotArea3D>
+  <cs:seriesAxis>
+    <cs:lnRef idx="0"/>
+    <cs:fillRef idx="0"/>
+    <cs:effectRef idx="0"/>
+    <cs:fontRef idx="minor">
+      <a:schemeClr val="tx1">
+        <a:lumMod val="65000"/>
+        <a:lumOff val="35000"/>
+      </a:schemeClr>
+    </cs:fontRef>
+    <cs:defRPr sz="900" kern="1200"/>
+  </cs:seriesAxis>
+  <cs:seriesLine>
+    <cs:lnRef idx="0"/>
+    <cs:fillRef idx="0"/>
+    <cs:effectRef idx="0"/>
+    <cs:fontRef idx="minor">
+      <a:schemeClr val="tx1"/>
+    </cs:fontRef>
+    <cs:spPr>
+      <a:ln w="9525" cap="flat" cmpd="sng" algn="ctr">
+        <a:solidFill>
+          <a:schemeClr val="tx1">
+            <a:lumMod val="35000"/>
+            <a:lumOff val="65000"/>
+          </a:schemeClr>
+        </a:solidFill>
+        <a:round/>
+      </a:ln>
+    </cs:spPr>
+  </cs:seriesLine>
+  <cs:title>
+    <cs:lnRef idx="0"/>
+    <cs:fillRef idx="0"/>
+    <cs:effectRef idx="0"/>
+    <cs:fontRef idx="minor">
+      <a:schemeClr val="tx1">
+        <a:lumMod val="65000"/>
+        <a:lumOff val="35000"/>
+      </a:schemeClr>
+    </cs:fontRef>
+    <cs:defRPr sz="1400" b="0" kern="1200" spc="0" baseline="0"/>
+  </cs:title>
+  <cs:trendline>
+    <cs:lnRef idx="0">
+      <cs:styleClr val="auto"/>
+    </cs:lnRef>
+    <cs:fillRef idx="0"/>
+    <cs:effectRef idx="0"/>
+    <cs:fontRef idx="minor">
+      <a:schemeClr val="tx1"/>
+    </cs:fontRef>
+    <cs:spPr>
+      <a:ln w="19050" cap="rnd">
+        <a:solidFill>
+          <a:schemeClr val="phClr"/>
+        </a:solidFill>
+        <a:prstDash val="sysDot"/>
+      </a:ln>
+    </cs:spPr>
+  </cs:trendline>
+  <cs:trendlineLabel>
+    <cs:lnRef idx="0"/>
+    <cs:fillRef idx="0"/>
+    <cs:effectRef idx="0"/>
+    <cs:fontRef idx="minor">
+      <a:schemeClr val="tx1">
+        <a:lumMod val="65000"/>
+        <a:lumOff val="35000"/>
+      </a:schemeClr>
+    </cs:fontRef>
+    <cs:defRPr sz="900" kern="1200"/>
+  </cs:trendlineLabel>
+  <cs:upBar>
+    <cs:lnRef idx="0"/>
+    <cs:fillRef idx="0"/>
+    <cs:effectRef idx="0"/>
+    <cs:fontRef idx="minor">
+      <a:schemeClr val="dk1"/>
+    </cs:fontRef>
+    <cs:spPr>
+      <a:solidFill>
+        <a:schemeClr val="lt1"/>
+      </a:solidFill>
+      <a:ln w="9525">
+        <a:solidFill>
+          <a:schemeClr val="tx1">
+            <a:lumMod val="15000"/>
+            <a:lumOff val="85000"/>
+          </a:schemeClr>
+        </a:solidFill>
+      </a:ln>
+    </cs:spPr>
+  </cs:upBar>
+  <cs:valueAxis>
+    <cs:lnRef idx="0"/>
+    <cs:fillRef idx="0"/>
+    <cs:effectRef idx="0"/>
+    <cs:fontRef idx="minor">
+      <a:schemeClr val="tx1">
+        <a:lumMod val="65000"/>
+        <a:lumOff val="35000"/>
+      </a:schemeClr>
+    </cs:fontRef>
+    <cs:defRPr sz="900" kern="1200"/>
+  </cs:valueAxis>
+  <cs:wall>
+    <cs:lnRef idx="0"/>
+    <cs:fillRef idx="0"/>
+    <cs:effectRef idx="0"/>
+    <cs:fontRef idx="minor">
+      <a:schemeClr val="tx1"/>
+    </cs:fontRef>
+    <cs:spPr>
+      <a:noFill/>
+      <a:ln>
+        <a:noFill/>
+      </a:ln>
+    </cs:spPr>
+  </cs:wall>
+</cs:chartStyle>
+</file>
+
 <file path=ppt/notesMasters/notesMaster1.xml><?xml version="1.0" encoding="utf-8"?>
 <p:notesMaster xmlns:a="http://schemas.openxmlformats.org/drawingml/2006/main" xmlns:r="http://schemas.openxmlformats.org/officeDocument/2006/relationships" xmlns:p="http://schemas.openxmlformats.org/presentationml/2006/main">
   <p:cSld>
@@ -214,7 +4301,7 @@
           <a:p>
             <a:fld id="{5BEAC4C3-7F01-4D2F-B765-F2404496EEE9}" type="datetimeFigureOut">
               <a:rPr lang="en-GB" smtClean="0"/>
-              <a:t>21/03/2026</a:t>
+              <a:t>27/03/2026</a:t>
             </a:fld>
             <a:endParaRPr lang="en-GB"/>
           </a:p>
@@ -718,7 +4805,7 @@
           <a:p>
             <a:fld id="{1D725620-1185-4627-BCBE-4E695665A1FA}" type="datetimeFigureOut">
               <a:rPr lang="en-GB" smtClean="0"/>
-              <a:t>21/03/2026</a:t>
+              <a:t>27/03/2026</a:t>
             </a:fld>
             <a:endParaRPr lang="en-GB"/>
           </a:p>
@@ -918,7 +5005,7 @@
           <a:p>
             <a:fld id="{1D725620-1185-4627-BCBE-4E695665A1FA}" type="datetimeFigureOut">
               <a:rPr lang="en-GB" smtClean="0"/>
-              <a:t>21/03/2026</a:t>
+              <a:t>27/03/2026</a:t>
             </a:fld>
             <a:endParaRPr lang="en-GB"/>
           </a:p>
@@ -1128,7 +5215,7 @@
           <a:p>
             <a:fld id="{1D725620-1185-4627-BCBE-4E695665A1FA}" type="datetimeFigureOut">
               <a:rPr lang="en-GB" smtClean="0"/>
-              <a:t>21/03/2026</a:t>
+              <a:t>27/03/2026</a:t>
             </a:fld>
             <a:endParaRPr lang="en-GB"/>
           </a:p>
@@ -1328,7 +5415,7 @@
           <a:p>
             <a:fld id="{1D725620-1185-4627-BCBE-4E695665A1FA}" type="datetimeFigureOut">
               <a:rPr lang="en-GB" smtClean="0"/>
-              <a:t>21/03/2026</a:t>
+              <a:t>27/03/2026</a:t>
             </a:fld>
             <a:endParaRPr lang="en-GB"/>
           </a:p>
@@ -1604,7 +5691,7 @@
           <a:p>
             <a:fld id="{1D725620-1185-4627-BCBE-4E695665A1FA}" type="datetimeFigureOut">
               <a:rPr lang="en-GB" smtClean="0"/>
-              <a:t>21/03/2026</a:t>
+              <a:t>27/03/2026</a:t>
             </a:fld>
             <a:endParaRPr lang="en-GB"/>
           </a:p>
@@ -1872,7 +5959,7 @@
           <a:p>
             <a:fld id="{1D725620-1185-4627-BCBE-4E695665A1FA}" type="datetimeFigureOut">
               <a:rPr lang="en-GB" smtClean="0"/>
-              <a:t>21/03/2026</a:t>
+              <a:t>27/03/2026</a:t>
             </a:fld>
             <a:endParaRPr lang="en-GB"/>
           </a:p>
@@ -2287,7 +6374,7 @@
           <a:p>
             <a:fld id="{1D725620-1185-4627-BCBE-4E695665A1FA}" type="datetimeFigureOut">
               <a:rPr lang="en-GB" smtClean="0"/>
-              <a:t>21/03/2026</a:t>
+              <a:t>27/03/2026</a:t>
             </a:fld>
             <a:endParaRPr lang="en-GB"/>
           </a:p>
@@ -2429,7 +6516,7 @@
           <a:p>
             <a:fld id="{1D725620-1185-4627-BCBE-4E695665A1FA}" type="datetimeFigureOut">
               <a:rPr lang="en-GB" smtClean="0"/>
-              <a:t>21/03/2026</a:t>
+              <a:t>27/03/2026</a:t>
             </a:fld>
             <a:endParaRPr lang="en-GB"/>
           </a:p>
@@ -2542,7 +6629,7 @@
           <a:p>
             <a:fld id="{1D725620-1185-4627-BCBE-4E695665A1FA}" type="datetimeFigureOut">
               <a:rPr lang="en-GB" smtClean="0"/>
-              <a:t>21/03/2026</a:t>
+              <a:t>27/03/2026</a:t>
             </a:fld>
             <a:endParaRPr lang="en-GB"/>
           </a:p>
@@ -2855,7 +6942,7 @@
           <a:p>
             <a:fld id="{1D725620-1185-4627-BCBE-4E695665A1FA}" type="datetimeFigureOut">
               <a:rPr lang="en-GB" smtClean="0"/>
-              <a:t>21/03/2026</a:t>
+              <a:t>27/03/2026</a:t>
             </a:fld>
             <a:endParaRPr lang="en-GB"/>
           </a:p>
@@ -3144,7 +7231,7 @@
           <a:p>
             <a:fld id="{1D725620-1185-4627-BCBE-4E695665A1FA}" type="datetimeFigureOut">
               <a:rPr lang="en-GB" smtClean="0"/>
-              <a:t>21/03/2026</a:t>
+              <a:t>27/03/2026</a:t>
             </a:fld>
             <a:endParaRPr lang="en-GB"/>
           </a:p>
@@ -3387,7 +7474,7 @@
           <a:p>
             <a:fld id="{1D725620-1185-4627-BCBE-4E695665A1FA}" type="datetimeFigureOut">
               <a:rPr lang="en-GB" smtClean="0"/>
-              <a:t>21/03/2026</a:t>
+              <a:t>27/03/2026</a:t>
             </a:fld>
             <a:endParaRPr lang="en-GB"/>
           </a:p>
@@ -5283,45 +9370,126 @@
           </a:p>
         </p:txBody>
       </p:sp>
-      <p:sp>
-        <p:nvSpPr>
-          <p:cNvPr id="2" name="TextBox 1">
+      <p:graphicFrame>
+        <p:nvGraphicFramePr>
+          <p:cNvPr id="3" name="Chart 2">
             <a:extLst>
               <a:ext uri="{FF2B5EF4-FFF2-40B4-BE49-F238E27FC236}">
-                <a16:creationId xmlns:a16="http://schemas.microsoft.com/office/drawing/2014/main" id="{0CED31DA-9AE5-1B55-DA8F-7C85080ABB73}"/>
+                <a16:creationId xmlns:a16="http://schemas.microsoft.com/office/drawing/2014/main" id="{0C048307-D502-434B-BC73-8FBB337C60C9}"/>
               </a:ext>
             </a:extLst>
           </p:cNvPr>
-          <p:cNvSpPr txBox="1"/>
-          <p:nvPr/>
-        </p:nvSpPr>
-        <p:spPr>
-          <a:xfrm>
-            <a:off x="4294513" y="3176833"/>
-            <a:ext cx="3602974" cy="369332"/>
-          </a:xfrm>
-          <a:prstGeom prst="rect">
-            <a:avLst/>
-          </a:prstGeom>
-          <a:noFill/>
-        </p:spPr>
-        <p:txBody>
-          <a:bodyPr wrap="none" rtlCol="0">
-            <a:spAutoFit/>
-          </a:bodyPr>
-          <a:lstStyle/>
-          <a:p>
-            <a:r>
-              <a:rPr lang="en-GB" i="1" dirty="0">
-                <a:solidFill>
-                  <a:srgbClr val="FF0000"/>
-                </a:solidFill>
-              </a:rPr>
-              <a:t>INSERT EXCEL BAR CHARTS HERE </a:t>
-            </a:r>
-          </a:p>
-        </p:txBody>
-      </p:sp>
+          <p:cNvGraphicFramePr>
+            <a:graphicFrameLocks/>
+          </p:cNvGraphicFramePr>
+          <p:nvPr>
+            <p:extLst>
+              <p:ext uri="{D42A27DB-BD31-4B8C-83A1-F6EECF244321}">
+                <p14:modId xmlns:p14="http://schemas.microsoft.com/office/powerpoint/2010/main" val="909230510"/>
+              </p:ext>
+            </p:extLst>
+          </p:nvPr>
+        </p:nvGraphicFramePr>
+        <p:xfrm>
+          <a:off x="6335486" y="3665101"/>
+          <a:ext cx="5464166" cy="2703095"/>
+        </p:xfrm>
+        <a:graphic>
+          <a:graphicData uri="http://schemas.openxmlformats.org/drawingml/2006/chart">
+            <c:chart xmlns:c="http://schemas.openxmlformats.org/drawingml/2006/chart" xmlns:r="http://schemas.openxmlformats.org/officeDocument/2006/relationships" r:id="rId2"/>
+          </a:graphicData>
+        </a:graphic>
+      </p:graphicFrame>
+      <p:graphicFrame>
+        <p:nvGraphicFramePr>
+          <p:cNvPr id="5" name="Chart 4">
+            <a:extLst>
+              <a:ext uri="{FF2B5EF4-FFF2-40B4-BE49-F238E27FC236}">
+                <a16:creationId xmlns:a16="http://schemas.microsoft.com/office/drawing/2014/main" id="{F25C4407-8EC6-0D25-CD16-FC8DB2E0D170}"/>
+              </a:ext>
+            </a:extLst>
+          </p:cNvPr>
+          <p:cNvGraphicFramePr>
+            <a:graphicFrameLocks/>
+          </p:cNvGraphicFramePr>
+          <p:nvPr>
+            <p:extLst>
+              <p:ext uri="{D42A27DB-BD31-4B8C-83A1-F6EECF244321}">
+                <p14:modId xmlns:p14="http://schemas.microsoft.com/office/powerpoint/2010/main" val="1974667873"/>
+              </p:ext>
+            </p:extLst>
+          </p:nvPr>
+        </p:nvGraphicFramePr>
+        <p:xfrm>
+          <a:off x="392348" y="690720"/>
+          <a:ext cx="5464166" cy="2699657"/>
+        </p:xfrm>
+        <a:graphic>
+          <a:graphicData uri="http://schemas.openxmlformats.org/drawingml/2006/chart">
+            <c:chart xmlns:c="http://schemas.openxmlformats.org/drawingml/2006/chart" xmlns:r="http://schemas.openxmlformats.org/officeDocument/2006/relationships" r:id="rId3"/>
+          </a:graphicData>
+        </a:graphic>
+      </p:graphicFrame>
+      <p:graphicFrame>
+        <p:nvGraphicFramePr>
+          <p:cNvPr id="6" name="Chart 5">
+            <a:extLst>
+              <a:ext uri="{FF2B5EF4-FFF2-40B4-BE49-F238E27FC236}">
+                <a16:creationId xmlns:a16="http://schemas.microsoft.com/office/drawing/2014/main" id="{0D5299CD-C3C9-FD02-03C2-0714783187EB}"/>
+              </a:ext>
+            </a:extLst>
+          </p:cNvPr>
+          <p:cNvGraphicFramePr>
+            <a:graphicFrameLocks/>
+          </p:cNvGraphicFramePr>
+          <p:nvPr>
+            <p:extLst>
+              <p:ext uri="{D42A27DB-BD31-4B8C-83A1-F6EECF244321}">
+                <p14:modId xmlns:p14="http://schemas.microsoft.com/office/powerpoint/2010/main" val="3487439672"/>
+              </p:ext>
+            </p:extLst>
+          </p:nvPr>
+        </p:nvGraphicFramePr>
+        <p:xfrm>
+          <a:off x="6096000" y="690719"/>
+          <a:ext cx="5464166" cy="2699657"/>
+        </p:xfrm>
+        <a:graphic>
+          <a:graphicData uri="http://schemas.openxmlformats.org/drawingml/2006/chart">
+            <c:chart xmlns:c="http://schemas.openxmlformats.org/drawingml/2006/chart" xmlns:r="http://schemas.openxmlformats.org/officeDocument/2006/relationships" r:id="rId4"/>
+          </a:graphicData>
+        </a:graphic>
+      </p:graphicFrame>
+      <p:graphicFrame>
+        <p:nvGraphicFramePr>
+          <p:cNvPr id="7" name="Chart 6">
+            <a:extLst>
+              <a:ext uri="{FF2B5EF4-FFF2-40B4-BE49-F238E27FC236}">
+                <a16:creationId xmlns:a16="http://schemas.microsoft.com/office/drawing/2014/main" id="{1B5E2216-1B89-8797-CF0A-A716D89E376E}"/>
+              </a:ext>
+            </a:extLst>
+          </p:cNvPr>
+          <p:cNvGraphicFramePr>
+            <a:graphicFrameLocks/>
+          </p:cNvGraphicFramePr>
+          <p:nvPr>
+            <p:extLst>
+              <p:ext uri="{D42A27DB-BD31-4B8C-83A1-F6EECF244321}">
+                <p14:modId xmlns:p14="http://schemas.microsoft.com/office/powerpoint/2010/main" val="444046621"/>
+              </p:ext>
+            </p:extLst>
+          </p:nvPr>
+        </p:nvGraphicFramePr>
+        <p:xfrm>
+          <a:off x="392348" y="3587854"/>
+          <a:ext cx="5464166" cy="2699657"/>
+        </p:xfrm>
+        <a:graphic>
+          <a:graphicData uri="http://schemas.openxmlformats.org/drawingml/2006/chart">
+            <c:chart xmlns:c="http://schemas.openxmlformats.org/drawingml/2006/chart" xmlns:r="http://schemas.openxmlformats.org/officeDocument/2006/relationships" r:id="rId5"/>
+          </a:graphicData>
+        </a:graphic>
+      </p:graphicFrame>
     </p:spTree>
     <p:extLst>
       <p:ext uri="{BB962C8B-B14F-4D97-AF65-F5344CB8AC3E}">

</xml_diff>